<commit_message>
Pitch slide 3: once-a-day framing and meal-prep/fruit alternatives in migraine row
Co-Authored-By: Claude Opus 5.5 <noreply@anthropic.com>
Claude-Session: https://claude.ai/code/session_01GJGkDeLHjnkx4ZbaPKgLVt
</commit_message>
<xml_diff>
--- a/09-pitch/pitch-deck.pptx
+++ b/09-pitch/pitch-deck.pptx
@@ -111,27 +111,27 @@
   <p:extLst>
     <p:ext uri="{521415D9-36F7-43E2-AB2F-B90AF26B5E84}">
       <p14:sectionLst xmlns:p14="http://schemas.microsoft.com/office/powerpoint/2010/main">
-        <p14:section name="Concept" id="{082cdbf3-dbed-b912-a26e-7f3cbd847a94}">
+        <p14:section name="Concept" id="{3ce6df5c-d06d-1736-5343-fb031b84786e}">
           <p14:sldIdLst>
             <p14:sldId id="256"/>
           </p14:sldIdLst>
         </p14:section>
-        <p14:section name="Problem" id="{f50c43b8-c3a6-aa18-61f1-16f9dbf515ad}">
+        <p14:section name="Problem" id="{efbce990-cb08-4c10-3b26-6323bdc79524}">
           <p14:sldIdLst>
             <p14:sldId id="257"/>
           </p14:sldIdLst>
         </p14:section>
-        <p14:section name="Customers" id="{980b53bf-9a46-3fe1-8fdf-7528bfa3b80d}">
+        <p14:section name="Customers" id="{41156d10-e9cc-3909-9553-e02c54d29fba}">
           <p14:sldIdLst>
             <p14:sldId id="258"/>
           </p14:sldIdLst>
         </p14:section>
-        <p14:section name="Market" id="{753e3af7-1520-8d6a-224e-646ddb001836}">
+        <p14:section name="Market" id="{7ce7b69d-7d98-d501-225e-d636865d60c7}">
           <p14:sldIdLst>
             <p14:sldId id="259"/>
           </p14:sldIdLst>
         </p14:section>
-        <p14:section name="Model" id="{2a167b6d-f5f2-4b0c-1ba9-82e7decde631}">
+        <p14:section name="Model" id="{4033c89c-3ce5-a665-71ec-df2c1deb453f}">
           <p14:sldIdLst>
             <p14:sldId id="260"/>
           </p14:sldIdLst>
@@ -716,7 +716,7 @@
           <a:p>
             <a:r>
               <a:rPr lang="en-US" dirty="0"/>
-              <a:t>~70s. I've spoken to 10 athletes and gym-goers, including a pro footballer, a rugby player and an aspiring bodybuilder, plus the Team Durham S&amp;C coach and a nutrition professor. I've got more interviews lined up [say who]. 7 of 10 liked the idea. They want high protein and real food. The problems with what's out there: price, taste, and ingredients they don't trust. The S&amp;C coach watched students fail to finish boxes of Grenade bars. Why it's a migraine: it hits after every session, twice a day for some, and on the road, at work or on weigh-in day there's no time to cook. Early persona: Jack trains most days, is trying to eat well and trusts his coach. Honestly: nobody has committed yet, and some gym-goers just wait for a meal, so I'm focusing on athletes who train hard. Interview notes are paraphrased, not quotes.</a:t>
+              <a:t>~70s. I've spoken to 10 athletes and gym-goers, including a pro footballer, a rugby player and an aspiring bodybuilder, plus the Team Durham S&amp;C coach and a nutrition professor. I've got more interviews lined up [say who]. 7 of 10 liked the idea. They want high protein and real food. The problems with what's out there: price, taste, and ingredients they don't trust. The S&amp;C coach watched students fail to finish boxes of Grenade bars. Why it's a migraine: after training they need protein and carbs. Chicken-and-rice meal prep works when they manage it, but it means cooking ahead and carrying a tub. The quick options fall short: fruit has no protein, lab bars are full of powders and sweeteners, 'natural' bars are mostly sugar. So they compromise or go without, after almost every session, which for someone training 5-6 days a week is 5-6 times a week. Early persona: Jack trains most days, is trying to eat well and trusts his coach. Honestly: nobody has committed yet, and some gym-goers just wait for a meal, so I'm focusing on athletes who train hard. Interview notes are paraphrased, not quotes.</a:t>
             </a:r>
             <a:endParaRPr lang="en-US" dirty="0"/>
           </a:p>
@@ -3866,7 +3866,7 @@
                   <a:schemeClr val="tx1"/>
                 </a:solidFill>
               </a:rPr>
-              <a:t>It hits after every session, twice a day for some. On the road, at work or on weigh-in day there's no time to cook, and nothing convenient fits.</a:t>
+              <a:t>After training they need protein and carbs. Meal prep isn't always possible, and quick options fall short: fruit lacks protein, lab bars are artificial, "natural" bars are sugary. It happens after almost every session.</a:t>
             </a:r>
             <a:endParaRPr lang="en-US" sz="1400" dirty="0"/>
           </a:p>
@@ -3880,8 +3880,8 @@
         </p:nvSpPr>
         <p:spPr>
           <a:xfrm>
-            <a:off x="4846320" y="5669280"/>
-            <a:ext cx="6766560" cy="548640"/>
+            <a:off x="4846320" y="5806440"/>
+            <a:ext cx="6766560" cy="502920"/>
           </a:xfrm>
           <a:prstGeom prst="rect">
             <a:avLst/>

</xml_diff>

<commit_message>
Lower sugar to ~5.5 g per bar (half honey, less banana); update recipes, packs, landing page and deck
Co-Authored-By: Claude Opus 5.5 <noreply@anthropic.com>
Claude-Session: https://claude.ai/code/session_01GJGkDeLHjnkx4ZbaPKgLVt
</commit_message>
<xml_diff>
--- a/09-pitch/pitch-deck.pptx
+++ b/09-pitch/pitch-deck.pptx
@@ -111,27 +111,27 @@
   <p:extLst>
     <p:ext uri="{521415D9-36F7-43E2-AB2F-B90AF26B5E84}">
       <p14:sectionLst xmlns:p14="http://schemas.microsoft.com/office/powerpoint/2010/main">
-        <p14:section name="Concept" id="{3ce6df5c-d06d-1736-5343-fb031b84786e}">
+        <p14:section name="Concept" id="{87c0af7f-8215-c983-3f9f-5f774ebb0ab9}">
           <p14:sldIdLst>
             <p14:sldId id="256"/>
           </p14:sldIdLst>
         </p14:section>
-        <p14:section name="Problem" id="{efbce990-cb08-4c10-3b26-6323bdc79524}">
+        <p14:section name="Problem" id="{26def38e-6c36-5200-4e0e-c11bb04a8992}">
           <p14:sldIdLst>
             <p14:sldId id="257"/>
           </p14:sldIdLst>
         </p14:section>
-        <p14:section name="Customers" id="{41156d10-e9cc-3909-9553-e02c54d29fba}">
+        <p14:section name="Customers" id="{d3c557a0-6e9b-19c2-7f00-65e4a979a53c}">
           <p14:sldIdLst>
             <p14:sldId id="258"/>
           </p14:sldIdLst>
         </p14:section>
-        <p14:section name="Market" id="{7ce7b69d-7d98-d501-225e-d636865d60c7}">
+        <p14:section name="Market" id="{db73940f-046a-bb75-b7d8-be1f57302cb9}">
           <p14:sldIdLst>
             <p14:sldId id="259"/>
           </p14:sldIdLst>
         </p14:section>
-        <p14:section name="Model" id="{4033c89c-3ce5-a665-71ec-df2c1deb453f}">
+        <p14:section name="Model" id="{cf0b707a-a3b8-2b2c-2b01-3382143c1d6e}">
           <p14:sldIdLst>
             <p14:sldId id="260"/>
           </p14:sldIdLst>
@@ -6270,7 +6270,7 @@
                             <a:schemeClr val="bg1"/>
                           </a:solidFill>
                         </a:rPr>
-                        <a:t>~20–21 g</a:t>
+                        <a:t>~21 g</a:t>
                       </a:r>
                       <a:endParaRPr lang="en-US" sz="1200" dirty="0"/>
                     </a:p>
@@ -6331,7 +6331,7 @@
                             <a:schemeClr val="bg1"/>
                           </a:solidFill>
                         </a:rPr>
-                        <a:t>~28–31 g</a:t>
+                        <a:t>~27–30 g</a:t>
                       </a:r>
                       <a:endParaRPr lang="en-US" sz="1200" dirty="0"/>
                     </a:p>
@@ -6392,7 +6392,7 @@
                             <a:schemeClr val="bg1"/>
                           </a:solidFill>
                         </a:rPr>
-                        <a:t>~7–8 g</a:t>
+                        <a:t>~5.5 g</a:t>
                       </a:r>
                       <a:endParaRPr lang="en-US" sz="1200" dirty="0"/>
                     </a:p>
@@ -7121,7 +7121,7 @@
                   <a:schemeClr val="accent3"/>
                 </a:solidFill>
               </a:rPr>
-              <a:t>Each ~20 g protein · ~30 g carbs · ≤8 g sugar · ~260–280 kcal (calculated)</a:t>
+              <a:t>Each ~21 g protein · ~27–30 g carbs · ~5.5 g sugar · ~260–280 kcal (calculated)</a:t>
             </a:r>
             <a:endParaRPr lang="en-US" sz="1400" dirty="0"/>
           </a:p>

</xml_diff>

<commit_message>
Friday pitch brief and deck update: Graft name, v6 numbers, early adopters and persona
Co-Authored-By: Claude Opus 5.5 <noreply@anthropic.com>
Claude-Session: https://claude.ai/code/session_01GJGkDeLHjnkx4ZbaPKgLVt
</commit_message>
<xml_diff>
--- a/09-pitch/pitch-deck.pptx
+++ b/09-pitch/pitch-deck.pptx
@@ -111,27 +111,27 @@
   <p:extLst>
     <p:ext uri="{521415D9-36F7-43E2-AB2F-B90AF26B5E84}">
       <p14:sectionLst xmlns:p14="http://schemas.microsoft.com/office/powerpoint/2010/main">
-        <p14:section name="Concept" id="{87c0af7f-8215-c983-3f9f-5f774ebb0ab9}">
+        <p14:section name="Concept" id="{5dff365d-d688-1e19-fa1e-661c40c9e0b0}">
           <p14:sldIdLst>
             <p14:sldId id="256"/>
           </p14:sldIdLst>
         </p14:section>
-        <p14:section name="Problem" id="{26def38e-6c36-5200-4e0e-c11bb04a8992}">
+        <p14:section name="Problem" id="{702d312a-6856-819a-7bbd-f85d8a259081}">
           <p14:sldIdLst>
             <p14:sldId id="257"/>
           </p14:sldIdLst>
         </p14:section>
-        <p14:section name="Customers" id="{d3c557a0-6e9b-19c2-7f00-65e4a979a53c}">
+        <p14:section name="Customers" id="{e5e2233b-6f16-6a45-86a6-ffeab6398033}">
           <p14:sldIdLst>
             <p14:sldId id="258"/>
           </p14:sldIdLst>
         </p14:section>
-        <p14:section name="Market" id="{db73940f-046a-bb75-b7d8-be1f57302cb9}">
+        <p14:section name="Market" id="{03750e0b-d081-f3ce-4560-115e7b42d6d7}">
           <p14:sldIdLst>
             <p14:sldId id="259"/>
           </p14:sldIdLst>
         </p14:section>
-        <p14:section name="Model" id="{cf0b707a-a3b8-2b2c-2b01-3382143c1d6e}">
+        <p14:section name="Model" id="{97b54a27-c0df-c894-49f3-f101e8fb736d}">
           <p14:sldIdLst>
             <p14:sldId id="260"/>
           </p14:sldIdLst>
@@ -540,7 +540,7 @@
           <a:p>
             <a:r>
               <a:rPr lang="en-US" dirty="0"/>
-              <a:t>~60s. I've pivoted. The idea is now a recovery bar made from real food, for athletes who train hard. It came from my own training. After two MMA classes back to back I'd eat a full meal and still be after more. Going from MMA straight to football, I'm in a rush and need something quick but proper. On a same-day weigh-in I'm depleted after making weight and have a short window to refuel before I compete. Every time, the choice is a lab-made protein bar full of powders and sweeteners, or nothing. So the bar is ~20 g protein and ~30 g carbs from eggs, quark and oats. Branding's in progress: working name only, nothing's set. (Note for weigh-in days: fibre before competing can upset the gut, so a lower-fibre version may suit that use. Worth testing.)</a:t>
+              <a:t>~60s. I've pivoted. The idea is now a recovery bar made from real food, for athletes who train hard. It came from my own training. After two MMA classes back to back I'd eat a full meal and still be after more. Going from MMA straight to football, I'm in a rush and need something quick but proper. On a same-day weigh-in I'm depleted after making weight and have a short window to refuel before I compete. Every time, the choice is a lab-made protein bar full of powders and sweeteners, or nothing. So I made Graft: a 50 g bar with ~15 g protein from egg, quark and oats, and athletes eat two after training, about 29 g protein and 28 g carbs. Graft is Northern for hard work: it's for people who put the work in. Earned, not engineered. (Note for weigh-in days: fibre before competing can upset the gut, so a lower-fibre version may suit that use. Worth testing.)</a:t>
             </a:r>
             <a:endParaRPr lang="en-US" dirty="0"/>
           </a:p>
@@ -716,7 +716,7 @@
           <a:p>
             <a:r>
               <a:rPr lang="en-US" dirty="0"/>
-              <a:t>~70s. I've spoken to 10 athletes and gym-goers, including a pro footballer, a rugby player and an aspiring bodybuilder, plus the Team Durham S&amp;C coach and a nutrition professor. I've got more interviews lined up [say who]. 7 of 10 liked the idea. They want high protein and real food. The problems with what's out there: price, taste, and ingredients they don't trust. The S&amp;C coach watched students fail to finish boxes of Grenade bars. Why it's a migraine: after training they need protein and carbs. Chicken-and-rice meal prep works when they manage it, but it means cooking ahead and carrying a tub. The quick options fall short: fruit has no protein, lab bars are full of powders and sweeteners, 'natural' bars are mostly sugar. So they compromise or go without, after almost every session, which for someone training 5-6 days a week is 5-6 times a week. Early persona: Jack trains most days, is trying to eat well and trusts his coach. Honestly: nobody has committed yet, and some gym-goers just wait for a meal, so I'm focusing on athletes who train hard. Interview notes are paraphrased, not quotes.</a:t>
+              <a:t>~70s. I've spoken to 10 athletes and gym-goers, including a pro footballer, a rugby player and an aspiring bodybuilder, plus the Team Durham S&amp;C coach and a nutrition professor. I've got more interviews lined up [say who]. 7 of 10 liked the idea. They want high protein and real food. The problems with what's out there: price, taste, and ingredients they don't trust. The S&amp;C coach watched students fail to finish boxes of Grenade bars. Why it's a migraine: after training they need protein and carbs. Chicken-and-rice meal prep works when they manage it, but it means cooking ahead and carrying a tub. The quick options fall short: fruit has no protein, lab bars are full of powders and sweeteners, 'natural' bars are mostly sugar. So they compromise or go without, after almost every session, which for someone training 5-6 days a week is 5-6 times a week. My persona is Jack: trains once a day, plays a sport, is trying to eat well and trusts his coach. My early adopters are the sharpest slice of Jack: coached athletes, starting with Team Durham squads and my MMA club. Why them: they train hardest, their coach tells them to eat whole food, and one coach means about 25 athletes and one delivery, which suits a fresh bar. Honestly: nobody has committed yet; that's what the squad trial is for. Interview notes are paraphrased, not quotes.</a:t>
             </a:r>
             <a:endParaRPr lang="en-US" dirty="0"/>
           </a:p>
@@ -804,7 +804,7 @@
           <a:p>
             <a:r>
               <a:rPr lang="en-US" dirty="0"/>
-              <a:t>~60s. These are the recovery bars athletes see: Myprotein's Re-Fuel, Amacx, HIGH5, Styrkr, Huel. The ones with 20 g protein get it from protein powder, and most rely on syrups or sugar alcohols. Re-Fuel's first ingredient is maltitol. The 'real food' bars like Veloforte have lots of sugar and only 12 g protein. Across 32+ UK bars I checked, none gets around 20 g protein from real food alone. Ours does: ~20 g protein and ~30 g carbs from eggs, quark and oats, with a little honey or banana. Our numbers are calculated from the ingredients and will be lab-checked.</a:t>
+              <a:t>~60s. These are the recovery bars athletes see: Myprotein's Re-Fuel, Amacx, HIGH5, Styrkr, Huel. The ones with 20 g protein get it from protein powder, and most rely on syrups or sugar alcohols. Re-Fuel's first ingredient is maltitol. The 'real food' bars like Veloforte have lots of sugar and only 12 g protein. Across 32+ UK bars I checked, none gets its protein from real food with low sugar. Graft does: two 50 g bars give about 29 g protein and 28 g carbs from egg, quark and oats, with a little honey or banana and no sweeteners. Our numbers are calculated from the ingredients and will be lab-checked.</a:t>
             </a:r>
             <a:endParaRPr lang="en-US" dirty="0"/>
           </a:p>
@@ -892,7 +892,7 @@
           <a:p>
             <a:r>
               <a:rPr lang="en-US" dirty="0"/>
-              <a:t>~60s. Three flavours in testing: Chocolate Peanut Butter, Vanilla and Banana Bread. Each is around 20 g protein and 30 g carbs. Because it's real food, it's fresh and chilled, not shelf-stable, so I'm using the Simmer Eats model. Simmer cooks fresh meals that last up to 5 days in the fridge and can be frozen on arrival. People order weekly (and squads order through their coach), I bake to order, deliver chilled around Durham to start, and they eat it within 3 days or freeze it. 'Baked this week, not 12 months ago.' Next steps: blind taste tests against Barebells, a squad trial with Team Durham, registering as a food business, and more interviews. Thank you.</a:t>
+              <a:t>~60s. Three flavours in testing: Chocolate Peanut Butter, Vanilla and Banana Bread. Each 50 g bar is about 15 g protein and 14 g carbs; athletes eat two after training. Because it's real food, it's fresh and chilled, not shelf-stable, so I'm using the Simmer Eats model. Simmer cooks fresh meals that last up to 5 days in the fridge and can be frozen on arrival. People order weekly (and squads order through their coach), I bake to order, deliver chilled around Durham to start, and they eat it within 3 days or freeze it. 'Baked this week, not 12 months ago.' Next steps: blind taste tests against Barebells, a squad trial with Team Durham, registering as a food business, and more interviews. Thank you.</a:t>
             </a:r>
             <a:endParaRPr lang="en-US" dirty="0"/>
           </a:p>
@@ -1057,7 +1057,7 @@
                   <a:schemeClr val="accent3"/>
                 </a:solidFill>
               </a:rPr>
-              <a:t>Durham Venture School · Week 5 · working name &amp; branding TBC</a:t>
+              <a:t>Graft · Earned, not engineered. · Durham Venture School</a:t>
             </a:r>
             <a:endParaRPr lang="en-US" sz="1000" dirty="0"/>
           </a:p>
@@ -1209,7 +1209,7 @@
                   <a:schemeClr val="accent3"/>
                 </a:solidFill>
               </a:rPr>
-              <a:t>Durham Venture School · Week 5 · working name &amp; branding TBC</a:t>
+              <a:t>Graft · Earned, not engineered. · Durham Venture School</a:t>
             </a:r>
             <a:endParaRPr lang="en-US" sz="1000" dirty="0"/>
           </a:p>
@@ -1665,6 +1665,17 @@
               </a:rPr>
               <a:t> recovery bar for athletes who train hard</a:t>
             </a:r>
+            <a:pPr algn="l" indent="0" marL="0">
+              <a:buNone/>
+            </a:pPr>
+            <a:r>
+              <a:rPr lang="en-US" sz="3600" b="1" dirty="0">
+                <a:solidFill>
+                  <a:schemeClr val="accent1"/>
+                </a:solidFill>
+              </a:rPr>
+              <a:t>  Graft.</a:t>
+            </a:r>
             <a:endParaRPr lang="en-US" sz="3600" dirty="0"/>
           </a:p>
         </p:txBody>
@@ -1699,7 +1710,7 @@
                   <a:schemeClr val="bg1"/>
                 </a:solidFill>
               </a:rPr>
-              <a:t>~20 g protein  ·  ~30 g carbs  ·  made from eggs, quark &amp; oats  ·  no powders, sweeteners or sugar alcohols</a:t>
+              <a:t>Two 50 g bars ≈ 29 g protein + 28 g carbs  ·  egg, quark &amp; oats  ·  no whey, sweeteners or sugar alcohols</a:t>
             </a:r>
             <a:endParaRPr lang="en-US" sz="1800" dirty="0"/>
           </a:p>
@@ -2185,7 +2196,7 @@
                   <a:schemeClr val="accent3"/>
                 </a:solidFill>
               </a:rPr>
-              <a:t>Branding is in the works: working name only, nothing set yet.</a:t>
+              <a:t>Graft: Northern for hard work. For people who put the work in. Earned, not engineered.</a:t>
             </a:r>
             <a:endParaRPr lang="en-US" sz="1400" dirty="0"/>
           </a:p>
@@ -3366,7 +3377,7 @@
                   <a:schemeClr val="bg1"/>
                 </a:solidFill>
               </a:rPr>
-              <a:t>Trains most days: gym (8/10) + a sport (4/10)</a:t>
+              <a:t>Trains once a day: gym (8/10) + a sport (4/10)</a:t>
             </a:r>
             <a:endParaRPr lang="en-US" sz="1400" dirty="0"/>
           </a:p>
@@ -3902,7 +3913,7 @@
                   <a:schemeClr val="accent3"/>
                 </a:solidFill>
               </a:rPr>
-              <a:t>Still to prove: 0/10 have committed yet, and some gym-goers just wait for a meal, so the focus is athletes who train hard.</a:t>
+              <a:t>Early adopters: coached athletes (Team Durham squads, my MMA club). One coach = ~25 athletes = one drop. Still to prove: 0/10 committed yet.</a:t>
             </a:r>
             <a:endParaRPr lang="en-US" sz="1300" dirty="0"/>
           </a:p>
@@ -4010,7 +4021,7 @@
                   <a:schemeClr val="tx1"/>
                 </a:solidFill>
               </a:rPr>
-              <a:t>Competition: nobody gets 20 g protein from real food</a:t>
+              <a:t>Competition: powders and sweeteners, or sugar</a:t>
             </a:r>
             <a:endParaRPr lang="en-US" sz="3200" dirty="0"/>
           </a:p>
@@ -6209,7 +6220,7 @@
                             <a:schemeClr val="bg1"/>
                           </a:solidFill>
                         </a:rPr>
-                        <a:t>Our bar (calculated)</a:t>
+                        <a:t>Graft, 2 × 50 g bars (calculated)</a:t>
                       </a:r>
                       <a:endParaRPr lang="en-US" sz="1200" dirty="0"/>
                     </a:p>
@@ -6270,7 +6281,7 @@
                             <a:schemeClr val="bg1"/>
                           </a:solidFill>
                         </a:rPr>
-                        <a:t>~21 g</a:t>
+                        <a:t>~29 g</a:t>
                       </a:r>
                       <a:endParaRPr lang="en-US" sz="1200" dirty="0"/>
                     </a:p>
@@ -6331,7 +6342,7 @@
                             <a:schemeClr val="bg1"/>
                           </a:solidFill>
                         </a:rPr>
-                        <a:t>~27–30 g</a:t>
+                        <a:t>~28 g</a:t>
                       </a:r>
                       <a:endParaRPr lang="en-US" sz="1200" dirty="0"/>
                     </a:p>
@@ -6392,7 +6403,7 @@
                             <a:schemeClr val="bg1"/>
                           </a:solidFill>
                         </a:rPr>
-                        <a:t>~5.5 g</a:t>
+                        <a:t>~8 g</a:t>
                       </a:r>
                       <a:endParaRPr lang="en-US" sz="1200" dirty="0"/>
                     </a:p>
@@ -6453,7 +6464,7 @@
                             <a:schemeClr val="bg1"/>
                           </a:solidFill>
                         </a:rPr>
-                        <a:t>Eggs, quark, oats, honey or banana. Nothing else</a:t>
+                        <a:t>Egg, quark, oats, a little honey or banana. No whey, no sweeteners</a:t>
                       </a:r>
                       <a:endParaRPr lang="en-US" sz="1200" dirty="0"/>
                     </a:p>
@@ -6641,7 +6652,7 @@
                   <a:schemeClr val="tx1"/>
                 </a:solidFill>
               </a:rPr>
-              <a:t>~20 g protein from real food</a:t>
+              <a:t>Protein from egg &amp; quark, not powder</a:t>
             </a:r>
             <a:endParaRPr lang="en-US" sz="1400" dirty="0"/>
           </a:p>
@@ -7100,7 +7111,7 @@
         <p:spPr>
           <a:xfrm>
             <a:off x="548640" y="2377440"/>
-            <a:ext cx="6949440" cy="365760"/>
+            <a:ext cx="11064240" cy="365760"/>
           </a:xfrm>
           <a:prstGeom prst="rect">
             <a:avLst/>
@@ -7121,7 +7132,7 @@
                   <a:schemeClr val="accent3"/>
                 </a:solidFill>
               </a:rPr>
-              <a:t>Each ~21 g protein · ~27–30 g carbs · ~5.5 g sugar · ~260–280 kcal (calculated)</a:t>
+              <a:t>Each 50 g bar: ~15 g protein · ~14 g carbs · ~4 g sugar · ~135 kcal (calculated) · eat two after training</a:t>
             </a:r>
             <a:endParaRPr lang="en-US" sz="1400" dirty="0"/>
           </a:p>

</xml_diff>

<commit_message>
Graft landing page, slogan 'Real food for grafters', exact early adopters in brief
Co-Authored-By: Claude Opus 5.5 <noreply@anthropic.com>
Claude-Session: https://claude.ai/code/session_01GJGkDeLHjnkx4ZbaPKgLVt
</commit_message>
<xml_diff>
--- a/09-pitch/pitch-deck.pptx
+++ b/09-pitch/pitch-deck.pptx
@@ -111,27 +111,27 @@
   <p:extLst>
     <p:ext uri="{521415D9-36F7-43E2-AB2F-B90AF26B5E84}">
       <p14:sectionLst xmlns:p14="http://schemas.microsoft.com/office/powerpoint/2010/main">
-        <p14:section name="Concept" id="{5dff365d-d688-1e19-fa1e-661c40c9e0b0}">
+        <p14:section name="Concept" id="{5b906eb9-5163-e33c-9ace-655949e8c1fc}">
           <p14:sldIdLst>
             <p14:sldId id="256"/>
           </p14:sldIdLst>
         </p14:section>
-        <p14:section name="Problem" id="{702d312a-6856-819a-7bbd-f85d8a259081}">
+        <p14:section name="Problem" id="{294882c9-bbec-b479-a9be-d6cfdb3cf893}">
           <p14:sldIdLst>
             <p14:sldId id="257"/>
           </p14:sldIdLst>
         </p14:section>
-        <p14:section name="Customers" id="{e5e2233b-6f16-6a45-86a6-ffeab6398033}">
+        <p14:section name="Customers" id="{8700431c-5bea-3613-4890-39b5013daddd}">
           <p14:sldIdLst>
             <p14:sldId id="258"/>
           </p14:sldIdLst>
         </p14:section>
-        <p14:section name="Market" id="{03750e0b-d081-f3ce-4560-115e7b42d6d7}">
+        <p14:section name="Market" id="{663409ed-a77f-31f0-20cc-939f042ed581}">
           <p14:sldIdLst>
             <p14:sldId id="259"/>
           </p14:sldIdLst>
         </p14:section>
-        <p14:section name="Model" id="{97b54a27-c0df-c894-49f3-f101e8fb736d}">
+        <p14:section name="Model" id="{98292073-f5fb-1f78-7794-1065278f3e24}">
           <p14:sldIdLst>
             <p14:sldId id="260"/>
           </p14:sldIdLst>
@@ -540,7 +540,7 @@
           <a:p>
             <a:r>
               <a:rPr lang="en-US" dirty="0"/>
-              <a:t>~60s. I've pivoted. The idea is now a recovery bar made from real food, for athletes who train hard. It came from my own training. After two MMA classes back to back I'd eat a full meal and still be after more. Going from MMA straight to football, I'm in a rush and need something quick but proper. On a same-day weigh-in I'm depleted after making weight and have a short window to refuel before I compete. Every time, the choice is a lab-made protein bar full of powders and sweeteners, or nothing. So I made Graft: a 50 g bar with ~15 g protein from egg, quark and oats, and athletes eat two after training, about 29 g protein and 28 g carbs. Graft is Northern for hard work: it's for people who put the work in. Earned, not engineered. (Note for weigh-in days: fibre before competing can upset the gut, so a lower-fibre version may suit that use. Worth testing.)</a:t>
+              <a:t>~60s. I've pivoted. The idea is now a recovery bar made from real food, for athletes who train hard. It came from my own training. After two MMA classes back to back I'd eat a full meal and still be after more. Going from MMA straight to football, I'm in a rush and need something quick but proper. On a same-day weigh-in I'm depleted after making weight and have a short window to refuel before I compete. Every time, the choice is a lab-made protein bar full of powders and sweeteners, or nothing. So I made Graft: a 50 g bar with ~15 g protein from egg, quark and oats, and athletes eat two after training, about 29 g protein and 28 g carbs. Graft is British slang for hard work: it is for people who put the work in. Real food for grafters. (Note for weigh-in days: fibre before competing can upset the gut, so a lower-fibre version may suit that use. Worth testing.)</a:t>
             </a:r>
             <a:endParaRPr lang="en-US" dirty="0"/>
           </a:p>
@@ -1057,7 +1057,7 @@
                   <a:schemeClr val="accent3"/>
                 </a:solidFill>
               </a:rPr>
-              <a:t>Graft · Earned, not engineered. · Durham Venture School</a:t>
+              <a:t>Graft · Real food for grafters · Durham Venture School</a:t>
             </a:r>
             <a:endParaRPr lang="en-US" sz="1000" dirty="0"/>
           </a:p>
@@ -1209,7 +1209,7 @@
                   <a:schemeClr val="accent3"/>
                 </a:solidFill>
               </a:rPr>
-              <a:t>Graft · Earned, not engineered. · Durham Venture School</a:t>
+              <a:t>Graft · Real food for grafters · Durham Venture School</a:t>
             </a:r>
             <a:endParaRPr lang="en-US" sz="1000" dirty="0"/>
           </a:p>
@@ -2196,7 +2196,7 @@
                   <a:schemeClr val="accent3"/>
                 </a:solidFill>
               </a:rPr>
-              <a:t>Graft: Northern for hard work. For people who put the work in. Earned, not engineered.</a:t>
+              <a:t>Graft: British slang for hard work. For people who put the work in. Real food for grafters.</a:t>
             </a:r>
             <a:endParaRPr lang="en-US" sz="1400" dirty="0"/>
           </a:p>

</xml_diff>

<commit_message>
Graft bubble logo: prepared files, landing page, deck, brand guidelines
Co-Authored-By: Claude Opus 5.5 <noreply@anthropic.com>
Claude-Session: https://claude.ai/code/session_01GJGkDeLHjnkx4ZbaPKgLVt
</commit_message>
<xml_diff>
--- a/09-pitch/pitch-deck.pptx
+++ b/09-pitch/pitch-deck.pptx
@@ -111,27 +111,27 @@
   <p:extLst>
     <p:ext uri="{521415D9-36F7-43E2-AB2F-B90AF26B5E84}">
       <p14:sectionLst xmlns:p14="http://schemas.microsoft.com/office/powerpoint/2010/main">
-        <p14:section name="Concept" id="{5b906eb9-5163-e33c-9ace-655949e8c1fc}">
+        <p14:section name="Concept" id="{ed8b209a-1884-8e74-ac8a-6ae90dddd9d0}">
           <p14:sldIdLst>
             <p14:sldId id="256"/>
           </p14:sldIdLst>
         </p14:section>
-        <p14:section name="Problem" id="{294882c9-bbec-b479-a9be-d6cfdb3cf893}">
+        <p14:section name="Problem" id="{9d3bf88d-22d6-537c-67cf-97c7868747c9}">
           <p14:sldIdLst>
             <p14:sldId id="257"/>
           </p14:sldIdLst>
         </p14:section>
-        <p14:section name="Customers" id="{8700431c-5bea-3613-4890-39b5013daddd}">
+        <p14:section name="Customers" id="{74ddd37a-6c6b-9bd9-007c-429cb7597773}">
           <p14:sldIdLst>
             <p14:sldId id="258"/>
           </p14:sldIdLst>
         </p14:section>
-        <p14:section name="Market" id="{663409ed-a77f-31f0-20cc-939f042ed581}">
+        <p14:section name="Market" id="{dcc7ae2d-4528-3bbc-d4bf-8fa6e3eb647d}">
           <p14:sldIdLst>
             <p14:sldId id="259"/>
           </p14:sldIdLst>
         </p14:section>
-        <p14:section name="Model" id="{98292073-f5fb-1f78-7794-1065278f3e24}">
+        <p14:section name="Model" id="{b876360a-f2bf-f79e-2f76-9851ec7d08f0}">
           <p14:sldIdLst>
             <p14:sldId id="260"/>
           </p14:sldIdLst>
@@ -1665,17 +1665,6 @@
               </a:rPr>
               <a:t> recovery bar for athletes who train hard</a:t>
             </a:r>
-            <a:pPr algn="l" indent="0" marL="0">
-              <a:buNone/>
-            </a:pPr>
-            <a:r>
-              <a:rPr lang="en-US" sz="3600" b="1" dirty="0">
-                <a:solidFill>
-                  <a:schemeClr val="accent1"/>
-                </a:solidFill>
-              </a:rPr>
-              <a:t>  Graft.</a:t>
-            </a:r>
             <a:endParaRPr lang="en-US" sz="3600" dirty="0"/>
           </a:p>
         </p:txBody>
@@ -2166,16 +2155,40 @@
           </a:p>
         </p:txBody>
       </p:sp>
-      <p:sp>
-        <p:nvSpPr>
-          <p:cNvPr id="20" name="Branding note"/>
+      <p:pic>
+        <p:nvPicPr>
+          <p:cNvPr id="20" name="Graft logo" descr="Graft logo">    </p:cNvPr>
+          <p:cNvPicPr>
+            <a:picLocks noChangeAspect="1"/>
+          </p:cNvPicPr>
+          <p:nvPr/>
+        </p:nvPicPr>
+        <p:blipFill>
+          <a:blip r:embed="rId4"/>
+          <a:stretch>
+            <a:fillRect/>
+          </a:stretch>
+        </p:blipFill>
+        <p:spPr>
+          <a:xfrm>
+            <a:off x="548640" y="5669280"/>
+            <a:ext cx="1600200" cy="448056"/>
+          </a:xfrm>
+          <a:prstGeom prst="rect">
+            <a:avLst/>
+          </a:prstGeom>
+        </p:spPr>
+      </p:pic>
+      <p:sp>
+        <p:nvSpPr>
+          <p:cNvPr id="21" name="Branding note"/>
           <p:cNvSpPr txBox="1"/>
           <p:nvPr/>
         </p:nvSpPr>
         <p:spPr>
           <a:xfrm>
-            <a:off x="548640" y="5806440"/>
-            <a:ext cx="11064240" cy="365760"/>
+            <a:off x="2377440" y="5715000"/>
+            <a:ext cx="9235440" cy="365760"/>
           </a:xfrm>
           <a:prstGeom prst="rect">
             <a:avLst/>
@@ -2196,7 +2209,7 @@
                   <a:schemeClr val="accent3"/>
                 </a:solidFill>
               </a:rPr>
-              <a:t>Graft: British slang for hard work. For people who put the work in. Real food for grafters.</a:t>
+              <a:t>Real food for grafters.  (Graft: British slang for hard work.)</a:t>
             </a:r>
             <a:endParaRPr lang="en-US" sz="1400" dirty="0"/>
           </a:p>
@@ -6892,9 +6905,33 @@
           </a:p>
         </p:txBody>
       </p:sp>
-      <p:sp>
-        <p:nvSpPr>
-          <p:cNvPr id="3" name="Flavours heading"/>
+      <p:pic>
+        <p:nvPicPr>
+          <p:cNvPr id="3" name="Graft logo" descr="Graft logo">    </p:cNvPr>
+          <p:cNvPicPr>
+            <a:picLocks noChangeAspect="1"/>
+          </p:cNvPicPr>
+          <p:nvPr/>
+        </p:nvPicPr>
+        <p:blipFill>
+          <a:blip r:embed="rId1"/>
+          <a:stretch>
+            <a:fillRect/>
+          </a:stretch>
+        </p:blipFill>
+        <p:spPr>
+          <a:xfrm>
+            <a:off x="10195560" y="457200"/>
+            <a:ext cx="1417320" cy="393192"/>
+          </a:xfrm>
+          <a:prstGeom prst="rect">
+            <a:avLst/>
+          </a:prstGeom>
+        </p:spPr>
+      </p:pic>
+      <p:sp>
+        <p:nvSpPr>
+          <p:cNvPr id="4" name="Flavours heading"/>
           <p:cNvSpPr txBox="1"/>
           <p:nvPr/>
         </p:nvSpPr>
@@ -6930,7 +6967,7 @@
       </p:sp>
       <p:sp>
         <p:nvSpPr>
-          <p:cNvPr id="4" name="Flavour 1"/>
+          <p:cNvPr id="5" name="Flavour 1"/>
           <p:cNvSpPr/>
           <p:nvPr/>
         </p:nvSpPr>
@@ -6952,7 +6989,7 @@
       </p:sp>
       <p:sp>
         <p:nvSpPr>
-          <p:cNvPr id="5" name="Flavour 1 label"/>
+          <p:cNvPr id="6" name="Flavour 1 label"/>
           <p:cNvSpPr txBox="1"/>
           <p:nvPr/>
         </p:nvSpPr>
@@ -6988,7 +7025,7 @@
       </p:sp>
       <p:sp>
         <p:nvSpPr>
-          <p:cNvPr id="6" name="Flavour 2"/>
+          <p:cNvPr id="7" name="Flavour 2"/>
           <p:cNvSpPr/>
           <p:nvPr/>
         </p:nvSpPr>
@@ -7010,7 +7047,7 @@
       </p:sp>
       <p:sp>
         <p:nvSpPr>
-          <p:cNvPr id="7" name="Flavour 2 label"/>
+          <p:cNvPr id="8" name="Flavour 2 label"/>
           <p:cNvSpPr txBox="1"/>
           <p:nvPr/>
         </p:nvSpPr>
@@ -7046,7 +7083,7 @@
       </p:sp>
       <p:sp>
         <p:nvSpPr>
-          <p:cNvPr id="8" name="Flavour 3"/>
+          <p:cNvPr id="9" name="Flavour 3"/>
           <p:cNvSpPr/>
           <p:nvPr/>
         </p:nvSpPr>
@@ -7068,7 +7105,7 @@
       </p:sp>
       <p:sp>
         <p:nvSpPr>
-          <p:cNvPr id="9" name="Flavour 3 label"/>
+          <p:cNvPr id="10" name="Flavour 3 label"/>
           <p:cNvSpPr txBox="1"/>
           <p:nvPr/>
         </p:nvSpPr>
@@ -7104,7 +7141,7 @@
       </p:sp>
       <p:sp>
         <p:nvSpPr>
-          <p:cNvPr id="10" name="Flavour macros"/>
+          <p:cNvPr id="11" name="Flavour macros"/>
           <p:cNvSpPr txBox="1"/>
           <p:nvPr/>
         </p:nvSpPr>
@@ -7140,7 +7177,7 @@
       </p:sp>
       <p:sp>
         <p:nvSpPr>
-          <p:cNvPr id="11" name="Step 1 card"/>
+          <p:cNvPr id="12" name="Step 1 card"/>
           <p:cNvSpPr/>
           <p:nvPr/>
         </p:nvSpPr>
@@ -7162,7 +7199,7 @@
       </p:sp>
       <p:sp>
         <p:nvSpPr>
-          <p:cNvPr id="12" name="Step 1 circle"/>
+          <p:cNvPr id="13" name="Step 1 circle"/>
           <p:cNvSpPr/>
           <p:nvPr/>
         </p:nvSpPr>
@@ -7182,14 +7219,14 @@
       </p:sp>
       <p:pic>
         <p:nvPicPr>
-          <p:cNvPr id="13" name="Step 1 icon" descr="Step 1">    </p:cNvPr>
+          <p:cNvPr id="14" name="Step 1 icon" descr="Step 1">    </p:cNvPr>
           <p:cNvPicPr>
             <a:picLocks noChangeAspect="1"/>
           </p:cNvPicPr>
           <p:nvPr/>
         </p:nvPicPr>
         <p:blipFill>
-          <a:blip r:embed="rId1"/>
+          <a:blip r:embed="rId2"/>
           <a:stretch>
             <a:fillRect/>
           </a:stretch>
@@ -7206,7 +7243,7 @@
       </p:pic>
       <p:sp>
         <p:nvSpPr>
-          <p:cNvPr id="14" name="Step 1 title"/>
+          <p:cNvPr id="15" name="Step 1 title"/>
           <p:cNvSpPr txBox="1"/>
           <p:nvPr/>
         </p:nvSpPr>
@@ -7242,7 +7279,7 @@
       </p:sp>
       <p:sp>
         <p:nvSpPr>
-          <p:cNvPr id="15" name="Step 1 text"/>
+          <p:cNvPr id="16" name="Step 1 text"/>
           <p:cNvSpPr txBox="1"/>
           <p:nvPr/>
         </p:nvSpPr>
@@ -7278,7 +7315,7 @@
       </p:sp>
       <p:sp>
         <p:nvSpPr>
-          <p:cNvPr id="16" name="Arrow 1"/>
+          <p:cNvPr id="17" name="Arrow 1"/>
           <p:cNvSpPr/>
           <p:nvPr/>
         </p:nvSpPr>
@@ -7298,7 +7335,7 @@
       </p:sp>
       <p:sp>
         <p:nvSpPr>
-          <p:cNvPr id="17" name="Step 2 card"/>
+          <p:cNvPr id="18" name="Step 2 card"/>
           <p:cNvSpPr/>
           <p:nvPr/>
         </p:nvSpPr>
@@ -7320,7 +7357,7 @@
       </p:sp>
       <p:sp>
         <p:nvSpPr>
-          <p:cNvPr id="18" name="Step 2 circle"/>
+          <p:cNvPr id="19" name="Step 2 circle"/>
           <p:cNvSpPr/>
           <p:nvPr/>
         </p:nvSpPr>
@@ -7340,14 +7377,14 @@
       </p:sp>
       <p:pic>
         <p:nvPicPr>
-          <p:cNvPr id="19" name="Step 2 icon" descr="Step 2">    </p:cNvPr>
+          <p:cNvPr id="20" name="Step 2 icon" descr="Step 2">    </p:cNvPr>
           <p:cNvPicPr>
             <a:picLocks noChangeAspect="1"/>
           </p:cNvPicPr>
           <p:nvPr/>
         </p:nvPicPr>
         <p:blipFill>
-          <a:blip r:embed="rId2"/>
+          <a:blip r:embed="rId3"/>
           <a:stretch>
             <a:fillRect/>
           </a:stretch>
@@ -7364,7 +7401,7 @@
       </p:pic>
       <p:sp>
         <p:nvSpPr>
-          <p:cNvPr id="20" name="Step 2 title"/>
+          <p:cNvPr id="21" name="Step 2 title"/>
           <p:cNvSpPr txBox="1"/>
           <p:nvPr/>
         </p:nvSpPr>
@@ -7400,7 +7437,7 @@
       </p:sp>
       <p:sp>
         <p:nvSpPr>
-          <p:cNvPr id="21" name="Step 2 text"/>
+          <p:cNvPr id="22" name="Step 2 text"/>
           <p:cNvSpPr txBox="1"/>
           <p:nvPr/>
         </p:nvSpPr>
@@ -7436,7 +7473,7 @@
       </p:sp>
       <p:sp>
         <p:nvSpPr>
-          <p:cNvPr id="22" name="Arrow 2"/>
+          <p:cNvPr id="23" name="Arrow 2"/>
           <p:cNvSpPr/>
           <p:nvPr/>
         </p:nvSpPr>
@@ -7456,7 +7493,7 @@
       </p:sp>
       <p:sp>
         <p:nvSpPr>
-          <p:cNvPr id="23" name="Step 3 card"/>
+          <p:cNvPr id="24" name="Step 3 card"/>
           <p:cNvSpPr/>
           <p:nvPr/>
         </p:nvSpPr>
@@ -7478,7 +7515,7 @@
       </p:sp>
       <p:sp>
         <p:nvSpPr>
-          <p:cNvPr id="24" name="Step 3 circle"/>
+          <p:cNvPr id="25" name="Step 3 circle"/>
           <p:cNvSpPr/>
           <p:nvPr/>
         </p:nvSpPr>
@@ -7498,14 +7535,14 @@
       </p:sp>
       <p:pic>
         <p:nvPicPr>
-          <p:cNvPr id="25" name="Step 3 icon" descr="Step 3">    </p:cNvPr>
+          <p:cNvPr id="26" name="Step 3 icon" descr="Step 3">    </p:cNvPr>
           <p:cNvPicPr>
             <a:picLocks noChangeAspect="1"/>
           </p:cNvPicPr>
           <p:nvPr/>
         </p:nvPicPr>
         <p:blipFill>
-          <a:blip r:embed="rId3"/>
+          <a:blip r:embed="rId4"/>
           <a:stretch>
             <a:fillRect/>
           </a:stretch>
@@ -7522,7 +7559,7 @@
       </p:pic>
       <p:sp>
         <p:nvSpPr>
-          <p:cNvPr id="26" name="Step 3 title"/>
+          <p:cNvPr id="27" name="Step 3 title"/>
           <p:cNvSpPr txBox="1"/>
           <p:nvPr/>
         </p:nvSpPr>
@@ -7558,7 +7595,7 @@
       </p:sp>
       <p:sp>
         <p:nvSpPr>
-          <p:cNvPr id="27" name="Step 3 text"/>
+          <p:cNvPr id="28" name="Step 3 text"/>
           <p:cNvSpPr txBox="1"/>
           <p:nvPr/>
         </p:nvSpPr>
@@ -7594,7 +7631,7 @@
       </p:sp>
       <p:sp>
         <p:nvSpPr>
-          <p:cNvPr id="28" name="Arrow 3"/>
+          <p:cNvPr id="29" name="Arrow 3"/>
           <p:cNvSpPr/>
           <p:nvPr/>
         </p:nvSpPr>
@@ -7614,7 +7651,7 @@
       </p:sp>
       <p:sp>
         <p:nvSpPr>
-          <p:cNvPr id="29" name="Step 4 card"/>
+          <p:cNvPr id="30" name="Step 4 card"/>
           <p:cNvSpPr/>
           <p:nvPr/>
         </p:nvSpPr>
@@ -7636,7 +7673,7 @@
       </p:sp>
       <p:sp>
         <p:nvSpPr>
-          <p:cNvPr id="30" name="Step 4 circle"/>
+          <p:cNvPr id="31" name="Step 4 circle"/>
           <p:cNvSpPr/>
           <p:nvPr/>
         </p:nvSpPr>
@@ -7656,14 +7693,14 @@
       </p:sp>
       <p:pic>
         <p:nvPicPr>
-          <p:cNvPr id="31" name="Step 4 icon" descr="Step 4">    </p:cNvPr>
+          <p:cNvPr id="32" name="Step 4 icon" descr="Step 4">    </p:cNvPr>
           <p:cNvPicPr>
             <a:picLocks noChangeAspect="1"/>
           </p:cNvPicPr>
           <p:nvPr/>
         </p:nvPicPr>
         <p:blipFill>
-          <a:blip r:embed="rId4"/>
+          <a:blip r:embed="rId5"/>
           <a:stretch>
             <a:fillRect/>
           </a:stretch>
@@ -7680,7 +7717,7 @@
       </p:pic>
       <p:sp>
         <p:nvSpPr>
-          <p:cNvPr id="32" name="Step 4 title"/>
+          <p:cNvPr id="33" name="Step 4 title"/>
           <p:cNvSpPr txBox="1"/>
           <p:nvPr/>
         </p:nvSpPr>
@@ -7716,7 +7753,7 @@
       </p:sp>
       <p:sp>
         <p:nvSpPr>
-          <p:cNvPr id="33" name="Step 4 text"/>
+          <p:cNvPr id="34" name="Step 4 text"/>
           <p:cNvSpPr txBox="1"/>
           <p:nvPr/>
         </p:nvSpPr>
@@ -7752,7 +7789,7 @@
       </p:sp>
       <p:sp>
         <p:nvSpPr>
-          <p:cNvPr id="34" name="Close box"/>
+          <p:cNvPr id="35" name="Close box"/>
           <p:cNvSpPr/>
           <p:nvPr/>
         </p:nvSpPr>
@@ -7774,7 +7811,7 @@
       </p:sp>
       <p:sp>
         <p:nvSpPr>
-          <p:cNvPr id="35" name="Close text"/>
+          <p:cNvPr id="36" name="Close text"/>
           <p:cNvSpPr txBox="1"/>
           <p:nvPr/>
         </p:nvSpPr>

</xml_diff>

<commit_message>
Market gap analysis: 4-test scoring of 25 UK snacks, gap chart, one-page summary, deck slide 4
Co-Authored-By: Claude Opus 5.5 <noreply@anthropic.com>
Claude-Session: https://claude.ai/code/session_01GJGkDeLHjnkx4ZbaPKgLVt
</commit_message>
<xml_diff>
--- a/09-pitch/pitch-deck.pptx
+++ b/09-pitch/pitch-deck.pptx
@@ -111,27 +111,27 @@
   <p:extLst>
     <p:ext uri="{521415D9-36F7-43E2-AB2F-B90AF26B5E84}">
       <p14:sectionLst xmlns:p14="http://schemas.microsoft.com/office/powerpoint/2010/main">
-        <p14:section name="Concept" id="{ed8b209a-1884-8e74-ac8a-6ae90dddd9d0}">
+        <p14:section name="Concept" id="{403483b8-0b5b-a0b4-d045-991deb5ba4ee}">
           <p14:sldIdLst>
             <p14:sldId id="256"/>
           </p14:sldIdLst>
         </p14:section>
-        <p14:section name="Problem" id="{9d3bf88d-22d6-537c-67cf-97c7868747c9}">
+        <p14:section name="Problem" id="{7540f01b-dbee-a4ee-09e5-46212d3d3a1d}">
           <p14:sldIdLst>
             <p14:sldId id="257"/>
           </p14:sldIdLst>
         </p14:section>
-        <p14:section name="Customers" id="{74ddd37a-6c6b-9bd9-007c-429cb7597773}">
+        <p14:section name="Customers" id="{6b78cc4e-f8e3-67b3-bfaf-170cd36795b2}">
           <p14:sldIdLst>
             <p14:sldId id="258"/>
           </p14:sldIdLst>
         </p14:section>
-        <p14:section name="Market" id="{dcc7ae2d-4528-3bbc-d4bf-8fa6e3eb647d}">
+        <p14:section name="Market" id="{d37a04da-deb5-58cf-f98a-9bfb3ebf583a}">
           <p14:sldIdLst>
             <p14:sldId id="259"/>
           </p14:sldIdLst>
         </p14:section>
-        <p14:section name="Model" id="{b876360a-f2bf-f79e-2f76-9851ec7d08f0}">
+        <p14:section name="Model" id="{ecadc0e4-3231-b04a-889e-0a0ef4266cd7}">
           <p14:sldIdLst>
             <p14:sldId id="260"/>
           </p14:sldIdLst>
@@ -804,7 +804,7 @@
           <a:p>
             <a:r>
               <a:rPr lang="en-US" dirty="0"/>
-              <a:t>~60s. These are the recovery bars athletes see: Myprotein's Re-Fuel, Amacx, HIGH5, Styrkr, Huel. The ones with 20 g protein get it from protein powder, and most rely on syrups or sugar alcohols. Re-Fuel's first ingredient is maltitol. The 'real food' bars like Veloforte have lots of sugar and only 12 g protein. Across 32+ UK bars I checked, none gets its protein from real food with low sugar. Graft does: two 50 g bars give about 29 g protein and 28 g carbs from egg, quark and oats, with a little honey or banana and no sweeteners. Our numbers are calculated from the ingredients and will be lab-checked.</a:t>
+              <a:t>~60s. I scored 25 UK protein snacks on four tests: at least 10 g protein, protein from real food rather than powders, no sweeteners, and low sugar. 20 have the protein, 11 are low in sugar, only 4 use real-food protein, and none pass all four. The high-protein, low-sugar bars all use powders, mostly with sweeteners. The real-food bars carry 13 to 20 g of sugar. Why? Shops need months of shelf life, and real food lasts days. Graft designs around that: bake to order, sell direct to squads. Graft's numbers are calculated, not yet lab-tested. OLD NOTES: These are the recovery bars athletes see: Myprotein's Re-Fuel, Amacx, HIGH5, Styrkr, Huel. The ones with 20 g protein get it from protein powder, and most rely on syrups or sugar alcohols. Re-Fuel's first ingredient is maltitol. The 'real food' bars like Veloforte have lots of sugar and only 12 g protein. Across 32+ UK bars I checked, none gets its protein from real food with low sugar. Graft does: two 50 g bars give about 29 g protein and 28 g carbs from egg, quark and oats, with a little honey or banana and no sweeteners. Our numbers are calculated from the ingredients and will be lab-checked.</a:t>
             </a:r>
             <a:endParaRPr lang="en-US" dirty="0"/>
           </a:p>
@@ -4034,2546 +4034,15 @@
                   <a:schemeClr val="tx1"/>
                 </a:solidFill>
               </a:rPr>
-              <a:t>Competition: powders and sweeteners, or sugar</a:t>
+              <a:t>The gap: nobody does all three</a:t>
             </a:r>
             <a:endParaRPr lang="en-US" sz="3200" dirty="0"/>
           </a:p>
         </p:txBody>
-      </p:sp>
-      <p:graphicFrame>
-        <p:nvGraphicFramePr>
-          <p:cNvPr id="5" name="Competitor table"/>
-          <p:cNvGraphicFramePr>
-            <a:graphicFrameLocks noGrp="1"/>
-          </p:cNvGraphicFramePr>
-          <p:nvPr>
-            <p:extLst>
-              <p:ext uri="{D42A27DB-BD31-4B8C-83A1-F6EECF244321}">
-                <p14:modId xmlns:p14="http://schemas.microsoft.com/office/powerpoint/2010/main" val="1579011935"/>
-              </p:ext>
-            </p:extLst>
-          </p:nvPr>
-        </p:nvGraphicFramePr>
-        <p:xfrm>
-          <a:off x="548640" y="1280160"/>
-          <a:ext cx="7680960" cy="914400"/>
-        </p:xfrm>
-        <a:graphic>
-          <a:graphicData uri="http://schemas.openxmlformats.org/drawingml/2006/table">
-            <a:tbl>
-              <a:tblPr/>
-              <a:tblGrid>
-                <a:gridCol w="2514600"/>
-                <a:gridCol w="868680"/>
-                <a:gridCol w="868680"/>
-                <a:gridCol w="777240"/>
-                <a:gridCol w="2651760"/>
-              </a:tblGrid>
-              <a:tr h="475488">
-                <a:tc>
-                  <a:txBody>
-                    <a:bodyPr/>
-                    <a:lstStyle/>
-                    <a:p>
-                      <a:pPr indent="0" marL="0">
-                        <a:buNone/>
-                      </a:pPr>
-                      <a:r>
-                        <a:rPr lang="en-US" sz="1200" b="1" dirty="0">
-                          <a:solidFill>
-                            <a:schemeClr val="bg1"/>
-                          </a:solidFill>
-                        </a:rPr>
-                        <a:t>Bar (per bar)</a:t>
-                      </a:r>
-                      <a:endParaRPr lang="en-US" sz="1200" dirty="0"/>
-                    </a:p>
-                  </a:txBody>
-                  <a:tcPr marL="54864" marR="54864" marT="54864" marB="54864" anchor="ctr">
-                    <a:lnL w="9525" cap="flat" cmpd="sng" algn="ctr">
-                      <a:solidFill>
-                        <a:srgbClr val="E5E7EB"/>
-                      </a:solidFill>
-                      <a:prstDash val="solid"/>
-                      <a:round/>
-                      <a:headEnd type="none" w="med" len="med"/>
-                      <a:tailEnd type="none" w="med" len="med"/>
-                    </a:lnL>
-                    <a:lnR w="9525" cap="flat" cmpd="sng" algn="ctr">
-                      <a:solidFill>
-                        <a:srgbClr val="E5E7EB"/>
-                      </a:solidFill>
-                      <a:prstDash val="solid"/>
-                      <a:round/>
-                      <a:headEnd type="none" w="med" len="med"/>
-                      <a:tailEnd type="none" w="med" len="med"/>
-                    </a:lnR>
-                    <a:lnT w="9525" cap="flat" cmpd="sng" algn="ctr">
-                      <a:solidFill>
-                        <a:srgbClr val="E5E7EB"/>
-                      </a:solidFill>
-                      <a:prstDash val="solid"/>
-                      <a:round/>
-                      <a:headEnd type="none" w="med" len="med"/>
-                      <a:tailEnd type="none" w="med" len="med"/>
-                    </a:lnT>
-                    <a:lnB w="9525" cap="flat" cmpd="sng" algn="ctr">
-                      <a:solidFill>
-                        <a:srgbClr val="E5E7EB"/>
-                      </a:solidFill>
-                      <a:prstDash val="solid"/>
-                      <a:round/>
-                      <a:headEnd type="none" w="med" len="med"/>
-                      <a:tailEnd type="none" w="med" len="med"/>
-                    </a:lnB>
-                    <a:solidFill>
-                      <a:schemeClr val="tx1"/>
-                    </a:solidFill>
-                  </a:tcPr>
-                </a:tc>
-                <a:tc>
-                  <a:txBody>
-                    <a:bodyPr/>
-                    <a:lstStyle/>
-                    <a:p>
-                      <a:pPr indent="0" marL="0">
-                        <a:buNone/>
-                      </a:pPr>
-                      <a:r>
-                        <a:rPr lang="en-US" sz="1200" b="1" dirty="0">
-                          <a:solidFill>
-                            <a:schemeClr val="bg1"/>
-                          </a:solidFill>
-                        </a:rPr>
-                        <a:t>Protein</a:t>
-                      </a:r>
-                      <a:endParaRPr lang="en-US" sz="1200" dirty="0"/>
-                    </a:p>
-                  </a:txBody>
-                  <a:tcPr marL="54864" marR="54864" marT="54864" marB="54864" anchor="ctr">
-                    <a:lnL w="9525" cap="flat" cmpd="sng" algn="ctr">
-                      <a:solidFill>
-                        <a:srgbClr val="E5E7EB"/>
-                      </a:solidFill>
-                      <a:prstDash val="solid"/>
-                      <a:round/>
-                      <a:headEnd type="none" w="med" len="med"/>
-                      <a:tailEnd type="none" w="med" len="med"/>
-                    </a:lnL>
-                    <a:lnR w="9525" cap="flat" cmpd="sng" algn="ctr">
-                      <a:solidFill>
-                        <a:srgbClr val="E5E7EB"/>
-                      </a:solidFill>
-                      <a:prstDash val="solid"/>
-                      <a:round/>
-                      <a:headEnd type="none" w="med" len="med"/>
-                      <a:tailEnd type="none" w="med" len="med"/>
-                    </a:lnR>
-                    <a:lnT w="9525" cap="flat" cmpd="sng" algn="ctr">
-                      <a:solidFill>
-                        <a:srgbClr val="E5E7EB"/>
-                      </a:solidFill>
-                      <a:prstDash val="solid"/>
-                      <a:round/>
-                      <a:headEnd type="none" w="med" len="med"/>
-                      <a:tailEnd type="none" w="med" len="med"/>
-                    </a:lnT>
-                    <a:lnB w="9525" cap="flat" cmpd="sng" algn="ctr">
-                      <a:solidFill>
-                        <a:srgbClr val="E5E7EB"/>
-                      </a:solidFill>
-                      <a:prstDash val="solid"/>
-                      <a:round/>
-                      <a:headEnd type="none" w="med" len="med"/>
-                      <a:tailEnd type="none" w="med" len="med"/>
-                    </a:lnB>
-                    <a:solidFill>
-                      <a:schemeClr val="tx1"/>
-                    </a:solidFill>
-                  </a:tcPr>
-                </a:tc>
-                <a:tc>
-                  <a:txBody>
-                    <a:bodyPr/>
-                    <a:lstStyle/>
-                    <a:p>
-                      <a:pPr indent="0" marL="0">
-                        <a:buNone/>
-                      </a:pPr>
-                      <a:r>
-                        <a:rPr lang="en-US" sz="1200" b="1" dirty="0">
-                          <a:solidFill>
-                            <a:schemeClr val="bg1"/>
-                          </a:solidFill>
-                        </a:rPr>
-                        <a:t>Carbs</a:t>
-                      </a:r>
-                      <a:endParaRPr lang="en-US" sz="1200" dirty="0"/>
-                    </a:p>
-                  </a:txBody>
-                  <a:tcPr marL="54864" marR="54864" marT="54864" marB="54864" anchor="ctr">
-                    <a:lnL w="9525" cap="flat" cmpd="sng" algn="ctr">
-                      <a:solidFill>
-                        <a:srgbClr val="E5E7EB"/>
-                      </a:solidFill>
-                      <a:prstDash val="solid"/>
-                      <a:round/>
-                      <a:headEnd type="none" w="med" len="med"/>
-                      <a:tailEnd type="none" w="med" len="med"/>
-                    </a:lnL>
-                    <a:lnR w="9525" cap="flat" cmpd="sng" algn="ctr">
-                      <a:solidFill>
-                        <a:srgbClr val="E5E7EB"/>
-                      </a:solidFill>
-                      <a:prstDash val="solid"/>
-                      <a:round/>
-                      <a:headEnd type="none" w="med" len="med"/>
-                      <a:tailEnd type="none" w="med" len="med"/>
-                    </a:lnR>
-                    <a:lnT w="9525" cap="flat" cmpd="sng" algn="ctr">
-                      <a:solidFill>
-                        <a:srgbClr val="E5E7EB"/>
-                      </a:solidFill>
-                      <a:prstDash val="solid"/>
-                      <a:round/>
-                      <a:headEnd type="none" w="med" len="med"/>
-                      <a:tailEnd type="none" w="med" len="med"/>
-                    </a:lnT>
-                    <a:lnB w="9525" cap="flat" cmpd="sng" algn="ctr">
-                      <a:solidFill>
-                        <a:srgbClr val="E5E7EB"/>
-                      </a:solidFill>
-                      <a:prstDash val="solid"/>
-                      <a:round/>
-                      <a:headEnd type="none" w="med" len="med"/>
-                      <a:tailEnd type="none" w="med" len="med"/>
-                    </a:lnB>
-                    <a:solidFill>
-                      <a:schemeClr val="tx1"/>
-                    </a:solidFill>
-                  </a:tcPr>
-                </a:tc>
-                <a:tc>
-                  <a:txBody>
-                    <a:bodyPr/>
-                    <a:lstStyle/>
-                    <a:p>
-                      <a:pPr indent="0" marL="0">
-                        <a:buNone/>
-                      </a:pPr>
-                      <a:r>
-                        <a:rPr lang="en-US" sz="1200" b="1" dirty="0">
-                          <a:solidFill>
-                            <a:schemeClr val="bg1"/>
-                          </a:solidFill>
-                        </a:rPr>
-                        <a:t>Sugar</a:t>
-                      </a:r>
-                      <a:endParaRPr lang="en-US" sz="1200" dirty="0"/>
-                    </a:p>
-                  </a:txBody>
-                  <a:tcPr marL="54864" marR="54864" marT="54864" marB="54864" anchor="ctr">
-                    <a:lnL w="9525" cap="flat" cmpd="sng" algn="ctr">
-                      <a:solidFill>
-                        <a:srgbClr val="E5E7EB"/>
-                      </a:solidFill>
-                      <a:prstDash val="solid"/>
-                      <a:round/>
-                      <a:headEnd type="none" w="med" len="med"/>
-                      <a:tailEnd type="none" w="med" len="med"/>
-                    </a:lnL>
-                    <a:lnR w="9525" cap="flat" cmpd="sng" algn="ctr">
-                      <a:solidFill>
-                        <a:srgbClr val="E5E7EB"/>
-                      </a:solidFill>
-                      <a:prstDash val="solid"/>
-                      <a:round/>
-                      <a:headEnd type="none" w="med" len="med"/>
-                      <a:tailEnd type="none" w="med" len="med"/>
-                    </a:lnR>
-                    <a:lnT w="9525" cap="flat" cmpd="sng" algn="ctr">
-                      <a:solidFill>
-                        <a:srgbClr val="E5E7EB"/>
-                      </a:solidFill>
-                      <a:prstDash val="solid"/>
-                      <a:round/>
-                      <a:headEnd type="none" w="med" len="med"/>
-                      <a:tailEnd type="none" w="med" len="med"/>
-                    </a:lnT>
-                    <a:lnB w="9525" cap="flat" cmpd="sng" algn="ctr">
-                      <a:solidFill>
-                        <a:srgbClr val="E5E7EB"/>
-                      </a:solidFill>
-                      <a:prstDash val="solid"/>
-                      <a:round/>
-                      <a:headEnd type="none" w="med" len="med"/>
-                      <a:tailEnd type="none" w="med" len="med"/>
-                    </a:lnB>
-                    <a:solidFill>
-                      <a:schemeClr val="tx1"/>
-                    </a:solidFill>
-                  </a:tcPr>
-                </a:tc>
-                <a:tc>
-                  <a:txBody>
-                    <a:bodyPr/>
-                    <a:lstStyle/>
-                    <a:p>
-                      <a:pPr indent="0" marL="0">
-                        <a:buNone/>
-                      </a:pPr>
-                      <a:r>
-                        <a:rPr lang="en-US" sz="1200" b="1" dirty="0">
-                          <a:solidFill>
-                            <a:schemeClr val="bg1"/>
-                          </a:solidFill>
-                        </a:rPr>
-                        <a:t>What it's made with</a:t>
-                      </a:r>
-                      <a:endParaRPr lang="en-US" sz="1200" dirty="0"/>
-                    </a:p>
-                  </a:txBody>
-                  <a:tcPr marL="54864" marR="54864" marT="54864" marB="54864" anchor="ctr">
-                    <a:lnL w="9525" cap="flat" cmpd="sng" algn="ctr">
-                      <a:solidFill>
-                        <a:srgbClr val="E5E7EB"/>
-                      </a:solidFill>
-                      <a:prstDash val="solid"/>
-                      <a:round/>
-                      <a:headEnd type="none" w="med" len="med"/>
-                      <a:tailEnd type="none" w="med" len="med"/>
-                    </a:lnL>
-                    <a:lnR w="9525" cap="flat" cmpd="sng" algn="ctr">
-                      <a:solidFill>
-                        <a:srgbClr val="E5E7EB"/>
-                      </a:solidFill>
-                      <a:prstDash val="solid"/>
-                      <a:round/>
-                      <a:headEnd type="none" w="med" len="med"/>
-                      <a:tailEnd type="none" w="med" len="med"/>
-                    </a:lnR>
-                    <a:lnT w="9525" cap="flat" cmpd="sng" algn="ctr">
-                      <a:solidFill>
-                        <a:srgbClr val="E5E7EB"/>
-                      </a:solidFill>
-                      <a:prstDash val="solid"/>
-                      <a:round/>
-                      <a:headEnd type="none" w="med" len="med"/>
-                      <a:tailEnd type="none" w="med" len="med"/>
-                    </a:lnT>
-                    <a:lnB w="9525" cap="flat" cmpd="sng" algn="ctr">
-                      <a:solidFill>
-                        <a:srgbClr val="E5E7EB"/>
-                      </a:solidFill>
-                      <a:prstDash val="solid"/>
-                      <a:round/>
-                      <a:headEnd type="none" w="med" len="med"/>
-                      <a:tailEnd type="none" w="med" len="med"/>
-                    </a:lnB>
-                    <a:solidFill>
-                      <a:schemeClr val="tx1"/>
-                    </a:solidFill>
-                  </a:tcPr>
-                </a:tc>
-              </a:tr>
-              <a:tr h="475488">
-                <a:tc>
-                  <a:txBody>
-                    <a:bodyPr/>
-                    <a:lstStyle/>
-                    <a:p>
-                      <a:pPr indent="0" marL="0">
-                        <a:buNone/>
-                      </a:pPr>
-                      <a:r>
-                        <a:rPr lang="en-US" sz="1200" dirty="0">
-                          <a:solidFill>
-                            <a:schemeClr val="tx1"/>
-                          </a:solidFill>
-                        </a:rPr>
-                        <a:t>Myprotein THE Re-Fuel (80 g)</a:t>
-                      </a:r>
-                      <a:endParaRPr lang="en-US" sz="1200" dirty="0"/>
-                    </a:p>
-                  </a:txBody>
-                  <a:tcPr marL="54864" marR="54864" marT="54864" marB="54864" anchor="ctr">
-                    <a:lnL w="9525" cap="flat" cmpd="sng" algn="ctr">
-                      <a:solidFill>
-                        <a:srgbClr val="E5E7EB"/>
-                      </a:solidFill>
-                      <a:prstDash val="solid"/>
-                      <a:round/>
-                      <a:headEnd type="none" w="med" len="med"/>
-                      <a:tailEnd type="none" w="med" len="med"/>
-                    </a:lnL>
-                    <a:lnR w="9525" cap="flat" cmpd="sng" algn="ctr">
-                      <a:solidFill>
-                        <a:srgbClr val="E5E7EB"/>
-                      </a:solidFill>
-                      <a:prstDash val="solid"/>
-                      <a:round/>
-                      <a:headEnd type="none" w="med" len="med"/>
-                      <a:tailEnd type="none" w="med" len="med"/>
-                    </a:lnR>
-                    <a:lnT w="9525" cap="flat" cmpd="sng" algn="ctr">
-                      <a:solidFill>
-                        <a:srgbClr val="E5E7EB"/>
-                      </a:solidFill>
-                      <a:prstDash val="solid"/>
-                      <a:round/>
-                      <a:headEnd type="none" w="med" len="med"/>
-                      <a:tailEnd type="none" w="med" len="med"/>
-                    </a:lnT>
-                    <a:lnB w="9525" cap="flat" cmpd="sng" algn="ctr">
-                      <a:solidFill>
-                        <a:srgbClr val="E5E7EB"/>
-                      </a:solidFill>
-                      <a:prstDash val="solid"/>
-                      <a:round/>
-                      <a:headEnd type="none" w="med" len="med"/>
-                      <a:tailEnd type="none" w="med" len="med"/>
-                    </a:lnB>
-                    <a:solidFill>
-                      <a:schemeClr val="bg1"/>
-                    </a:solidFill>
-                  </a:tcPr>
-                </a:tc>
-                <a:tc>
-                  <a:txBody>
-                    <a:bodyPr/>
-                    <a:lstStyle/>
-                    <a:p>
-                      <a:pPr indent="0" marL="0">
-                        <a:buNone/>
-                      </a:pPr>
-                      <a:r>
-                        <a:rPr lang="en-US" sz="1200" dirty="0">
-                          <a:solidFill>
-                            <a:schemeClr val="tx1"/>
-                          </a:solidFill>
-                        </a:rPr>
-                        <a:t>22 g</a:t>
-                      </a:r>
-                      <a:endParaRPr lang="en-US" sz="1200" dirty="0"/>
-                    </a:p>
-                  </a:txBody>
-                  <a:tcPr marL="54864" marR="54864" marT="54864" marB="54864" anchor="ctr">
-                    <a:lnL w="9525" cap="flat" cmpd="sng" algn="ctr">
-                      <a:solidFill>
-                        <a:srgbClr val="E5E7EB"/>
-                      </a:solidFill>
-                      <a:prstDash val="solid"/>
-                      <a:round/>
-                      <a:headEnd type="none" w="med" len="med"/>
-                      <a:tailEnd type="none" w="med" len="med"/>
-                    </a:lnL>
-                    <a:lnR w="9525" cap="flat" cmpd="sng" algn="ctr">
-                      <a:solidFill>
-                        <a:srgbClr val="E5E7EB"/>
-                      </a:solidFill>
-                      <a:prstDash val="solid"/>
-                      <a:round/>
-                      <a:headEnd type="none" w="med" len="med"/>
-                      <a:tailEnd type="none" w="med" len="med"/>
-                    </a:lnR>
-                    <a:lnT w="9525" cap="flat" cmpd="sng" algn="ctr">
-                      <a:solidFill>
-                        <a:srgbClr val="E5E7EB"/>
-                      </a:solidFill>
-                      <a:prstDash val="solid"/>
-                      <a:round/>
-                      <a:headEnd type="none" w="med" len="med"/>
-                      <a:tailEnd type="none" w="med" len="med"/>
-                    </a:lnT>
-                    <a:lnB w="9525" cap="flat" cmpd="sng" algn="ctr">
-                      <a:solidFill>
-                        <a:srgbClr val="E5E7EB"/>
-                      </a:solidFill>
-                      <a:prstDash val="solid"/>
-                      <a:round/>
-                      <a:headEnd type="none" w="med" len="med"/>
-                      <a:tailEnd type="none" w="med" len="med"/>
-                    </a:lnB>
-                    <a:solidFill>
-                      <a:schemeClr val="bg1"/>
-                    </a:solidFill>
-                  </a:tcPr>
-                </a:tc>
-                <a:tc>
-                  <a:txBody>
-                    <a:bodyPr/>
-                    <a:lstStyle/>
-                    <a:p>
-                      <a:pPr indent="0" marL="0">
-                        <a:buNone/>
-                      </a:pPr>
-                      <a:r>
-                        <a:rPr lang="en-US" sz="1200" dirty="0">
-                          <a:solidFill>
-                            <a:schemeClr val="tx1"/>
-                          </a:solidFill>
-                        </a:rPr>
-                        <a:t>32 g</a:t>
-                      </a:r>
-                      <a:endParaRPr lang="en-US" sz="1200" dirty="0"/>
-                    </a:p>
-                  </a:txBody>
-                  <a:tcPr marL="54864" marR="54864" marT="54864" marB="54864" anchor="ctr">
-                    <a:lnL w="9525" cap="flat" cmpd="sng" algn="ctr">
-                      <a:solidFill>
-                        <a:srgbClr val="E5E7EB"/>
-                      </a:solidFill>
-                      <a:prstDash val="solid"/>
-                      <a:round/>
-                      <a:headEnd type="none" w="med" len="med"/>
-                      <a:tailEnd type="none" w="med" len="med"/>
-                    </a:lnL>
-                    <a:lnR w="9525" cap="flat" cmpd="sng" algn="ctr">
-                      <a:solidFill>
-                        <a:srgbClr val="E5E7EB"/>
-                      </a:solidFill>
-                      <a:prstDash val="solid"/>
-                      <a:round/>
-                      <a:headEnd type="none" w="med" len="med"/>
-                      <a:tailEnd type="none" w="med" len="med"/>
-                    </a:lnR>
-                    <a:lnT w="9525" cap="flat" cmpd="sng" algn="ctr">
-                      <a:solidFill>
-                        <a:srgbClr val="E5E7EB"/>
-                      </a:solidFill>
-                      <a:prstDash val="solid"/>
-                      <a:round/>
-                      <a:headEnd type="none" w="med" len="med"/>
-                      <a:tailEnd type="none" w="med" len="med"/>
-                    </a:lnT>
-                    <a:lnB w="9525" cap="flat" cmpd="sng" algn="ctr">
-                      <a:solidFill>
-                        <a:srgbClr val="E5E7EB"/>
-                      </a:solidFill>
-                      <a:prstDash val="solid"/>
-                      <a:round/>
-                      <a:headEnd type="none" w="med" len="med"/>
-                      <a:tailEnd type="none" w="med" len="med"/>
-                    </a:lnB>
-                    <a:solidFill>
-                      <a:schemeClr val="bg1"/>
-                    </a:solidFill>
-                  </a:tcPr>
-                </a:tc>
-                <a:tc>
-                  <a:txBody>
-                    <a:bodyPr/>
-                    <a:lstStyle/>
-                    <a:p>
-                      <a:pPr indent="0" marL="0">
-                        <a:buNone/>
-                      </a:pPr>
-                      <a:r>
-                        <a:rPr lang="en-US" sz="1200" dirty="0">
-                          <a:solidFill>
-                            <a:schemeClr val="tx1"/>
-                          </a:solidFill>
-                        </a:rPr>
-                        <a:t>n/p</a:t>
-                      </a:r>
-                      <a:endParaRPr lang="en-US" sz="1200" dirty="0"/>
-                    </a:p>
-                  </a:txBody>
-                  <a:tcPr marL="54864" marR="54864" marT="54864" marB="54864" anchor="ctr">
-                    <a:lnL w="9525" cap="flat" cmpd="sng" algn="ctr">
-                      <a:solidFill>
-                        <a:srgbClr val="E5E7EB"/>
-                      </a:solidFill>
-                      <a:prstDash val="solid"/>
-                      <a:round/>
-                      <a:headEnd type="none" w="med" len="med"/>
-                      <a:tailEnd type="none" w="med" len="med"/>
-                    </a:lnL>
-                    <a:lnR w="9525" cap="flat" cmpd="sng" algn="ctr">
-                      <a:solidFill>
-                        <a:srgbClr val="E5E7EB"/>
-                      </a:solidFill>
-                      <a:prstDash val="solid"/>
-                      <a:round/>
-                      <a:headEnd type="none" w="med" len="med"/>
-                      <a:tailEnd type="none" w="med" len="med"/>
-                    </a:lnR>
-                    <a:lnT w="9525" cap="flat" cmpd="sng" algn="ctr">
-                      <a:solidFill>
-                        <a:srgbClr val="E5E7EB"/>
-                      </a:solidFill>
-                      <a:prstDash val="solid"/>
-                      <a:round/>
-                      <a:headEnd type="none" w="med" len="med"/>
-                      <a:tailEnd type="none" w="med" len="med"/>
-                    </a:lnT>
-                    <a:lnB w="9525" cap="flat" cmpd="sng" algn="ctr">
-                      <a:solidFill>
-                        <a:srgbClr val="E5E7EB"/>
-                      </a:solidFill>
-                      <a:prstDash val="solid"/>
-                      <a:round/>
-                      <a:headEnd type="none" w="med" len="med"/>
-                      <a:tailEnd type="none" w="med" len="med"/>
-                    </a:lnB>
-                    <a:solidFill>
-                      <a:schemeClr val="bg1"/>
-                    </a:solidFill>
-                  </a:tcPr>
-                </a:tc>
-                <a:tc>
-                  <a:txBody>
-                    <a:bodyPr/>
-                    <a:lstStyle/>
-                    <a:p>
-                      <a:pPr indent="0" marL="0">
-                        <a:buNone/>
-                      </a:pPr>
-                      <a:r>
-                        <a:rPr lang="en-US" sz="1200" dirty="0">
-                          <a:solidFill>
-                            <a:schemeClr val="tx1"/>
-                          </a:solidFill>
-                        </a:rPr>
-                        <a:t>Maltitol (1st ingredient), whey, glycerol</a:t>
-                      </a:r>
-                      <a:endParaRPr lang="en-US" sz="1200" dirty="0"/>
-                    </a:p>
-                  </a:txBody>
-                  <a:tcPr marL="54864" marR="54864" marT="54864" marB="54864" anchor="ctr">
-                    <a:lnL w="9525" cap="flat" cmpd="sng" algn="ctr">
-                      <a:solidFill>
-                        <a:srgbClr val="E5E7EB"/>
-                      </a:solidFill>
-                      <a:prstDash val="solid"/>
-                      <a:round/>
-                      <a:headEnd type="none" w="med" len="med"/>
-                      <a:tailEnd type="none" w="med" len="med"/>
-                    </a:lnL>
-                    <a:lnR w="9525" cap="flat" cmpd="sng" algn="ctr">
-                      <a:solidFill>
-                        <a:srgbClr val="E5E7EB"/>
-                      </a:solidFill>
-                      <a:prstDash val="solid"/>
-                      <a:round/>
-                      <a:headEnd type="none" w="med" len="med"/>
-                      <a:tailEnd type="none" w="med" len="med"/>
-                    </a:lnR>
-                    <a:lnT w="9525" cap="flat" cmpd="sng" algn="ctr">
-                      <a:solidFill>
-                        <a:srgbClr val="E5E7EB"/>
-                      </a:solidFill>
-                      <a:prstDash val="solid"/>
-                      <a:round/>
-                      <a:headEnd type="none" w="med" len="med"/>
-                      <a:tailEnd type="none" w="med" len="med"/>
-                    </a:lnT>
-                    <a:lnB w="9525" cap="flat" cmpd="sng" algn="ctr">
-                      <a:solidFill>
-                        <a:srgbClr val="E5E7EB"/>
-                      </a:solidFill>
-                      <a:prstDash val="solid"/>
-                      <a:round/>
-                      <a:headEnd type="none" w="med" len="med"/>
-                      <a:tailEnd type="none" w="med" len="med"/>
-                    </a:lnB>
-                    <a:solidFill>
-                      <a:schemeClr val="bg1"/>
-                    </a:solidFill>
-                  </a:tcPr>
-                </a:tc>
-              </a:tr>
-              <a:tr h="475488">
-                <a:tc>
-                  <a:txBody>
-                    <a:bodyPr/>
-                    <a:lstStyle/>
-                    <a:p>
-                      <a:pPr indent="0" marL="0">
-                        <a:buNone/>
-                      </a:pPr>
-                      <a:r>
-                        <a:rPr lang="en-US" sz="1200" dirty="0">
-                          <a:solidFill>
-                            <a:schemeClr val="tx1"/>
-                          </a:solidFill>
-                        </a:rPr>
-                        <a:t>Amacx Recovery (55 g, XMiles)</a:t>
-                      </a:r>
-                      <a:endParaRPr lang="en-US" sz="1200" dirty="0"/>
-                    </a:p>
-                  </a:txBody>
-                  <a:tcPr marL="54864" marR="54864" marT="54864" marB="54864" anchor="ctr">
-                    <a:lnL w="9525" cap="flat" cmpd="sng" algn="ctr">
-                      <a:solidFill>
-                        <a:srgbClr val="E5E7EB"/>
-                      </a:solidFill>
-                      <a:prstDash val="solid"/>
-                      <a:round/>
-                      <a:headEnd type="none" w="med" len="med"/>
-                      <a:tailEnd type="none" w="med" len="med"/>
-                    </a:lnL>
-                    <a:lnR w="9525" cap="flat" cmpd="sng" algn="ctr">
-                      <a:solidFill>
-                        <a:srgbClr val="E5E7EB"/>
-                      </a:solidFill>
-                      <a:prstDash val="solid"/>
-                      <a:round/>
-                      <a:headEnd type="none" w="med" len="med"/>
-                      <a:tailEnd type="none" w="med" len="med"/>
-                    </a:lnR>
-                    <a:lnT w="9525" cap="flat" cmpd="sng" algn="ctr">
-                      <a:solidFill>
-                        <a:srgbClr val="E5E7EB"/>
-                      </a:solidFill>
-                      <a:prstDash val="solid"/>
-                      <a:round/>
-                      <a:headEnd type="none" w="med" len="med"/>
-                      <a:tailEnd type="none" w="med" len="med"/>
-                    </a:lnT>
-                    <a:lnB w="9525" cap="flat" cmpd="sng" algn="ctr">
-                      <a:solidFill>
-                        <a:srgbClr val="E5E7EB"/>
-                      </a:solidFill>
-                      <a:prstDash val="solid"/>
-                      <a:round/>
-                      <a:headEnd type="none" w="med" len="med"/>
-                      <a:tailEnd type="none" w="med" len="med"/>
-                    </a:lnB>
-                    <a:solidFill>
-                      <a:schemeClr val="bg1"/>
-                    </a:solidFill>
-                  </a:tcPr>
-                </a:tc>
-                <a:tc>
-                  <a:txBody>
-                    <a:bodyPr/>
-                    <a:lstStyle/>
-                    <a:p>
-                      <a:pPr indent="0" marL="0">
-                        <a:buNone/>
-                      </a:pPr>
-                      <a:r>
-                        <a:rPr lang="en-US" sz="1200" dirty="0">
-                          <a:solidFill>
-                            <a:schemeClr val="tx1"/>
-                          </a:solidFill>
-                        </a:rPr>
-                        <a:t>20 g</a:t>
-                      </a:r>
-                      <a:endParaRPr lang="en-US" sz="1200" dirty="0"/>
-                    </a:p>
-                  </a:txBody>
-                  <a:tcPr marL="54864" marR="54864" marT="54864" marB="54864" anchor="ctr">
-                    <a:lnL w="9525" cap="flat" cmpd="sng" algn="ctr">
-                      <a:solidFill>
-                        <a:srgbClr val="E5E7EB"/>
-                      </a:solidFill>
-                      <a:prstDash val="solid"/>
-                      <a:round/>
-                      <a:headEnd type="none" w="med" len="med"/>
-                      <a:tailEnd type="none" w="med" len="med"/>
-                    </a:lnL>
-                    <a:lnR w="9525" cap="flat" cmpd="sng" algn="ctr">
-                      <a:solidFill>
-                        <a:srgbClr val="E5E7EB"/>
-                      </a:solidFill>
-                      <a:prstDash val="solid"/>
-                      <a:round/>
-                      <a:headEnd type="none" w="med" len="med"/>
-                      <a:tailEnd type="none" w="med" len="med"/>
-                    </a:lnR>
-                    <a:lnT w="9525" cap="flat" cmpd="sng" algn="ctr">
-                      <a:solidFill>
-                        <a:srgbClr val="E5E7EB"/>
-                      </a:solidFill>
-                      <a:prstDash val="solid"/>
-                      <a:round/>
-                      <a:headEnd type="none" w="med" len="med"/>
-                      <a:tailEnd type="none" w="med" len="med"/>
-                    </a:lnT>
-                    <a:lnB w="9525" cap="flat" cmpd="sng" algn="ctr">
-                      <a:solidFill>
-                        <a:srgbClr val="E5E7EB"/>
-                      </a:solidFill>
-                      <a:prstDash val="solid"/>
-                      <a:round/>
-                      <a:headEnd type="none" w="med" len="med"/>
-                      <a:tailEnd type="none" w="med" len="med"/>
-                    </a:lnB>
-                    <a:solidFill>
-                      <a:schemeClr val="bg1"/>
-                    </a:solidFill>
-                  </a:tcPr>
-                </a:tc>
-                <a:tc>
-                  <a:txBody>
-                    <a:bodyPr/>
-                    <a:lstStyle/>
-                    <a:p>
-                      <a:pPr indent="0" marL="0">
-                        <a:buNone/>
-                      </a:pPr>
-                      <a:r>
-                        <a:rPr lang="en-US" sz="1200" dirty="0">
-                          <a:solidFill>
-                            <a:schemeClr val="tx1"/>
-                          </a:solidFill>
-                        </a:rPr>
-                        <a:t>22 g</a:t>
-                      </a:r>
-                      <a:endParaRPr lang="en-US" sz="1200" dirty="0"/>
-                    </a:p>
-                  </a:txBody>
-                  <a:tcPr marL="54864" marR="54864" marT="54864" marB="54864" anchor="ctr">
-                    <a:lnL w="9525" cap="flat" cmpd="sng" algn="ctr">
-                      <a:solidFill>
-                        <a:srgbClr val="E5E7EB"/>
-                      </a:solidFill>
-                      <a:prstDash val="solid"/>
-                      <a:round/>
-                      <a:headEnd type="none" w="med" len="med"/>
-                      <a:tailEnd type="none" w="med" len="med"/>
-                    </a:lnL>
-                    <a:lnR w="9525" cap="flat" cmpd="sng" algn="ctr">
-                      <a:solidFill>
-                        <a:srgbClr val="E5E7EB"/>
-                      </a:solidFill>
-                      <a:prstDash val="solid"/>
-                      <a:round/>
-                      <a:headEnd type="none" w="med" len="med"/>
-                      <a:tailEnd type="none" w="med" len="med"/>
-                    </a:lnR>
-                    <a:lnT w="9525" cap="flat" cmpd="sng" algn="ctr">
-                      <a:solidFill>
-                        <a:srgbClr val="E5E7EB"/>
-                      </a:solidFill>
-                      <a:prstDash val="solid"/>
-                      <a:round/>
-                      <a:headEnd type="none" w="med" len="med"/>
-                      <a:tailEnd type="none" w="med" len="med"/>
-                    </a:lnT>
-                    <a:lnB w="9525" cap="flat" cmpd="sng" algn="ctr">
-                      <a:solidFill>
-                        <a:srgbClr val="E5E7EB"/>
-                      </a:solidFill>
-                      <a:prstDash val="solid"/>
-                      <a:round/>
-                      <a:headEnd type="none" w="med" len="med"/>
-                      <a:tailEnd type="none" w="med" len="med"/>
-                    </a:lnB>
-                    <a:solidFill>
-                      <a:schemeClr val="bg1"/>
-                    </a:solidFill>
-                  </a:tcPr>
-                </a:tc>
-                <a:tc>
-                  <a:txBody>
-                    <a:bodyPr/>
-                    <a:lstStyle/>
-                    <a:p>
-                      <a:pPr indent="0" marL="0">
-                        <a:buNone/>
-                      </a:pPr>
-                      <a:r>
-                        <a:rPr lang="en-US" sz="1200" dirty="0">
-                          <a:solidFill>
-                            <a:schemeClr val="tx1"/>
-                          </a:solidFill>
-                        </a:rPr>
-                        <a:t>n/p</a:t>
-                      </a:r>
-                      <a:endParaRPr lang="en-US" sz="1200" dirty="0"/>
-                    </a:p>
-                  </a:txBody>
-                  <a:tcPr marL="54864" marR="54864" marT="54864" marB="54864" anchor="ctr">
-                    <a:lnL w="9525" cap="flat" cmpd="sng" algn="ctr">
-                      <a:solidFill>
-                        <a:srgbClr val="E5E7EB"/>
-                      </a:solidFill>
-                      <a:prstDash val="solid"/>
-                      <a:round/>
-                      <a:headEnd type="none" w="med" len="med"/>
-                      <a:tailEnd type="none" w="med" len="med"/>
-                    </a:lnL>
-                    <a:lnR w="9525" cap="flat" cmpd="sng" algn="ctr">
-                      <a:solidFill>
-                        <a:srgbClr val="E5E7EB"/>
-                      </a:solidFill>
-                      <a:prstDash val="solid"/>
-                      <a:round/>
-                      <a:headEnd type="none" w="med" len="med"/>
-                      <a:tailEnd type="none" w="med" len="med"/>
-                    </a:lnR>
-                    <a:lnT w="9525" cap="flat" cmpd="sng" algn="ctr">
-                      <a:solidFill>
-                        <a:srgbClr val="E5E7EB"/>
-                      </a:solidFill>
-                      <a:prstDash val="solid"/>
-                      <a:round/>
-                      <a:headEnd type="none" w="med" len="med"/>
-                      <a:tailEnd type="none" w="med" len="med"/>
-                    </a:lnT>
-                    <a:lnB w="9525" cap="flat" cmpd="sng" algn="ctr">
-                      <a:solidFill>
-                        <a:srgbClr val="E5E7EB"/>
-                      </a:solidFill>
-                      <a:prstDash val="solid"/>
-                      <a:round/>
-                      <a:headEnd type="none" w="med" len="med"/>
-                      <a:tailEnd type="none" w="med" len="med"/>
-                    </a:lnB>
-                    <a:solidFill>
-                      <a:schemeClr val="bg1"/>
-                    </a:solidFill>
-                  </a:tcPr>
-                </a:tc>
-                <a:tc>
-                  <a:txBody>
-                    <a:bodyPr/>
-                    <a:lstStyle/>
-                    <a:p>
-                      <a:pPr indent="0" marL="0">
-                        <a:buNone/>
-                      </a:pPr>
-                      <a:r>
-                        <a:rPr lang="en-US" sz="1200" dirty="0">
-                          <a:solidFill>
-                            <a:schemeClr val="tx1"/>
-                          </a:solidFill>
-                        </a:rPr>
-                        <a:t>Soy/whey/milk protein mix, glucose-fructose syrup</a:t>
-                      </a:r>
-                      <a:endParaRPr lang="en-US" sz="1200" dirty="0"/>
-                    </a:p>
-                  </a:txBody>
-                  <a:tcPr marL="54864" marR="54864" marT="54864" marB="54864" anchor="ctr">
-                    <a:lnL w="9525" cap="flat" cmpd="sng" algn="ctr">
-                      <a:solidFill>
-                        <a:srgbClr val="E5E7EB"/>
-                      </a:solidFill>
-                      <a:prstDash val="solid"/>
-                      <a:round/>
-                      <a:headEnd type="none" w="med" len="med"/>
-                      <a:tailEnd type="none" w="med" len="med"/>
-                    </a:lnL>
-                    <a:lnR w="9525" cap="flat" cmpd="sng" algn="ctr">
-                      <a:solidFill>
-                        <a:srgbClr val="E5E7EB"/>
-                      </a:solidFill>
-                      <a:prstDash val="solid"/>
-                      <a:round/>
-                      <a:headEnd type="none" w="med" len="med"/>
-                      <a:tailEnd type="none" w="med" len="med"/>
-                    </a:lnR>
-                    <a:lnT w="9525" cap="flat" cmpd="sng" algn="ctr">
-                      <a:solidFill>
-                        <a:srgbClr val="E5E7EB"/>
-                      </a:solidFill>
-                      <a:prstDash val="solid"/>
-                      <a:round/>
-                      <a:headEnd type="none" w="med" len="med"/>
-                      <a:tailEnd type="none" w="med" len="med"/>
-                    </a:lnT>
-                    <a:lnB w="9525" cap="flat" cmpd="sng" algn="ctr">
-                      <a:solidFill>
-                        <a:srgbClr val="E5E7EB"/>
-                      </a:solidFill>
-                      <a:prstDash val="solid"/>
-                      <a:round/>
-                      <a:headEnd type="none" w="med" len="med"/>
-                      <a:tailEnd type="none" w="med" len="med"/>
-                    </a:lnB>
-                    <a:solidFill>
-                      <a:schemeClr val="bg1"/>
-                    </a:solidFill>
-                  </a:tcPr>
-                </a:tc>
-              </a:tr>
-              <a:tr h="475488">
-                <a:tc>
-                  <a:txBody>
-                    <a:bodyPr/>
-                    <a:lstStyle/>
-                    <a:p>
-                      <a:pPr indent="0" marL="0">
-                        <a:buNone/>
-                      </a:pPr>
-                      <a:r>
-                        <a:rPr lang="en-US" sz="1200" dirty="0">
-                          <a:solidFill>
-                            <a:schemeClr val="tx1"/>
-                          </a:solidFill>
-                        </a:rPr>
-                        <a:t>HIGH5 Recovery Protein (50 g)</a:t>
-                      </a:r>
-                      <a:endParaRPr lang="en-US" sz="1200" dirty="0"/>
-                    </a:p>
-                  </a:txBody>
-                  <a:tcPr marL="54864" marR="54864" marT="54864" marB="54864" anchor="ctr">
-                    <a:lnL w="9525" cap="flat" cmpd="sng" algn="ctr">
-                      <a:solidFill>
-                        <a:srgbClr val="E5E7EB"/>
-                      </a:solidFill>
-                      <a:prstDash val="solid"/>
-                      <a:round/>
-                      <a:headEnd type="none" w="med" len="med"/>
-                      <a:tailEnd type="none" w="med" len="med"/>
-                    </a:lnL>
-                    <a:lnR w="9525" cap="flat" cmpd="sng" algn="ctr">
-                      <a:solidFill>
-                        <a:srgbClr val="E5E7EB"/>
-                      </a:solidFill>
-                      <a:prstDash val="solid"/>
-                      <a:round/>
-                      <a:headEnd type="none" w="med" len="med"/>
-                      <a:tailEnd type="none" w="med" len="med"/>
-                    </a:lnR>
-                    <a:lnT w="9525" cap="flat" cmpd="sng" algn="ctr">
-                      <a:solidFill>
-                        <a:srgbClr val="E5E7EB"/>
-                      </a:solidFill>
-                      <a:prstDash val="solid"/>
-                      <a:round/>
-                      <a:headEnd type="none" w="med" len="med"/>
-                      <a:tailEnd type="none" w="med" len="med"/>
-                    </a:lnT>
-                    <a:lnB w="9525" cap="flat" cmpd="sng" algn="ctr">
-                      <a:solidFill>
-                        <a:srgbClr val="E5E7EB"/>
-                      </a:solidFill>
-                      <a:prstDash val="solid"/>
-                      <a:round/>
-                      <a:headEnd type="none" w="med" len="med"/>
-                      <a:tailEnd type="none" w="med" len="med"/>
-                    </a:lnB>
-                    <a:solidFill>
-                      <a:schemeClr val="bg1"/>
-                    </a:solidFill>
-                  </a:tcPr>
-                </a:tc>
-                <a:tc>
-                  <a:txBody>
-                    <a:bodyPr/>
-                    <a:lstStyle/>
-                    <a:p>
-                      <a:pPr indent="0" marL="0">
-                        <a:buNone/>
-                      </a:pPr>
-                      <a:r>
-                        <a:rPr lang="en-US" sz="1200" dirty="0">
-                          <a:solidFill>
-                            <a:schemeClr val="tx1"/>
-                          </a:solidFill>
-                        </a:rPr>
-                        <a:t>19 g</a:t>
-                      </a:r>
-                      <a:endParaRPr lang="en-US" sz="1200" dirty="0"/>
-                    </a:p>
-                  </a:txBody>
-                  <a:tcPr marL="54864" marR="54864" marT="54864" marB="54864" anchor="ctr">
-                    <a:lnL w="9525" cap="flat" cmpd="sng" algn="ctr">
-                      <a:solidFill>
-                        <a:srgbClr val="E5E7EB"/>
-                      </a:solidFill>
-                      <a:prstDash val="solid"/>
-                      <a:round/>
-                      <a:headEnd type="none" w="med" len="med"/>
-                      <a:tailEnd type="none" w="med" len="med"/>
-                    </a:lnL>
-                    <a:lnR w="9525" cap="flat" cmpd="sng" algn="ctr">
-                      <a:solidFill>
-                        <a:srgbClr val="E5E7EB"/>
-                      </a:solidFill>
-                      <a:prstDash val="solid"/>
-                      <a:round/>
-                      <a:headEnd type="none" w="med" len="med"/>
-                      <a:tailEnd type="none" w="med" len="med"/>
-                    </a:lnR>
-                    <a:lnT w="9525" cap="flat" cmpd="sng" algn="ctr">
-                      <a:solidFill>
-                        <a:srgbClr val="E5E7EB"/>
-                      </a:solidFill>
-                      <a:prstDash val="solid"/>
-                      <a:round/>
-                      <a:headEnd type="none" w="med" len="med"/>
-                      <a:tailEnd type="none" w="med" len="med"/>
-                    </a:lnT>
-                    <a:lnB w="9525" cap="flat" cmpd="sng" algn="ctr">
-                      <a:solidFill>
-                        <a:srgbClr val="E5E7EB"/>
-                      </a:solidFill>
-                      <a:prstDash val="solid"/>
-                      <a:round/>
-                      <a:headEnd type="none" w="med" len="med"/>
-                      <a:tailEnd type="none" w="med" len="med"/>
-                    </a:lnB>
-                    <a:solidFill>
-                      <a:schemeClr val="bg1"/>
-                    </a:solidFill>
-                  </a:tcPr>
-                </a:tc>
-                <a:tc>
-                  <a:txBody>
-                    <a:bodyPr/>
-                    <a:lstStyle/>
-                    <a:p>
-                      <a:pPr indent="0" marL="0">
-                        <a:buNone/>
-                      </a:pPr>
-                      <a:r>
-                        <a:rPr lang="en-US" sz="1200" dirty="0">
-                          <a:solidFill>
-                            <a:schemeClr val="tx1"/>
-                          </a:solidFill>
-                        </a:rPr>
-                        <a:t>19 g</a:t>
-                      </a:r>
-                      <a:endParaRPr lang="en-US" sz="1200" dirty="0"/>
-                    </a:p>
-                  </a:txBody>
-                  <a:tcPr marL="54864" marR="54864" marT="54864" marB="54864" anchor="ctr">
-                    <a:lnL w="9525" cap="flat" cmpd="sng" algn="ctr">
-                      <a:solidFill>
-                        <a:srgbClr val="E5E7EB"/>
-                      </a:solidFill>
-                      <a:prstDash val="solid"/>
-                      <a:round/>
-                      <a:headEnd type="none" w="med" len="med"/>
-                      <a:tailEnd type="none" w="med" len="med"/>
-                    </a:lnL>
-                    <a:lnR w="9525" cap="flat" cmpd="sng" algn="ctr">
-                      <a:solidFill>
-                        <a:srgbClr val="E5E7EB"/>
-                      </a:solidFill>
-                      <a:prstDash val="solid"/>
-                      <a:round/>
-                      <a:headEnd type="none" w="med" len="med"/>
-                      <a:tailEnd type="none" w="med" len="med"/>
-                    </a:lnR>
-                    <a:lnT w="9525" cap="flat" cmpd="sng" algn="ctr">
-                      <a:solidFill>
-                        <a:srgbClr val="E5E7EB"/>
-                      </a:solidFill>
-                      <a:prstDash val="solid"/>
-                      <a:round/>
-                      <a:headEnd type="none" w="med" len="med"/>
-                      <a:tailEnd type="none" w="med" len="med"/>
-                    </a:lnT>
-                    <a:lnB w="9525" cap="flat" cmpd="sng" algn="ctr">
-                      <a:solidFill>
-                        <a:srgbClr val="E5E7EB"/>
-                      </a:solidFill>
-                      <a:prstDash val="solid"/>
-                      <a:round/>
-                      <a:headEnd type="none" w="med" len="med"/>
-                      <a:tailEnd type="none" w="med" len="med"/>
-                    </a:lnB>
-                    <a:solidFill>
-                      <a:schemeClr val="bg1"/>
-                    </a:solidFill>
-                  </a:tcPr>
-                </a:tc>
-                <a:tc>
-                  <a:txBody>
-                    <a:bodyPr/>
-                    <a:lstStyle/>
-                    <a:p>
-                      <a:pPr indent="0" marL="0">
-                        <a:buNone/>
-                      </a:pPr>
-                      <a:r>
-                        <a:rPr lang="en-US" sz="1200" dirty="0">
-                          <a:solidFill>
-                            <a:schemeClr val="tx1"/>
-                          </a:solidFill>
-                        </a:rPr>
-                        <a:t>n/p</a:t>
-                      </a:r>
-                      <a:endParaRPr lang="en-US" sz="1200" dirty="0"/>
-                    </a:p>
-                  </a:txBody>
-                  <a:tcPr marL="54864" marR="54864" marT="54864" marB="54864" anchor="ctr">
-                    <a:lnL w="9525" cap="flat" cmpd="sng" algn="ctr">
-                      <a:solidFill>
-                        <a:srgbClr val="E5E7EB"/>
-                      </a:solidFill>
-                      <a:prstDash val="solid"/>
-                      <a:round/>
-                      <a:headEnd type="none" w="med" len="med"/>
-                      <a:tailEnd type="none" w="med" len="med"/>
-                    </a:lnL>
-                    <a:lnR w="9525" cap="flat" cmpd="sng" algn="ctr">
-                      <a:solidFill>
-                        <a:srgbClr val="E5E7EB"/>
-                      </a:solidFill>
-                      <a:prstDash val="solid"/>
-                      <a:round/>
-                      <a:headEnd type="none" w="med" len="med"/>
-                      <a:tailEnd type="none" w="med" len="med"/>
-                    </a:lnR>
-                    <a:lnT w="9525" cap="flat" cmpd="sng" algn="ctr">
-                      <a:solidFill>
-                        <a:srgbClr val="E5E7EB"/>
-                      </a:solidFill>
-                      <a:prstDash val="solid"/>
-                      <a:round/>
-                      <a:headEnd type="none" w="med" len="med"/>
-                      <a:tailEnd type="none" w="med" len="med"/>
-                    </a:lnT>
-                    <a:lnB w="9525" cap="flat" cmpd="sng" algn="ctr">
-                      <a:solidFill>
-                        <a:srgbClr val="E5E7EB"/>
-                      </a:solidFill>
-                      <a:prstDash val="solid"/>
-                      <a:round/>
-                      <a:headEnd type="none" w="med" len="med"/>
-                      <a:tailEnd type="none" w="med" len="med"/>
-                    </a:lnB>
-                    <a:solidFill>
-                      <a:schemeClr val="bg1"/>
-                    </a:solidFill>
-                  </a:tcPr>
-                </a:tc>
-                <a:tc>
-                  <a:txBody>
-                    <a:bodyPr/>
-                    <a:lstStyle/>
-                    <a:p>
-                      <a:pPr indent="0" marL="0">
-                        <a:buNone/>
-                      </a:pPr>
-                      <a:r>
-                        <a:rPr lang="en-US" sz="1200" dirty="0">
-                          <a:solidFill>
-                            <a:schemeClr val="tx1"/>
-                          </a:solidFill>
-                        </a:rPr>
-                        <a:t>Glucose syrup, invert sugar, sugar, milk &amp; soy protein</a:t>
-                      </a:r>
-                      <a:endParaRPr lang="en-US" sz="1200" dirty="0"/>
-                    </a:p>
-                  </a:txBody>
-                  <a:tcPr marL="54864" marR="54864" marT="54864" marB="54864" anchor="ctr">
-                    <a:lnL w="9525" cap="flat" cmpd="sng" algn="ctr">
-                      <a:solidFill>
-                        <a:srgbClr val="E5E7EB"/>
-                      </a:solidFill>
-                      <a:prstDash val="solid"/>
-                      <a:round/>
-                      <a:headEnd type="none" w="med" len="med"/>
-                      <a:tailEnd type="none" w="med" len="med"/>
-                    </a:lnL>
-                    <a:lnR w="9525" cap="flat" cmpd="sng" algn="ctr">
-                      <a:solidFill>
-                        <a:srgbClr val="E5E7EB"/>
-                      </a:solidFill>
-                      <a:prstDash val="solid"/>
-                      <a:round/>
-                      <a:headEnd type="none" w="med" len="med"/>
-                      <a:tailEnd type="none" w="med" len="med"/>
-                    </a:lnR>
-                    <a:lnT w="9525" cap="flat" cmpd="sng" algn="ctr">
-                      <a:solidFill>
-                        <a:srgbClr val="E5E7EB"/>
-                      </a:solidFill>
-                      <a:prstDash val="solid"/>
-                      <a:round/>
-                      <a:headEnd type="none" w="med" len="med"/>
-                      <a:tailEnd type="none" w="med" len="med"/>
-                    </a:lnT>
-                    <a:lnB w="9525" cap="flat" cmpd="sng" algn="ctr">
-                      <a:solidFill>
-                        <a:srgbClr val="E5E7EB"/>
-                      </a:solidFill>
-                      <a:prstDash val="solid"/>
-                      <a:round/>
-                      <a:headEnd type="none" w="med" len="med"/>
-                      <a:tailEnd type="none" w="med" len="med"/>
-                    </a:lnB>
-                    <a:solidFill>
-                      <a:schemeClr val="bg1"/>
-                    </a:solidFill>
-                  </a:tcPr>
-                </a:tc>
-              </a:tr>
-              <a:tr h="475488">
-                <a:tc>
-                  <a:txBody>
-                    <a:bodyPr/>
-                    <a:lstStyle/>
-                    <a:p>
-                      <a:pPr indent="0" marL="0">
-                        <a:buNone/>
-                      </a:pPr>
-                      <a:r>
-                        <a:rPr lang="en-US" sz="1200" dirty="0">
-                          <a:solidFill>
-                            <a:schemeClr val="tx1"/>
-                          </a:solidFill>
-                        </a:rPr>
-                        <a:t>Styrkr BAR+ Recovery (74 g)</a:t>
-                      </a:r>
-                      <a:endParaRPr lang="en-US" sz="1200" dirty="0"/>
-                    </a:p>
-                  </a:txBody>
-                  <a:tcPr marL="54864" marR="54864" marT="54864" marB="54864" anchor="ctr">
-                    <a:lnL w="9525" cap="flat" cmpd="sng" algn="ctr">
-                      <a:solidFill>
-                        <a:srgbClr val="E5E7EB"/>
-                      </a:solidFill>
-                      <a:prstDash val="solid"/>
-                      <a:round/>
-                      <a:headEnd type="none" w="med" len="med"/>
-                      <a:tailEnd type="none" w="med" len="med"/>
-                    </a:lnL>
-                    <a:lnR w="9525" cap="flat" cmpd="sng" algn="ctr">
-                      <a:solidFill>
-                        <a:srgbClr val="E5E7EB"/>
-                      </a:solidFill>
-                      <a:prstDash val="solid"/>
-                      <a:round/>
-                      <a:headEnd type="none" w="med" len="med"/>
-                      <a:tailEnd type="none" w="med" len="med"/>
-                    </a:lnR>
-                    <a:lnT w="9525" cap="flat" cmpd="sng" algn="ctr">
-                      <a:solidFill>
-                        <a:srgbClr val="E5E7EB"/>
-                      </a:solidFill>
-                      <a:prstDash val="solid"/>
-                      <a:round/>
-                      <a:headEnd type="none" w="med" len="med"/>
-                      <a:tailEnd type="none" w="med" len="med"/>
-                    </a:lnT>
-                    <a:lnB w="9525" cap="flat" cmpd="sng" algn="ctr">
-                      <a:solidFill>
-                        <a:srgbClr val="E5E7EB"/>
-                      </a:solidFill>
-                      <a:prstDash val="solid"/>
-                      <a:round/>
-                      <a:headEnd type="none" w="med" len="med"/>
-                      <a:tailEnd type="none" w="med" len="med"/>
-                    </a:lnB>
-                    <a:solidFill>
-                      <a:schemeClr val="bg1"/>
-                    </a:solidFill>
-                  </a:tcPr>
-                </a:tc>
-                <a:tc>
-                  <a:txBody>
-                    <a:bodyPr/>
-                    <a:lstStyle/>
-                    <a:p>
-                      <a:pPr indent="0" marL="0">
-                        <a:buNone/>
-                      </a:pPr>
-                      <a:r>
-                        <a:rPr lang="en-US" sz="1200" dirty="0">
-                          <a:solidFill>
-                            <a:schemeClr val="tx1"/>
-                          </a:solidFill>
-                        </a:rPr>
-                        <a:t>15 g</a:t>
-                      </a:r>
-                      <a:endParaRPr lang="en-US" sz="1200" dirty="0"/>
-                    </a:p>
-                  </a:txBody>
-                  <a:tcPr marL="54864" marR="54864" marT="54864" marB="54864" anchor="ctr">
-                    <a:lnL w="9525" cap="flat" cmpd="sng" algn="ctr">
-                      <a:solidFill>
-                        <a:srgbClr val="E5E7EB"/>
-                      </a:solidFill>
-                      <a:prstDash val="solid"/>
-                      <a:round/>
-                      <a:headEnd type="none" w="med" len="med"/>
-                      <a:tailEnd type="none" w="med" len="med"/>
-                    </a:lnL>
-                    <a:lnR w="9525" cap="flat" cmpd="sng" algn="ctr">
-                      <a:solidFill>
-                        <a:srgbClr val="E5E7EB"/>
-                      </a:solidFill>
-                      <a:prstDash val="solid"/>
-                      <a:round/>
-                      <a:headEnd type="none" w="med" len="med"/>
-                      <a:tailEnd type="none" w="med" len="med"/>
-                    </a:lnR>
-                    <a:lnT w="9525" cap="flat" cmpd="sng" algn="ctr">
-                      <a:solidFill>
-                        <a:srgbClr val="E5E7EB"/>
-                      </a:solidFill>
-                      <a:prstDash val="solid"/>
-                      <a:round/>
-                      <a:headEnd type="none" w="med" len="med"/>
-                      <a:tailEnd type="none" w="med" len="med"/>
-                    </a:lnT>
-                    <a:lnB w="9525" cap="flat" cmpd="sng" algn="ctr">
-                      <a:solidFill>
-                        <a:srgbClr val="E5E7EB"/>
-                      </a:solidFill>
-                      <a:prstDash val="solid"/>
-                      <a:round/>
-                      <a:headEnd type="none" w="med" len="med"/>
-                      <a:tailEnd type="none" w="med" len="med"/>
-                    </a:lnB>
-                    <a:solidFill>
-                      <a:schemeClr val="bg1"/>
-                    </a:solidFill>
-                  </a:tcPr>
-                </a:tc>
-                <a:tc>
-                  <a:txBody>
-                    <a:bodyPr/>
-                    <a:lstStyle/>
-                    <a:p>
-                      <a:pPr indent="0" marL="0">
-                        <a:buNone/>
-                      </a:pPr>
-                      <a:r>
-                        <a:rPr lang="en-US" sz="1200" dirty="0">
-                          <a:solidFill>
-                            <a:schemeClr val="tx1"/>
-                          </a:solidFill>
-                        </a:rPr>
-                        <a:t>47 g</a:t>
-                      </a:r>
-                      <a:endParaRPr lang="en-US" sz="1200" dirty="0"/>
-                    </a:p>
-                  </a:txBody>
-                  <a:tcPr marL="54864" marR="54864" marT="54864" marB="54864" anchor="ctr">
-                    <a:lnL w="9525" cap="flat" cmpd="sng" algn="ctr">
-                      <a:solidFill>
-                        <a:srgbClr val="E5E7EB"/>
-                      </a:solidFill>
-                      <a:prstDash val="solid"/>
-                      <a:round/>
-                      <a:headEnd type="none" w="med" len="med"/>
-                      <a:tailEnd type="none" w="med" len="med"/>
-                    </a:lnL>
-                    <a:lnR w="9525" cap="flat" cmpd="sng" algn="ctr">
-                      <a:solidFill>
-                        <a:srgbClr val="E5E7EB"/>
-                      </a:solidFill>
-                      <a:prstDash val="solid"/>
-                      <a:round/>
-                      <a:headEnd type="none" w="med" len="med"/>
-                      <a:tailEnd type="none" w="med" len="med"/>
-                    </a:lnR>
-                    <a:lnT w="9525" cap="flat" cmpd="sng" algn="ctr">
-                      <a:solidFill>
-                        <a:srgbClr val="E5E7EB"/>
-                      </a:solidFill>
-                      <a:prstDash val="solid"/>
-                      <a:round/>
-                      <a:headEnd type="none" w="med" len="med"/>
-                      <a:tailEnd type="none" w="med" len="med"/>
-                    </a:lnT>
-                    <a:lnB w="9525" cap="flat" cmpd="sng" algn="ctr">
-                      <a:solidFill>
-                        <a:srgbClr val="E5E7EB"/>
-                      </a:solidFill>
-                      <a:prstDash val="solid"/>
-                      <a:round/>
-                      <a:headEnd type="none" w="med" len="med"/>
-                      <a:tailEnd type="none" w="med" len="med"/>
-                    </a:lnB>
-                    <a:solidFill>
-                      <a:schemeClr val="bg1"/>
-                    </a:solidFill>
-                  </a:tcPr>
-                </a:tc>
-                <a:tc>
-                  <a:txBody>
-                    <a:bodyPr/>
-                    <a:lstStyle/>
-                    <a:p>
-                      <a:pPr indent="0" marL="0">
-                        <a:buNone/>
-                      </a:pPr>
-                      <a:r>
-                        <a:rPr lang="en-US" sz="1200" dirty="0">
-                          <a:solidFill>
-                            <a:schemeClr val="tx1"/>
-                          </a:solidFill>
-                        </a:rPr>
-                        <a:t>28 g</a:t>
-                      </a:r>
-                      <a:endParaRPr lang="en-US" sz="1200" dirty="0"/>
-                    </a:p>
-                  </a:txBody>
-                  <a:tcPr marL="54864" marR="54864" marT="54864" marB="54864" anchor="ctr">
-                    <a:lnL w="9525" cap="flat" cmpd="sng" algn="ctr">
-                      <a:solidFill>
-                        <a:srgbClr val="E5E7EB"/>
-                      </a:solidFill>
-                      <a:prstDash val="solid"/>
-                      <a:round/>
-                      <a:headEnd type="none" w="med" len="med"/>
-                      <a:tailEnd type="none" w="med" len="med"/>
-                    </a:lnL>
-                    <a:lnR w="9525" cap="flat" cmpd="sng" algn="ctr">
-                      <a:solidFill>
-                        <a:srgbClr val="E5E7EB"/>
-                      </a:solidFill>
-                      <a:prstDash val="solid"/>
-                      <a:round/>
-                      <a:headEnd type="none" w="med" len="med"/>
-                      <a:tailEnd type="none" w="med" len="med"/>
-                    </a:lnR>
-                    <a:lnT w="9525" cap="flat" cmpd="sng" algn="ctr">
-                      <a:solidFill>
-                        <a:srgbClr val="E5E7EB"/>
-                      </a:solidFill>
-                      <a:prstDash val="solid"/>
-                      <a:round/>
-                      <a:headEnd type="none" w="med" len="med"/>
-                      <a:tailEnd type="none" w="med" len="med"/>
-                    </a:lnT>
-                    <a:lnB w="9525" cap="flat" cmpd="sng" algn="ctr">
-                      <a:solidFill>
-                        <a:srgbClr val="E5E7EB"/>
-                      </a:solidFill>
-                      <a:prstDash val="solid"/>
-                      <a:round/>
-                      <a:headEnd type="none" w="med" len="med"/>
-                      <a:tailEnd type="none" w="med" len="med"/>
-                    </a:lnB>
-                    <a:solidFill>
-                      <a:schemeClr val="bg1"/>
-                    </a:solidFill>
-                  </a:tcPr>
-                </a:tc>
-                <a:tc>
-                  <a:txBody>
-                    <a:bodyPr/>
-                    <a:lstStyle/>
-                    <a:p>
-                      <a:pPr indent="0" marL="0">
-                        <a:buNone/>
-                      </a:pPr>
-                      <a:r>
-                        <a:rPr lang="en-US" sz="1200" dirty="0">
-                          <a:solidFill>
-                            <a:schemeClr val="tx1"/>
-                          </a:solidFill>
-                        </a:rPr>
-                        <a:t>Glucose syrup, soy protein isolate, sugar</a:t>
-                      </a:r>
-                      <a:endParaRPr lang="en-US" sz="1200" dirty="0"/>
-                    </a:p>
-                  </a:txBody>
-                  <a:tcPr marL="54864" marR="54864" marT="54864" marB="54864" anchor="ctr">
-                    <a:lnL w="9525" cap="flat" cmpd="sng" algn="ctr">
-                      <a:solidFill>
-                        <a:srgbClr val="E5E7EB"/>
-                      </a:solidFill>
-                      <a:prstDash val="solid"/>
-                      <a:round/>
-                      <a:headEnd type="none" w="med" len="med"/>
-                      <a:tailEnd type="none" w="med" len="med"/>
-                    </a:lnL>
-                    <a:lnR w="9525" cap="flat" cmpd="sng" algn="ctr">
-                      <a:solidFill>
-                        <a:srgbClr val="E5E7EB"/>
-                      </a:solidFill>
-                      <a:prstDash val="solid"/>
-                      <a:round/>
-                      <a:headEnd type="none" w="med" len="med"/>
-                      <a:tailEnd type="none" w="med" len="med"/>
-                    </a:lnR>
-                    <a:lnT w="9525" cap="flat" cmpd="sng" algn="ctr">
-                      <a:solidFill>
-                        <a:srgbClr val="E5E7EB"/>
-                      </a:solidFill>
-                      <a:prstDash val="solid"/>
-                      <a:round/>
-                      <a:headEnd type="none" w="med" len="med"/>
-                      <a:tailEnd type="none" w="med" len="med"/>
-                    </a:lnT>
-                    <a:lnB w="9525" cap="flat" cmpd="sng" algn="ctr">
-                      <a:solidFill>
-                        <a:srgbClr val="E5E7EB"/>
-                      </a:solidFill>
-                      <a:prstDash val="solid"/>
-                      <a:round/>
-                      <a:headEnd type="none" w="med" len="med"/>
-                      <a:tailEnd type="none" w="med" len="med"/>
-                    </a:lnB>
-                    <a:solidFill>
-                      <a:schemeClr val="bg1"/>
-                    </a:solidFill>
-                  </a:tcPr>
-                </a:tc>
-              </a:tr>
-              <a:tr h="475488">
-                <a:tc>
-                  <a:txBody>
-                    <a:bodyPr/>
-                    <a:lstStyle/>
-                    <a:p>
-                      <a:pPr indent="0" marL="0">
-                        <a:buNone/>
-                      </a:pPr>
-                      <a:r>
-                        <a:rPr lang="en-US" sz="1200" dirty="0">
-                          <a:solidFill>
-                            <a:schemeClr val="tx1"/>
-                          </a:solidFill>
-                        </a:rPr>
-                        <a:t>Huel Bar (55 g)</a:t>
-                      </a:r>
-                      <a:endParaRPr lang="en-US" sz="1200" dirty="0"/>
-                    </a:p>
-                  </a:txBody>
-                  <a:tcPr marL="54864" marR="54864" marT="54864" marB="54864" anchor="ctr">
-                    <a:lnL w="9525" cap="flat" cmpd="sng" algn="ctr">
-                      <a:solidFill>
-                        <a:srgbClr val="E5E7EB"/>
-                      </a:solidFill>
-                      <a:prstDash val="solid"/>
-                      <a:round/>
-                      <a:headEnd type="none" w="med" len="med"/>
-                      <a:tailEnd type="none" w="med" len="med"/>
-                    </a:lnL>
-                    <a:lnR w="9525" cap="flat" cmpd="sng" algn="ctr">
-                      <a:solidFill>
-                        <a:srgbClr val="E5E7EB"/>
-                      </a:solidFill>
-                      <a:prstDash val="solid"/>
-                      <a:round/>
-                      <a:headEnd type="none" w="med" len="med"/>
-                      <a:tailEnd type="none" w="med" len="med"/>
-                    </a:lnR>
-                    <a:lnT w="9525" cap="flat" cmpd="sng" algn="ctr">
-                      <a:solidFill>
-                        <a:srgbClr val="E5E7EB"/>
-                      </a:solidFill>
-                      <a:prstDash val="solid"/>
-                      <a:round/>
-                      <a:headEnd type="none" w="med" len="med"/>
-                      <a:tailEnd type="none" w="med" len="med"/>
-                    </a:lnT>
-                    <a:lnB w="9525" cap="flat" cmpd="sng" algn="ctr">
-                      <a:solidFill>
-                        <a:srgbClr val="E5E7EB"/>
-                      </a:solidFill>
-                      <a:prstDash val="solid"/>
-                      <a:round/>
-                      <a:headEnd type="none" w="med" len="med"/>
-                      <a:tailEnd type="none" w="med" len="med"/>
-                    </a:lnB>
-                    <a:solidFill>
-                      <a:schemeClr val="bg1"/>
-                    </a:solidFill>
-                  </a:tcPr>
-                </a:tc>
-                <a:tc>
-                  <a:txBody>
-                    <a:bodyPr/>
-                    <a:lstStyle/>
-                    <a:p>
-                      <a:pPr indent="0" marL="0">
-                        <a:buNone/>
-                      </a:pPr>
-                      <a:r>
-                        <a:rPr lang="en-US" sz="1200" dirty="0">
-                          <a:solidFill>
-                            <a:schemeClr val="tx1"/>
-                          </a:solidFill>
-                        </a:rPr>
-                        <a:t>15 g</a:t>
-                      </a:r>
-                      <a:endParaRPr lang="en-US" sz="1200" dirty="0"/>
-                    </a:p>
-                  </a:txBody>
-                  <a:tcPr marL="54864" marR="54864" marT="54864" marB="54864" anchor="ctr">
-                    <a:lnL w="9525" cap="flat" cmpd="sng" algn="ctr">
-                      <a:solidFill>
-                        <a:srgbClr val="E5E7EB"/>
-                      </a:solidFill>
-                      <a:prstDash val="solid"/>
-                      <a:round/>
-                      <a:headEnd type="none" w="med" len="med"/>
-                      <a:tailEnd type="none" w="med" len="med"/>
-                    </a:lnL>
-                    <a:lnR w="9525" cap="flat" cmpd="sng" algn="ctr">
-                      <a:solidFill>
-                        <a:srgbClr val="E5E7EB"/>
-                      </a:solidFill>
-                      <a:prstDash val="solid"/>
-                      <a:round/>
-                      <a:headEnd type="none" w="med" len="med"/>
-                      <a:tailEnd type="none" w="med" len="med"/>
-                    </a:lnR>
-                    <a:lnT w="9525" cap="flat" cmpd="sng" algn="ctr">
-                      <a:solidFill>
-                        <a:srgbClr val="E5E7EB"/>
-                      </a:solidFill>
-                      <a:prstDash val="solid"/>
-                      <a:round/>
-                      <a:headEnd type="none" w="med" len="med"/>
-                      <a:tailEnd type="none" w="med" len="med"/>
-                    </a:lnT>
-                    <a:lnB w="9525" cap="flat" cmpd="sng" algn="ctr">
-                      <a:solidFill>
-                        <a:srgbClr val="E5E7EB"/>
-                      </a:solidFill>
-                      <a:prstDash val="solid"/>
-                      <a:round/>
-                      <a:headEnd type="none" w="med" len="med"/>
-                      <a:tailEnd type="none" w="med" len="med"/>
-                    </a:lnB>
-                    <a:solidFill>
-                      <a:schemeClr val="bg1"/>
-                    </a:solidFill>
-                  </a:tcPr>
-                </a:tc>
-                <a:tc>
-                  <a:txBody>
-                    <a:bodyPr/>
-                    <a:lstStyle/>
-                    <a:p>
-                      <a:pPr indent="0" marL="0">
-                        <a:buNone/>
-                      </a:pPr>
-                      <a:r>
-                        <a:rPr lang="en-US" sz="1200" dirty="0">
-                          <a:solidFill>
-                            <a:schemeClr val="tx1"/>
-                          </a:solidFill>
-                        </a:rPr>
-                        <a:t>17 g</a:t>
-                      </a:r>
-                      <a:endParaRPr lang="en-US" sz="1200" dirty="0"/>
-                    </a:p>
-                  </a:txBody>
-                  <a:tcPr marL="54864" marR="54864" marT="54864" marB="54864" anchor="ctr">
-                    <a:lnL w="9525" cap="flat" cmpd="sng" algn="ctr">
-                      <a:solidFill>
-                        <a:srgbClr val="E5E7EB"/>
-                      </a:solidFill>
-                      <a:prstDash val="solid"/>
-                      <a:round/>
-                      <a:headEnd type="none" w="med" len="med"/>
-                      <a:tailEnd type="none" w="med" len="med"/>
-                    </a:lnL>
-                    <a:lnR w="9525" cap="flat" cmpd="sng" algn="ctr">
-                      <a:solidFill>
-                        <a:srgbClr val="E5E7EB"/>
-                      </a:solidFill>
-                      <a:prstDash val="solid"/>
-                      <a:round/>
-                      <a:headEnd type="none" w="med" len="med"/>
-                      <a:tailEnd type="none" w="med" len="med"/>
-                    </a:lnR>
-                    <a:lnT w="9525" cap="flat" cmpd="sng" algn="ctr">
-                      <a:solidFill>
-                        <a:srgbClr val="E5E7EB"/>
-                      </a:solidFill>
-                      <a:prstDash val="solid"/>
-                      <a:round/>
-                      <a:headEnd type="none" w="med" len="med"/>
-                      <a:tailEnd type="none" w="med" len="med"/>
-                    </a:lnT>
-                    <a:lnB w="9525" cap="flat" cmpd="sng" algn="ctr">
-                      <a:solidFill>
-                        <a:srgbClr val="E5E7EB"/>
-                      </a:solidFill>
-                      <a:prstDash val="solid"/>
-                      <a:round/>
-                      <a:headEnd type="none" w="med" len="med"/>
-                      <a:tailEnd type="none" w="med" len="med"/>
-                    </a:lnB>
-                    <a:solidFill>
-                      <a:schemeClr val="bg1"/>
-                    </a:solidFill>
-                  </a:tcPr>
-                </a:tc>
-                <a:tc>
-                  <a:txBody>
-                    <a:bodyPr/>
-                    <a:lstStyle/>
-                    <a:p>
-                      <a:pPr indent="0" marL="0">
-                        <a:buNone/>
-                      </a:pPr>
-                      <a:r>
-                        <a:rPr lang="en-US" sz="1200" dirty="0">
-                          <a:solidFill>
-                            <a:schemeClr val="tx1"/>
-                          </a:solidFill>
-                        </a:rPr>
-                        <a:t>2 g</a:t>
-                      </a:r>
-                      <a:endParaRPr lang="en-US" sz="1200" dirty="0"/>
-                    </a:p>
-                  </a:txBody>
-                  <a:tcPr marL="54864" marR="54864" marT="54864" marB="54864" anchor="ctr">
-                    <a:lnL w="9525" cap="flat" cmpd="sng" algn="ctr">
-                      <a:solidFill>
-                        <a:srgbClr val="E5E7EB"/>
-                      </a:solidFill>
-                      <a:prstDash val="solid"/>
-                      <a:round/>
-                      <a:headEnd type="none" w="med" len="med"/>
-                      <a:tailEnd type="none" w="med" len="med"/>
-                    </a:lnL>
-                    <a:lnR w="9525" cap="flat" cmpd="sng" algn="ctr">
-                      <a:solidFill>
-                        <a:srgbClr val="E5E7EB"/>
-                      </a:solidFill>
-                      <a:prstDash val="solid"/>
-                      <a:round/>
-                      <a:headEnd type="none" w="med" len="med"/>
-                      <a:tailEnd type="none" w="med" len="med"/>
-                    </a:lnR>
-                    <a:lnT w="9525" cap="flat" cmpd="sng" algn="ctr">
-                      <a:solidFill>
-                        <a:srgbClr val="E5E7EB"/>
-                      </a:solidFill>
-                      <a:prstDash val="solid"/>
-                      <a:round/>
-                      <a:headEnd type="none" w="med" len="med"/>
-                      <a:tailEnd type="none" w="med" len="med"/>
-                    </a:lnT>
-                    <a:lnB w="9525" cap="flat" cmpd="sng" algn="ctr">
-                      <a:solidFill>
-                        <a:srgbClr val="E5E7EB"/>
-                      </a:solidFill>
-                      <a:prstDash val="solid"/>
-                      <a:round/>
-                      <a:headEnd type="none" w="med" len="med"/>
-                      <a:tailEnd type="none" w="med" len="med"/>
-                    </a:lnB>
-                    <a:solidFill>
-                      <a:schemeClr val="bg1"/>
-                    </a:solidFill>
-                  </a:tcPr>
-                </a:tc>
-                <a:tc>
-                  <a:txBody>
-                    <a:bodyPr/>
-                    <a:lstStyle/>
-                    <a:p>
-                      <a:pPr indent="0" marL="0">
-                        <a:buNone/>
-                      </a:pPr>
-                      <a:r>
-                        <a:rPr lang="en-US" sz="1200" dirty="0">
-                          <a:solidFill>
-                            <a:schemeClr val="tx1"/>
-                          </a:solidFill>
-                        </a:rPr>
-                        <a:t>Maltitol, rice &amp; pea protein, corn fibre</a:t>
-                      </a:r>
-                      <a:endParaRPr lang="en-US" sz="1200" dirty="0"/>
-                    </a:p>
-                  </a:txBody>
-                  <a:tcPr marL="54864" marR="54864" marT="54864" marB="54864" anchor="ctr">
-                    <a:lnL w="9525" cap="flat" cmpd="sng" algn="ctr">
-                      <a:solidFill>
-                        <a:srgbClr val="E5E7EB"/>
-                      </a:solidFill>
-                      <a:prstDash val="solid"/>
-                      <a:round/>
-                      <a:headEnd type="none" w="med" len="med"/>
-                      <a:tailEnd type="none" w="med" len="med"/>
-                    </a:lnL>
-                    <a:lnR w="9525" cap="flat" cmpd="sng" algn="ctr">
-                      <a:solidFill>
-                        <a:srgbClr val="E5E7EB"/>
-                      </a:solidFill>
-                      <a:prstDash val="solid"/>
-                      <a:round/>
-                      <a:headEnd type="none" w="med" len="med"/>
-                      <a:tailEnd type="none" w="med" len="med"/>
-                    </a:lnR>
-                    <a:lnT w="9525" cap="flat" cmpd="sng" algn="ctr">
-                      <a:solidFill>
-                        <a:srgbClr val="E5E7EB"/>
-                      </a:solidFill>
-                      <a:prstDash val="solid"/>
-                      <a:round/>
-                      <a:headEnd type="none" w="med" len="med"/>
-                      <a:tailEnd type="none" w="med" len="med"/>
-                    </a:lnT>
-                    <a:lnB w="9525" cap="flat" cmpd="sng" algn="ctr">
-                      <a:solidFill>
-                        <a:srgbClr val="E5E7EB"/>
-                      </a:solidFill>
-                      <a:prstDash val="solid"/>
-                      <a:round/>
-                      <a:headEnd type="none" w="med" len="med"/>
-                      <a:tailEnd type="none" w="med" len="med"/>
-                    </a:lnB>
-                    <a:solidFill>
-                      <a:schemeClr val="bg1"/>
-                    </a:solidFill>
-                  </a:tcPr>
-                </a:tc>
-              </a:tr>
-              <a:tr h="475488">
-                <a:tc>
-                  <a:txBody>
-                    <a:bodyPr/>
-                    <a:lstStyle/>
-                    <a:p>
-                      <a:pPr indent="0" marL="0">
-                        <a:buNone/>
-                      </a:pPr>
-                      <a:r>
-                        <a:rPr lang="en-US" sz="1200" dirty="0">
-                          <a:solidFill>
-                            <a:schemeClr val="tx1"/>
-                          </a:solidFill>
-                        </a:rPr>
-                        <a:t>Veloforte Forza (70 g, "real food")</a:t>
-                      </a:r>
-                      <a:endParaRPr lang="en-US" sz="1200" dirty="0"/>
-                    </a:p>
-                  </a:txBody>
-                  <a:tcPr marL="54864" marR="54864" marT="54864" marB="54864" anchor="ctr">
-                    <a:lnL w="9525" cap="flat" cmpd="sng" algn="ctr">
-                      <a:solidFill>
-                        <a:srgbClr val="E5E7EB"/>
-                      </a:solidFill>
-                      <a:prstDash val="solid"/>
-                      <a:round/>
-                      <a:headEnd type="none" w="med" len="med"/>
-                      <a:tailEnd type="none" w="med" len="med"/>
-                    </a:lnL>
-                    <a:lnR w="9525" cap="flat" cmpd="sng" algn="ctr">
-                      <a:solidFill>
-                        <a:srgbClr val="E5E7EB"/>
-                      </a:solidFill>
-                      <a:prstDash val="solid"/>
-                      <a:round/>
-                      <a:headEnd type="none" w="med" len="med"/>
-                      <a:tailEnd type="none" w="med" len="med"/>
-                    </a:lnR>
-                    <a:lnT w="9525" cap="flat" cmpd="sng" algn="ctr">
-                      <a:solidFill>
-                        <a:srgbClr val="E5E7EB"/>
-                      </a:solidFill>
-                      <a:prstDash val="solid"/>
-                      <a:round/>
-                      <a:headEnd type="none" w="med" len="med"/>
-                      <a:tailEnd type="none" w="med" len="med"/>
-                    </a:lnT>
-                    <a:lnB w="9525" cap="flat" cmpd="sng" algn="ctr">
-                      <a:solidFill>
-                        <a:srgbClr val="E5E7EB"/>
-                      </a:solidFill>
-                      <a:prstDash val="solid"/>
-                      <a:round/>
-                      <a:headEnd type="none" w="med" len="med"/>
-                      <a:tailEnd type="none" w="med" len="med"/>
-                    </a:lnB>
-                    <a:solidFill>
-                      <a:schemeClr val="bg1"/>
-                    </a:solidFill>
-                  </a:tcPr>
-                </a:tc>
-                <a:tc>
-                  <a:txBody>
-                    <a:bodyPr/>
-                    <a:lstStyle/>
-                    <a:p>
-                      <a:pPr indent="0" marL="0">
-                        <a:buNone/>
-                      </a:pPr>
-                      <a:r>
-                        <a:rPr lang="en-US" sz="1200" dirty="0">
-                          <a:solidFill>
-                            <a:schemeClr val="tx1"/>
-                          </a:solidFill>
-                        </a:rPr>
-                        <a:t>12 g</a:t>
-                      </a:r>
-                      <a:endParaRPr lang="en-US" sz="1200" dirty="0"/>
-                    </a:p>
-                  </a:txBody>
-                  <a:tcPr marL="54864" marR="54864" marT="54864" marB="54864" anchor="ctr">
-                    <a:lnL w="9525" cap="flat" cmpd="sng" algn="ctr">
-                      <a:solidFill>
-                        <a:srgbClr val="E5E7EB"/>
-                      </a:solidFill>
-                      <a:prstDash val="solid"/>
-                      <a:round/>
-                      <a:headEnd type="none" w="med" len="med"/>
-                      <a:tailEnd type="none" w="med" len="med"/>
-                    </a:lnL>
-                    <a:lnR w="9525" cap="flat" cmpd="sng" algn="ctr">
-                      <a:solidFill>
-                        <a:srgbClr val="E5E7EB"/>
-                      </a:solidFill>
-                      <a:prstDash val="solid"/>
-                      <a:round/>
-                      <a:headEnd type="none" w="med" len="med"/>
-                      <a:tailEnd type="none" w="med" len="med"/>
-                    </a:lnR>
-                    <a:lnT w="9525" cap="flat" cmpd="sng" algn="ctr">
-                      <a:solidFill>
-                        <a:srgbClr val="E5E7EB"/>
-                      </a:solidFill>
-                      <a:prstDash val="solid"/>
-                      <a:round/>
-                      <a:headEnd type="none" w="med" len="med"/>
-                      <a:tailEnd type="none" w="med" len="med"/>
-                    </a:lnT>
-                    <a:lnB w="9525" cap="flat" cmpd="sng" algn="ctr">
-                      <a:solidFill>
-                        <a:srgbClr val="E5E7EB"/>
-                      </a:solidFill>
-                      <a:prstDash val="solid"/>
-                      <a:round/>
-                      <a:headEnd type="none" w="med" len="med"/>
-                      <a:tailEnd type="none" w="med" len="med"/>
-                    </a:lnB>
-                    <a:solidFill>
-                      <a:schemeClr val="bg1"/>
-                    </a:solidFill>
-                  </a:tcPr>
-                </a:tc>
-                <a:tc>
-                  <a:txBody>
-                    <a:bodyPr/>
-                    <a:lstStyle/>
-                    <a:p>
-                      <a:pPr indent="0" marL="0">
-                        <a:buNone/>
-                      </a:pPr>
-                      <a:r>
-                        <a:rPr lang="en-US" sz="1200" dirty="0">
-                          <a:solidFill>
-                            <a:schemeClr val="tx1"/>
-                          </a:solidFill>
-                        </a:rPr>
-                        <a:t>38 g</a:t>
-                      </a:r>
-                      <a:endParaRPr lang="en-US" sz="1200" dirty="0"/>
-                    </a:p>
-                  </a:txBody>
-                  <a:tcPr marL="54864" marR="54864" marT="54864" marB="54864" anchor="ctr">
-                    <a:lnL w="9525" cap="flat" cmpd="sng" algn="ctr">
-                      <a:solidFill>
-                        <a:srgbClr val="E5E7EB"/>
-                      </a:solidFill>
-                      <a:prstDash val="solid"/>
-                      <a:round/>
-                      <a:headEnd type="none" w="med" len="med"/>
-                      <a:tailEnd type="none" w="med" len="med"/>
-                    </a:lnL>
-                    <a:lnR w="9525" cap="flat" cmpd="sng" algn="ctr">
-                      <a:solidFill>
-                        <a:srgbClr val="E5E7EB"/>
-                      </a:solidFill>
-                      <a:prstDash val="solid"/>
-                      <a:round/>
-                      <a:headEnd type="none" w="med" len="med"/>
-                      <a:tailEnd type="none" w="med" len="med"/>
-                    </a:lnR>
-                    <a:lnT w="9525" cap="flat" cmpd="sng" algn="ctr">
-                      <a:solidFill>
-                        <a:srgbClr val="E5E7EB"/>
-                      </a:solidFill>
-                      <a:prstDash val="solid"/>
-                      <a:round/>
-                      <a:headEnd type="none" w="med" len="med"/>
-                      <a:tailEnd type="none" w="med" len="med"/>
-                    </a:lnT>
-                    <a:lnB w="9525" cap="flat" cmpd="sng" algn="ctr">
-                      <a:solidFill>
-                        <a:srgbClr val="E5E7EB"/>
-                      </a:solidFill>
-                      <a:prstDash val="solid"/>
-                      <a:round/>
-                      <a:headEnd type="none" w="med" len="med"/>
-                      <a:tailEnd type="none" w="med" len="med"/>
-                    </a:lnB>
-                    <a:solidFill>
-                      <a:schemeClr val="bg1"/>
-                    </a:solidFill>
-                  </a:tcPr>
-                </a:tc>
-                <a:tc>
-                  <a:txBody>
-                    <a:bodyPr/>
-                    <a:lstStyle/>
-                    <a:p>
-                      <a:pPr indent="0" marL="0">
-                        <a:buNone/>
-                      </a:pPr>
-                      <a:r>
-                        <a:rPr lang="en-US" sz="1200" dirty="0">
-                          <a:solidFill>
-                            <a:schemeClr val="tx1"/>
-                          </a:solidFill>
-                        </a:rPr>
-                        <a:t>28 g</a:t>
-                      </a:r>
-                      <a:endParaRPr lang="en-US" sz="1200" dirty="0"/>
-                    </a:p>
-                  </a:txBody>
-                  <a:tcPr marL="54864" marR="54864" marT="54864" marB="54864" anchor="ctr">
-                    <a:lnL w="9525" cap="flat" cmpd="sng" algn="ctr">
-                      <a:solidFill>
-                        <a:srgbClr val="E5E7EB"/>
-                      </a:solidFill>
-                      <a:prstDash val="solid"/>
-                      <a:round/>
-                      <a:headEnd type="none" w="med" len="med"/>
-                      <a:tailEnd type="none" w="med" len="med"/>
-                    </a:lnL>
-                    <a:lnR w="9525" cap="flat" cmpd="sng" algn="ctr">
-                      <a:solidFill>
-                        <a:srgbClr val="E5E7EB"/>
-                      </a:solidFill>
-                      <a:prstDash val="solid"/>
-                      <a:round/>
-                      <a:headEnd type="none" w="med" len="med"/>
-                      <a:tailEnd type="none" w="med" len="med"/>
-                    </a:lnR>
-                    <a:lnT w="9525" cap="flat" cmpd="sng" algn="ctr">
-                      <a:solidFill>
-                        <a:srgbClr val="E5E7EB"/>
-                      </a:solidFill>
-                      <a:prstDash val="solid"/>
-                      <a:round/>
-                      <a:headEnd type="none" w="med" len="med"/>
-                      <a:tailEnd type="none" w="med" len="med"/>
-                    </a:lnT>
-                    <a:lnB w="9525" cap="flat" cmpd="sng" algn="ctr">
-                      <a:solidFill>
-                        <a:srgbClr val="E5E7EB"/>
-                      </a:solidFill>
-                      <a:prstDash val="solid"/>
-                      <a:round/>
-                      <a:headEnd type="none" w="med" len="med"/>
-                      <a:tailEnd type="none" w="med" len="med"/>
-                    </a:lnB>
-                    <a:solidFill>
-                      <a:schemeClr val="bg1"/>
-                    </a:solidFill>
-                  </a:tcPr>
-                </a:tc>
-                <a:tc>
-                  <a:txBody>
-                    <a:bodyPr/>
-                    <a:lstStyle/>
-                    <a:p>
-                      <a:pPr indent="0" marL="0">
-                        <a:buNone/>
-                      </a:pPr>
-                      <a:r>
-                        <a:rPr lang="en-US" sz="1200" dirty="0">
-                          <a:solidFill>
-                            <a:schemeClr val="tx1"/>
-                          </a:solidFill>
-                        </a:rPr>
-                        <a:t>Apricot, almond, egg white, cane sugar</a:t>
-                      </a:r>
-                      <a:endParaRPr lang="en-US" sz="1200" dirty="0"/>
-                    </a:p>
-                  </a:txBody>
-                  <a:tcPr marL="54864" marR="54864" marT="54864" marB="54864" anchor="ctr">
-                    <a:lnL w="9525" cap="flat" cmpd="sng" algn="ctr">
-                      <a:solidFill>
-                        <a:srgbClr val="E5E7EB"/>
-                      </a:solidFill>
-                      <a:prstDash val="solid"/>
-                      <a:round/>
-                      <a:headEnd type="none" w="med" len="med"/>
-                      <a:tailEnd type="none" w="med" len="med"/>
-                    </a:lnL>
-                    <a:lnR w="9525" cap="flat" cmpd="sng" algn="ctr">
-                      <a:solidFill>
-                        <a:srgbClr val="E5E7EB"/>
-                      </a:solidFill>
-                      <a:prstDash val="solid"/>
-                      <a:round/>
-                      <a:headEnd type="none" w="med" len="med"/>
-                      <a:tailEnd type="none" w="med" len="med"/>
-                    </a:lnR>
-                    <a:lnT w="9525" cap="flat" cmpd="sng" algn="ctr">
-                      <a:solidFill>
-                        <a:srgbClr val="E5E7EB"/>
-                      </a:solidFill>
-                      <a:prstDash val="solid"/>
-                      <a:round/>
-                      <a:headEnd type="none" w="med" len="med"/>
-                      <a:tailEnd type="none" w="med" len="med"/>
-                    </a:lnT>
-                    <a:lnB w="9525" cap="flat" cmpd="sng" algn="ctr">
-                      <a:solidFill>
-                        <a:srgbClr val="E5E7EB"/>
-                      </a:solidFill>
-                      <a:prstDash val="solid"/>
-                      <a:round/>
-                      <a:headEnd type="none" w="med" len="med"/>
-                      <a:tailEnd type="none" w="med" len="med"/>
-                    </a:lnB>
-                    <a:solidFill>
-                      <a:schemeClr val="bg1"/>
-                    </a:solidFill>
-                  </a:tcPr>
-                </a:tc>
-              </a:tr>
-              <a:tr h="475488">
-                <a:tc>
-                  <a:txBody>
-                    <a:bodyPr/>
-                    <a:lstStyle/>
-                    <a:p>
-                      <a:pPr indent="0" marL="0">
-                        <a:buNone/>
-                      </a:pPr>
-                      <a:r>
-                        <a:rPr lang="en-US" sz="1200" b="1" dirty="0">
-                          <a:solidFill>
-                            <a:schemeClr val="bg1"/>
-                          </a:solidFill>
-                        </a:rPr>
-                        <a:t>Graft, 2 × 50 g bars (calculated)</a:t>
-                      </a:r>
-                      <a:endParaRPr lang="en-US" sz="1200" dirty="0"/>
-                    </a:p>
-                  </a:txBody>
-                  <a:tcPr marL="54864" marR="54864" marT="54864" marB="54864" anchor="ctr">
-                    <a:lnL w="9525" cap="flat" cmpd="sng" algn="ctr">
-                      <a:solidFill>
-                        <a:srgbClr val="E5E7EB"/>
-                      </a:solidFill>
-                      <a:prstDash val="solid"/>
-                      <a:round/>
-                      <a:headEnd type="none" w="med" len="med"/>
-                      <a:tailEnd type="none" w="med" len="med"/>
-                    </a:lnL>
-                    <a:lnR w="9525" cap="flat" cmpd="sng" algn="ctr">
-                      <a:solidFill>
-                        <a:srgbClr val="E5E7EB"/>
-                      </a:solidFill>
-                      <a:prstDash val="solid"/>
-                      <a:round/>
-                      <a:headEnd type="none" w="med" len="med"/>
-                      <a:tailEnd type="none" w="med" len="med"/>
-                    </a:lnR>
-                    <a:lnT w="9525" cap="flat" cmpd="sng" algn="ctr">
-                      <a:solidFill>
-                        <a:srgbClr val="E5E7EB"/>
-                      </a:solidFill>
-                      <a:prstDash val="solid"/>
-                      <a:round/>
-                      <a:headEnd type="none" w="med" len="med"/>
-                      <a:tailEnd type="none" w="med" len="med"/>
-                    </a:lnT>
-                    <a:lnB w="9525" cap="flat" cmpd="sng" algn="ctr">
-                      <a:solidFill>
-                        <a:srgbClr val="E5E7EB"/>
-                      </a:solidFill>
-                      <a:prstDash val="solid"/>
-                      <a:round/>
-                      <a:headEnd type="none" w="med" len="med"/>
-                      <a:tailEnd type="none" w="med" len="med"/>
-                    </a:lnB>
-                    <a:solidFill>
-                      <a:schemeClr val="accent1"/>
-                    </a:solidFill>
-                  </a:tcPr>
-                </a:tc>
-                <a:tc>
-                  <a:txBody>
-                    <a:bodyPr/>
-                    <a:lstStyle/>
-                    <a:p>
-                      <a:pPr indent="0" marL="0">
-                        <a:buNone/>
-                      </a:pPr>
-                      <a:r>
-                        <a:rPr lang="en-US" sz="1200" b="1" dirty="0">
-                          <a:solidFill>
-                            <a:schemeClr val="bg1"/>
-                          </a:solidFill>
-                        </a:rPr>
-                        <a:t>~29 g</a:t>
-                      </a:r>
-                      <a:endParaRPr lang="en-US" sz="1200" dirty="0"/>
-                    </a:p>
-                  </a:txBody>
-                  <a:tcPr marL="54864" marR="54864" marT="54864" marB="54864" anchor="ctr">
-                    <a:lnL w="9525" cap="flat" cmpd="sng" algn="ctr">
-                      <a:solidFill>
-                        <a:srgbClr val="E5E7EB"/>
-                      </a:solidFill>
-                      <a:prstDash val="solid"/>
-                      <a:round/>
-                      <a:headEnd type="none" w="med" len="med"/>
-                      <a:tailEnd type="none" w="med" len="med"/>
-                    </a:lnL>
-                    <a:lnR w="9525" cap="flat" cmpd="sng" algn="ctr">
-                      <a:solidFill>
-                        <a:srgbClr val="E5E7EB"/>
-                      </a:solidFill>
-                      <a:prstDash val="solid"/>
-                      <a:round/>
-                      <a:headEnd type="none" w="med" len="med"/>
-                      <a:tailEnd type="none" w="med" len="med"/>
-                    </a:lnR>
-                    <a:lnT w="9525" cap="flat" cmpd="sng" algn="ctr">
-                      <a:solidFill>
-                        <a:srgbClr val="E5E7EB"/>
-                      </a:solidFill>
-                      <a:prstDash val="solid"/>
-                      <a:round/>
-                      <a:headEnd type="none" w="med" len="med"/>
-                      <a:tailEnd type="none" w="med" len="med"/>
-                    </a:lnT>
-                    <a:lnB w="9525" cap="flat" cmpd="sng" algn="ctr">
-                      <a:solidFill>
-                        <a:srgbClr val="E5E7EB"/>
-                      </a:solidFill>
-                      <a:prstDash val="solid"/>
-                      <a:round/>
-                      <a:headEnd type="none" w="med" len="med"/>
-                      <a:tailEnd type="none" w="med" len="med"/>
-                    </a:lnB>
-                    <a:solidFill>
-                      <a:schemeClr val="accent1"/>
-                    </a:solidFill>
-                  </a:tcPr>
-                </a:tc>
-                <a:tc>
-                  <a:txBody>
-                    <a:bodyPr/>
-                    <a:lstStyle/>
-                    <a:p>
-                      <a:pPr indent="0" marL="0">
-                        <a:buNone/>
-                      </a:pPr>
-                      <a:r>
-                        <a:rPr lang="en-US" sz="1200" b="1" dirty="0">
-                          <a:solidFill>
-                            <a:schemeClr val="bg1"/>
-                          </a:solidFill>
-                        </a:rPr>
-                        <a:t>~28 g</a:t>
-                      </a:r>
-                      <a:endParaRPr lang="en-US" sz="1200" dirty="0"/>
-                    </a:p>
-                  </a:txBody>
-                  <a:tcPr marL="54864" marR="54864" marT="54864" marB="54864" anchor="ctr">
-                    <a:lnL w="9525" cap="flat" cmpd="sng" algn="ctr">
-                      <a:solidFill>
-                        <a:srgbClr val="E5E7EB"/>
-                      </a:solidFill>
-                      <a:prstDash val="solid"/>
-                      <a:round/>
-                      <a:headEnd type="none" w="med" len="med"/>
-                      <a:tailEnd type="none" w="med" len="med"/>
-                    </a:lnL>
-                    <a:lnR w="9525" cap="flat" cmpd="sng" algn="ctr">
-                      <a:solidFill>
-                        <a:srgbClr val="E5E7EB"/>
-                      </a:solidFill>
-                      <a:prstDash val="solid"/>
-                      <a:round/>
-                      <a:headEnd type="none" w="med" len="med"/>
-                      <a:tailEnd type="none" w="med" len="med"/>
-                    </a:lnR>
-                    <a:lnT w="9525" cap="flat" cmpd="sng" algn="ctr">
-                      <a:solidFill>
-                        <a:srgbClr val="E5E7EB"/>
-                      </a:solidFill>
-                      <a:prstDash val="solid"/>
-                      <a:round/>
-                      <a:headEnd type="none" w="med" len="med"/>
-                      <a:tailEnd type="none" w="med" len="med"/>
-                    </a:lnT>
-                    <a:lnB w="9525" cap="flat" cmpd="sng" algn="ctr">
-                      <a:solidFill>
-                        <a:srgbClr val="E5E7EB"/>
-                      </a:solidFill>
-                      <a:prstDash val="solid"/>
-                      <a:round/>
-                      <a:headEnd type="none" w="med" len="med"/>
-                      <a:tailEnd type="none" w="med" len="med"/>
-                    </a:lnB>
-                    <a:solidFill>
-                      <a:schemeClr val="accent1"/>
-                    </a:solidFill>
-                  </a:tcPr>
-                </a:tc>
-                <a:tc>
-                  <a:txBody>
-                    <a:bodyPr/>
-                    <a:lstStyle/>
-                    <a:p>
-                      <a:pPr indent="0" marL="0">
-                        <a:buNone/>
-                      </a:pPr>
-                      <a:r>
-                        <a:rPr lang="en-US" sz="1200" b="1" dirty="0">
-                          <a:solidFill>
-                            <a:schemeClr val="bg1"/>
-                          </a:solidFill>
-                        </a:rPr>
-                        <a:t>~8 g</a:t>
-                      </a:r>
-                      <a:endParaRPr lang="en-US" sz="1200" dirty="0"/>
-                    </a:p>
-                  </a:txBody>
-                  <a:tcPr marL="54864" marR="54864" marT="54864" marB="54864" anchor="ctr">
-                    <a:lnL w="9525" cap="flat" cmpd="sng" algn="ctr">
-                      <a:solidFill>
-                        <a:srgbClr val="E5E7EB"/>
-                      </a:solidFill>
-                      <a:prstDash val="solid"/>
-                      <a:round/>
-                      <a:headEnd type="none" w="med" len="med"/>
-                      <a:tailEnd type="none" w="med" len="med"/>
-                    </a:lnL>
-                    <a:lnR w="9525" cap="flat" cmpd="sng" algn="ctr">
-                      <a:solidFill>
-                        <a:srgbClr val="E5E7EB"/>
-                      </a:solidFill>
-                      <a:prstDash val="solid"/>
-                      <a:round/>
-                      <a:headEnd type="none" w="med" len="med"/>
-                      <a:tailEnd type="none" w="med" len="med"/>
-                    </a:lnR>
-                    <a:lnT w="9525" cap="flat" cmpd="sng" algn="ctr">
-                      <a:solidFill>
-                        <a:srgbClr val="E5E7EB"/>
-                      </a:solidFill>
-                      <a:prstDash val="solid"/>
-                      <a:round/>
-                      <a:headEnd type="none" w="med" len="med"/>
-                      <a:tailEnd type="none" w="med" len="med"/>
-                    </a:lnT>
-                    <a:lnB w="9525" cap="flat" cmpd="sng" algn="ctr">
-                      <a:solidFill>
-                        <a:srgbClr val="E5E7EB"/>
-                      </a:solidFill>
-                      <a:prstDash val="solid"/>
-                      <a:round/>
-                      <a:headEnd type="none" w="med" len="med"/>
-                      <a:tailEnd type="none" w="med" len="med"/>
-                    </a:lnB>
-                    <a:solidFill>
-                      <a:schemeClr val="accent1"/>
-                    </a:solidFill>
-                  </a:tcPr>
-                </a:tc>
-                <a:tc>
-                  <a:txBody>
-                    <a:bodyPr/>
-                    <a:lstStyle/>
-                    <a:p>
-                      <a:pPr indent="0" marL="0">
-                        <a:buNone/>
-                      </a:pPr>
-                      <a:r>
-                        <a:rPr lang="en-US" sz="1200" b="1" dirty="0">
-                          <a:solidFill>
-                            <a:schemeClr val="bg1"/>
-                          </a:solidFill>
-                        </a:rPr>
-                        <a:t>Egg, quark, oats, a little honey or banana. No whey, no sweeteners</a:t>
-                      </a:r>
-                      <a:endParaRPr lang="en-US" sz="1200" dirty="0"/>
-                    </a:p>
-                  </a:txBody>
-                  <a:tcPr marL="54864" marR="54864" marT="54864" marB="54864" anchor="ctr">
-                    <a:lnL w="9525" cap="flat" cmpd="sng" algn="ctr">
-                      <a:solidFill>
-                        <a:srgbClr val="E5E7EB"/>
-                      </a:solidFill>
-                      <a:prstDash val="solid"/>
-                      <a:round/>
-                      <a:headEnd type="none" w="med" len="med"/>
-                      <a:tailEnd type="none" w="med" len="med"/>
-                    </a:lnL>
-                    <a:lnR w="9525" cap="flat" cmpd="sng" algn="ctr">
-                      <a:solidFill>
-                        <a:srgbClr val="E5E7EB"/>
-                      </a:solidFill>
-                      <a:prstDash val="solid"/>
-                      <a:round/>
-                      <a:headEnd type="none" w="med" len="med"/>
-                      <a:tailEnd type="none" w="med" len="med"/>
-                    </a:lnR>
-                    <a:lnT w="9525" cap="flat" cmpd="sng" algn="ctr">
-                      <a:solidFill>
-                        <a:srgbClr val="E5E7EB"/>
-                      </a:solidFill>
-                      <a:prstDash val="solid"/>
-                      <a:round/>
-                      <a:headEnd type="none" w="med" len="med"/>
-                      <a:tailEnd type="none" w="med" len="med"/>
-                    </a:lnT>
-                    <a:lnB w="9525" cap="flat" cmpd="sng" algn="ctr">
-                      <a:solidFill>
-                        <a:srgbClr val="E5E7EB"/>
-                      </a:solidFill>
-                      <a:prstDash val="solid"/>
-                      <a:round/>
-                      <a:headEnd type="none" w="med" len="med"/>
-                      <a:tailEnd type="none" w="med" len="med"/>
-                    </a:lnB>
-                    <a:solidFill>
-                      <a:schemeClr val="accent1"/>
-                    </a:solidFill>
-                  </a:tcPr>
-                </a:tc>
-              </a:tr>
-            </a:tbl>
-          </a:graphicData>
-        </a:graphic>
-      </p:graphicFrame>
-      <p:sp>
-        <p:nvSpPr>
-          <p:cNvPr id="4" name="Gap card"/>
-          <p:cNvSpPr/>
-          <p:nvPr/>
-        </p:nvSpPr>
-        <p:spPr>
-          <a:xfrm>
-            <a:off x="8503920" y="1280160"/>
-            <a:ext cx="3108960" cy="3794760"/>
-          </a:xfrm>
-          <a:prstGeom prst="roundRect">
-            <a:avLst>
-              <a:gd name="adj" fmla="val 3529"/>
-            </a:avLst>
-          </a:prstGeom>
-          <a:solidFill>
-            <a:schemeClr val="bg2"/>
-          </a:solidFill>
-          <a:ln/>
-        </p:spPr>
-      </p:sp>
-      <p:sp>
-        <p:nvSpPr>
-          <p:cNvPr id="5" name="What we have circle"/>
-          <p:cNvSpPr/>
-          <p:nvPr/>
-        </p:nvSpPr>
-        <p:spPr>
-          <a:xfrm>
-            <a:off x="8732520" y="1463040"/>
-            <a:ext cx="548640" cy="548640"/>
-          </a:xfrm>
-          <a:prstGeom prst="ellipse">
-            <a:avLst/>
-          </a:prstGeom>
-          <a:solidFill>
-            <a:schemeClr val="accent2"/>
-          </a:solidFill>
-          <a:ln/>
-        </p:spPr>
       </p:sp>
       <p:pic>
         <p:nvPicPr>
-          <p:cNvPr id="6" name="What we have icon" descr="What we have">    </p:cNvPr>
+          <p:cNvPr id="3" name="Gap chart" descr="Scatter of 25 UK protein snacks: protein vs sugar per 50 g. Every high-protein, low-sugar bar uses powders; real-food bars are high in sugar; Graft is the only real-food point in the gap.">    </p:cNvPr>
           <p:cNvPicPr>
             <a:picLocks noChangeAspect="1"/>
           </p:cNvPicPr>
@@ -6587,8 +4056,8 @@
         </p:blipFill>
         <p:spPr>
           <a:xfrm>
-            <a:off x="8869680" y="1600200"/>
-            <a:ext cx="274320" cy="274320"/>
+            <a:off x="548640" y="1234440"/>
+            <a:ext cx="7863840" cy="4892040"/>
           </a:xfrm>
           <a:prstGeom prst="rect">
             <a:avLst/>
@@ -6597,23 +4066,45 @@
       </p:pic>
       <p:sp>
         <p:nvSpPr>
-          <p:cNvPr id="7" name="Gap card title"/>
+          <p:cNvPr id="4" name="Gap card"/>
+          <p:cNvSpPr/>
+          <p:nvPr/>
+        </p:nvSpPr>
+        <p:spPr>
+          <a:xfrm>
+            <a:off x="8641080" y="1234440"/>
+            <a:ext cx="2971800" cy="4892040"/>
+          </a:xfrm>
+          <a:prstGeom prst="roundRect">
+            <a:avLst>
+              <a:gd name="adj" fmla="val 3692"/>
+            </a:avLst>
+          </a:prstGeom>
+          <a:solidFill>
+            <a:schemeClr val="bg2"/>
+          </a:solidFill>
+          <a:ln/>
+        </p:spPr>
+      </p:sp>
+      <p:sp>
+        <p:nvSpPr>
+          <p:cNvPr id="5" name="Tests title"/>
           <p:cNvSpPr txBox="1"/>
           <p:nvPr/>
         </p:nvSpPr>
         <p:spPr>
           <a:xfrm>
-            <a:off x="8732520" y="2103120"/>
-            <a:ext cx="2743200" cy="640080"/>
-          </a:xfrm>
-          <a:prstGeom prst="rect">
-            <a:avLst/>
-          </a:prstGeom>
-          <a:noFill/>
-          <a:ln/>
-        </p:spPr>
-        <p:txBody>
-          <a:bodyPr wrap="square" lIns="0" tIns="0" rIns="0" bIns="0" rtlCol="0" anchor="t"/>
+            <a:off x="8869680" y="1417320"/>
+            <a:ext cx="2560320" cy="365760"/>
+          </a:xfrm>
+          <a:prstGeom prst="rect">
+            <a:avLst/>
+          </a:prstGeom>
+          <a:noFill/>
+          <a:ln/>
+        </p:spPr>
+        <p:txBody>
+          <a:bodyPr wrap="square" lIns="0" tIns="0" rIns="0" bIns="0" rtlCol="0" anchor="ctr"/>
           <a:lstStyle/>
           <a:p>
             <a:pPr indent="0" marL="0">
@@ -6625,7 +4116,7 @@
                   <a:schemeClr val="tx1"/>
                 </a:solidFill>
               </a:rPr>
-              <a:t>What they don't have, and we do</a:t>
+              <a:t>25 snacks, 4 tests</a:t>
             </a:r>
             <a:endParaRPr lang="en-US" sz="1600" dirty="0"/>
           </a:p>
@@ -6633,14 +4124,14 @@
       </p:sp>
       <p:sp>
         <p:nvSpPr>
-          <p:cNvPr id="8" name="Gap card list"/>
+          <p:cNvPr id="6" name="Tests list"/>
           <p:cNvSpPr txBox="1"/>
           <p:nvPr/>
         </p:nvSpPr>
         <p:spPr>
           <a:xfrm>
-            <a:off x="8732520" y="2788920"/>
-            <a:ext cx="2743200" cy="2148840"/>
+            <a:off x="8869680" y="1828800"/>
+            <a:ext cx="2560320" cy="1371600"/>
           </a:xfrm>
           <a:prstGeom prst="rect">
             <a:avLst/>
@@ -6654,146 +4145,186 @@
           <a:p>
             <a:pPr marL="342900" indent="-342900">
               <a:spcAft>
-                <a:spcPts val="600"/>
+                <a:spcPts val="300"/>
               </a:spcAft>
               <a:buSzPct val="100000"/>
               <a:buChar char="•"/>
             </a:pPr>
             <a:r>
-              <a:rPr lang="en-US" sz="1400" dirty="0">
+              <a:rPr lang="en-US" sz="1300" dirty="0">
                 <a:solidFill>
                   <a:schemeClr val="tx1"/>
                 </a:solidFill>
               </a:rPr>
-              <a:t>Protein from egg &amp; quark, not powder</a:t>
-            </a:r>
-            <a:endParaRPr lang="en-US" sz="1400" dirty="0"/>
+              <a:t>≥10 g protein: 20</a:t>
+            </a:r>
+            <a:endParaRPr lang="en-US" sz="1300" dirty="0"/>
           </a:p>
           <a:p>
             <a:pPr marL="342900" indent="-342900">
               <a:spcAft>
-                <a:spcPts val="600"/>
+                <a:spcPts val="300"/>
               </a:spcAft>
               <a:buSzPct val="100000"/>
               <a:buChar char="•"/>
             </a:pPr>
             <a:r>
-              <a:rPr lang="en-US" sz="1400" dirty="0">
+              <a:rPr lang="en-US" sz="1300" dirty="0">
                 <a:solidFill>
                   <a:schemeClr val="tx1"/>
                 </a:solidFill>
               </a:rPr>
-              <a:t>Real carbs from oats</a:t>
-            </a:r>
-            <a:endParaRPr lang="en-US" sz="1400" dirty="0"/>
+              <a:t>Low sugar: 11</a:t>
+            </a:r>
+            <a:endParaRPr lang="en-US" sz="1300" dirty="0"/>
           </a:p>
           <a:p>
             <a:pPr marL="342900" indent="-342900">
               <a:spcAft>
-                <a:spcPts val="600"/>
+                <a:spcPts val="300"/>
               </a:spcAft>
               <a:buSzPct val="100000"/>
               <a:buChar char="•"/>
             </a:pPr>
             <a:r>
-              <a:rPr lang="en-US" sz="1400" dirty="0">
+              <a:rPr lang="en-US" sz="1300" dirty="0">
                 <a:solidFill>
                   <a:schemeClr val="tx1"/>
                 </a:solidFill>
               </a:rPr>
-              <a:t>No powders, sweeteners or sugar alcohols</a:t>
-            </a:r>
-            <a:endParaRPr lang="en-US" sz="1400" dirty="0"/>
+              <a:t>Real-food protein: 4</a:t>
+            </a:r>
+            <a:endParaRPr lang="en-US" sz="1300" dirty="0"/>
           </a:p>
           <a:p>
             <a:pPr marL="342900" indent="-342900">
               <a:spcAft>
-                <a:spcPts val="600"/>
+                <a:spcPts val="300"/>
               </a:spcAft>
               <a:buSzPct val="100000"/>
               <a:buChar char="•"/>
             </a:pPr>
             <a:r>
-              <a:rPr lang="en-US" sz="1400" dirty="0">
+              <a:rPr lang="en-US" sz="1300" b="1" dirty="0">
+                <a:solidFill>
+                  <a:schemeClr val="accent1"/>
+                </a:solidFill>
+              </a:rPr>
+              <a:t>All four: 0</a:t>
+            </a:r>
+            <a:endParaRPr lang="en-US" sz="1300" dirty="0"/>
+          </a:p>
+        </p:txBody>
+      </p:sp>
+      <p:sp>
+        <p:nvSpPr>
+          <p:cNvPr id="7" name="Why title"/>
+          <p:cNvSpPr txBox="1"/>
+          <p:nvPr/>
+        </p:nvSpPr>
+        <p:spPr>
+          <a:xfrm>
+            <a:off x="8869680" y="3337560"/>
+            <a:ext cx="2560320" cy="365760"/>
+          </a:xfrm>
+          <a:prstGeom prst="rect">
+            <a:avLst/>
+          </a:prstGeom>
+          <a:noFill/>
+          <a:ln/>
+        </p:spPr>
+        <p:txBody>
+          <a:bodyPr wrap="square" lIns="0" tIns="0" rIns="0" bIns="0" rtlCol="0" anchor="ctr"/>
+          <a:lstStyle/>
+          <a:p>
+            <a:pPr indent="0" marL="0">
+              <a:buNone/>
+            </a:pPr>
+            <a:r>
+              <a:rPr lang="en-US" sz="1600" b="1" dirty="0">
                 <a:solidFill>
                   <a:schemeClr val="tx1"/>
                 </a:solidFill>
               </a:rPr>
-              <a:t>Baked fresh</a:t>
-            </a:r>
-            <a:endParaRPr lang="en-US" sz="1400" dirty="0"/>
-          </a:p>
-        </p:txBody>
-      </p:sp>
-      <p:sp>
-        <p:nvSpPr>
-          <p:cNvPr id="9" name="Market summary"/>
+              <a:t>Why the gap exists</a:t>
+            </a:r>
+            <a:endParaRPr lang="en-US" sz="1600" dirty="0"/>
+          </a:p>
+        </p:txBody>
+      </p:sp>
+      <p:sp>
+        <p:nvSpPr>
+          <p:cNvPr id="8" name="Why list"/>
           <p:cNvSpPr txBox="1"/>
           <p:nvPr/>
         </p:nvSpPr>
         <p:spPr>
           <a:xfrm>
-            <a:off x="548640" y="5257800"/>
-            <a:ext cx="11064240" cy="502920"/>
-          </a:xfrm>
-          <a:prstGeom prst="rect">
-            <a:avLst/>
-          </a:prstGeom>
-          <a:noFill/>
-          <a:ln/>
-        </p:spPr>
-        <p:txBody>
-          <a:bodyPr wrap="square" lIns="0" tIns="0" rIns="0" bIns="0" rtlCol="0" anchor="ctr"/>
-          <a:lstStyle/>
-          <a:p>
-            <a:pPr indent="0" marL="0">
-              <a:buNone/>
-            </a:pPr>
-            <a:r>
-              <a:rPr lang="en-US" sz="1400" b="1" dirty="0">
+            <a:off x="8869680" y="3749040"/>
+            <a:ext cx="2560320" cy="2194560"/>
+          </a:xfrm>
+          <a:prstGeom prst="rect">
+            <a:avLst/>
+          </a:prstGeom>
+          <a:noFill/>
+          <a:ln/>
+        </p:spPr>
+        <p:txBody>
+          <a:bodyPr wrap="square" lIns="0" tIns="0" rIns="0" bIns="0" rtlCol="0" anchor="t"/>
+          <a:lstStyle/>
+          <a:p>
+            <a:pPr marL="342900" indent="-342900">
+              <a:spcAft>
+                <a:spcPts val="400"/>
+              </a:spcAft>
+              <a:buSzPct val="100000"/>
+              <a:buChar char="•"/>
+            </a:pPr>
+            <a:r>
+              <a:rPr lang="en-US" sz="1300" dirty="0">
                 <a:solidFill>
                   <a:schemeClr val="tx1"/>
                 </a:solidFill>
               </a:rPr>
-              <a:t>Checked 32+ UK bars: the high-protein ones use powders and sweeteners; the real-food ones are high in sugar, low in protein.</a:t>
-            </a:r>
-            <a:endParaRPr lang="en-US" sz="1400" dirty="0"/>
-          </a:p>
-        </p:txBody>
-      </p:sp>
-      <p:sp>
-        <p:nvSpPr>
-          <p:cNvPr id="10" name="Table source"/>
-          <p:cNvSpPr txBox="1"/>
-          <p:nvPr/>
-        </p:nvSpPr>
-        <p:spPr>
-          <a:xfrm>
-            <a:off x="548640" y="5806440"/>
-            <a:ext cx="11064240" cy="320040"/>
-          </a:xfrm>
-          <a:prstGeom prst="rect">
-            <a:avLst/>
-          </a:prstGeom>
-          <a:noFill/>
-          <a:ln/>
-        </p:spPr>
-        <p:txBody>
-          <a:bodyPr wrap="square" lIns="0" tIns="0" rIns="0" bIns="0" rtlCol="0" anchor="ctr"/>
-          <a:lstStyle/>
-          <a:p>
-            <a:pPr indent="0" marL="0">
-              <a:buNone/>
-            </a:pPr>
-            <a:r>
-              <a:rPr lang="en-US" sz="1000" i="1" dirty="0">
-                <a:solidFill>
-                  <a:schemeClr val="accent3"/>
-                </a:solidFill>
-              </a:rPr>
-              <a:t>Per bar, from brand/retailer pages, Oct 2026. n/p = not published where checked. Our figures are calculated from ingredients, not lab-tested.</a:t>
-            </a:r>
-            <a:endParaRPr lang="en-US" sz="1000" dirty="0"/>
+              <a:t>Shops need months of shelf life; real food lasts days</a:t>
+            </a:r>
+            <a:endParaRPr lang="en-US" sz="1300" dirty="0"/>
+          </a:p>
+          <a:p>
+            <a:pPr marL="342900" indent="-342900">
+              <a:spcAft>
+                <a:spcPts val="400"/>
+              </a:spcAft>
+              <a:buSzPct val="100000"/>
+              <a:buChar char="•"/>
+            </a:pPr>
+            <a:r>
+              <a:rPr lang="en-US" sz="1300" dirty="0">
+                <a:solidFill>
+                  <a:schemeClr val="tx1"/>
+                </a:solidFill>
+              </a:rPr>
+              <a:t>Powders and sweeteners keep bars soft and cheap</a:t>
+            </a:r>
+            <a:endParaRPr lang="en-US" sz="1300" dirty="0"/>
+          </a:p>
+          <a:p>
+            <a:pPr marL="342900" indent="-342900">
+              <a:spcAft>
+                <a:spcPts val="400"/>
+              </a:spcAft>
+              <a:buSzPct val="100000"/>
+              <a:buChar char="•"/>
+            </a:pPr>
+            <a:r>
+              <a:rPr lang="en-US" sz="1300" b="1" dirty="0">
+                <a:solidFill>
+                  <a:schemeClr val="tx1"/>
+                </a:solidFill>
+              </a:rPr>
+              <a:t>Graft bakes to order and sells direct to squads</a:t>
+            </a:r>
+            <a:endParaRPr lang="en-US" sz="1300" dirty="0"/>
           </a:p>
         </p:txBody>
       </p:sp>

</xml_diff>

<commit_message>
Deck clarity: one-sentence idea first and last, story titles, formats, next step and ask
Co-Authored-By: Claude Opus 5.5 <noreply@anthropic.com>
Claude-Session: https://claude.ai/code/session_01GJGkDeLHjnkx4ZbaPKgLVt
</commit_message>
<xml_diff>
--- a/09-pitch/pitch-deck.pptx
+++ b/09-pitch/pitch-deck.pptx
@@ -111,27 +111,27 @@
   <p:extLst>
     <p:ext uri="{521415D9-36F7-43E2-AB2F-B90AF26B5E84}">
       <p14:sectionLst xmlns:p14="http://schemas.microsoft.com/office/powerpoint/2010/main">
-        <p14:section name="Concept" id="{403483b8-0b5b-a0b4-d045-991deb5ba4ee}">
+        <p14:section name="Concept" id="{f90da0be-236d-53dc-d980-59eec338996d}">
           <p14:sldIdLst>
             <p14:sldId id="256"/>
           </p14:sldIdLst>
         </p14:section>
-        <p14:section name="Problem" id="{7540f01b-dbee-a4ee-09e5-46212d3d3a1d}">
+        <p14:section name="Problem" id="{446a5db6-64de-2dc1-06aa-20e8e3956d2b}">
           <p14:sldIdLst>
             <p14:sldId id="257"/>
           </p14:sldIdLst>
         </p14:section>
-        <p14:section name="Customers" id="{6b78cc4e-f8e3-67b3-bfaf-170cd36795b2}">
+        <p14:section name="Customers" id="{cc83562e-069b-db60-1499-dd8cf268dc52}">
           <p14:sldIdLst>
             <p14:sldId id="258"/>
           </p14:sldIdLst>
         </p14:section>
-        <p14:section name="Market" id="{d37a04da-deb5-58cf-f98a-9bfb3ebf583a}">
+        <p14:section name="Market" id="{6591acc7-19da-b5e4-8b5b-b761d94ce765}">
           <p14:sldIdLst>
             <p14:sldId id="259"/>
           </p14:sldIdLst>
         </p14:section>
-        <p14:section name="Model" id="{ecadc0e4-3231-b04a-889e-0a0ef4266cd7}">
+        <p14:section name="Model" id="{08a9511d-95eb-7171-02dc-40940da1e6c8}">
           <p14:sldIdLst>
             <p14:sldId id="260"/>
           </p14:sldIdLst>
@@ -540,7 +540,7 @@
           <a:p>
             <a:r>
               <a:rPr lang="en-US" dirty="0"/>
-              <a:t>~60s. I've pivoted. The idea is now a recovery bar made from real food, for athletes who train hard. It came from my own training. After two MMA classes back to back I'd eat a full meal and still be after more. Going from MMA straight to football, I'm in a rush and need something quick but proper. On a same-day weigh-in I'm depleted after making weight and have a short window to refuel before I compete. Every time, the choice is a lab-made protein bar full of powders and sweeteners, or nothing. So I made Graft: a 50 g bar with ~15 g protein from egg, quark and oats, and athletes eat two after training, about 29 g protein and 28 g carbs. Graft is British slang for hard work: it is for people who put the work in. Real food for grafters. (Note for weigh-in days: fibre before competing can upset the gut, so a lower-fibre version may suit that use. Worth testing.)</a:t>
+              <a:t>~60s. SAY FIRST: 'Graft is a fresh, baked protein snack made from real food (egg, quark and oats) for athletes who train hard and can't always cook. Baked to order and delivered to squads.' I'm Ewan: Durham Business Management graduate; I train MMA, play football and lift. It came from my own training. After two MMA classes back to back I'd eat a full meal and still be after more. Going from MMA straight to football, I'm in a rush and need something quick but proper. On a same-day weigh-in I'm depleted after making weight and have a short window to refuel before I compete. Every time, the choice is a lab-made protein bar full of powders and sweeteners, or nothing. So I made Graft: about 15 g protein per 50 g from egg, quark and oats, no powders or sweeteners. The format (soft-baked bar, bites or slice) is decided by taste test. Graft is British slang for hard work: it is for people who put the work in. Real food for grafters. (Note for weigh-in days: fibre before competing can upset the gut, so a lower-fibre version may suit that use. Worth testing.)</a:t>
             </a:r>
             <a:endParaRPr lang="en-US" dirty="0"/>
           </a:p>
@@ -804,7 +804,7 @@
           <a:p>
             <a:r>
               <a:rPr lang="en-US" dirty="0"/>
-              <a:t>~60s. I scored 25 UK protein snacks on four tests: at least 10 g protein, protein from real food rather than powders, no sweeteners, and low sugar. 20 have the protein, 11 are low in sugar, only 4 use real-food protein, and none pass all four. The high-protein, low-sugar bars all use powders, mostly with sweeteners. The real-food bars carry 13 to 20 g of sugar. Why? Shops need months of shelf life, and real food lasts days. Graft designs around that: bake to order, sell direct to squads. Graft's numbers are calculated, not yet lab-tested. OLD NOTES: These are the recovery bars athletes see: Myprotein's Re-Fuel, Amacx, HIGH5, Styrkr, Huel. The ones with 20 g protein get it from protein powder, and most rely on syrups or sugar alcohols. Re-Fuel's first ingredient is maltitol. The 'real food' bars like Veloforte have lots of sugar and only 12 g protein. Across 32+ UK bars I checked, none gets its protein from real food with low sugar. Graft does: two 50 g bars give about 29 g protein and 28 g carbs from egg, quark and oats, with a little honey or banana and no sweeteners. Our numbers are calculated from the ingredients and will be lab-checked.</a:t>
+              <a:t>~60s. I scored 25 UK protein snacks on four tests: at least 10 g protein, protein from real food rather than powders, no sweeteners, and low sugar. 20 have the protein, 11 are low in sugar, only 4 use real-food protein, and none pass all four. The high-protein, low-sugar bars all use powders, mostly with sweeteners. The real-food bars carry 13 to 20 g of sugar. Why? Shops need months of shelf life, and real food lasts days. Graft designs around that: bake to order, sell direct to squads. Graft's numbers are calculated, not yet lab-tested. OLD NOTES (competitor detail): These are the bars athletes see: Myprotein's Re-Fuel, Amacx, HIGH5, Styrkr, Huel. The ones with 20 g protein get it from protein powder, and most rely on syrups or sugar alcohols. Re-Fuel's first ingredient is maltitol. The 'real food' bars like Veloforte have lots of sugar and only 12 g protein. Across 32+ UK bars I checked, none gets its protein from real food with low sugar. Graft does: two 50 g bars give about 29 g protein and 28 g carbs from egg, quark and oats, with a little honey or banana and no sweeteners. Our numbers are calculated from the ingredients and will be lab-checked.</a:t>
             </a:r>
             <a:endParaRPr lang="en-US" dirty="0"/>
           </a:p>
@@ -892,7 +892,7 @@
           <a:p>
             <a:r>
               <a:rPr lang="en-US" dirty="0"/>
-              <a:t>~60s. Three flavours in testing: Chocolate Peanut Butter, Vanilla and Banana Bread. Each 50 g bar is about 15 g protein and 14 g carbs; athletes eat two after training. Because it's real food, it's fresh and chilled, not shelf-stable, so I'm using the Simmer Eats model. Simmer cooks fresh meals that last up to 5 days in the fridge and can be frozen on arrival. People order weekly (and squads order through their coach), I bake to order, deliver chilled around Durham to start, and they eat it within 3 days or freeze it. 'Baked this week, not 12 months ago.' Next steps: blind taste tests against Barebells, a squad trial with Team Durham, registering as a food business, and more interviews. Thank you.</a:t>
+              <a:t>~60s. I'm testing three formats with the same ingredients: a soft-baked bar, bites and a slice; the taste test decides. About 15 g protein per 50 g, calculated. Because it's real food, it's fresh and chilled, not shelf-stable, so I'm using the Simmer Eats model. Simmer cooks fresh meals that last up to 5 days in the fridge and can be frozen on arrival. People order weekly (and squads order through their coach), I bake to order, deliver chilled around Durham to start, and they eat it within 3 days or freeze it. 'Baked this week, not 12 months ago.' Next: a blind taste test against Barebells, aiming for 7 out of 9, then a free squad trial. What I need: kitchen access and coach introductions. SAY LAST: 'Graft is a fresh, baked protein snack made from real food (egg, quark and oats) for athletes who train hard and can't always cook. Baked to order and delivered to squads. Real food for grafters.' Thank you.</a:t>
             </a:r>
             <a:endParaRPr lang="en-US" dirty="0"/>
           </a:p>
@@ -1641,7 +1641,7 @@
                   <a:schemeClr val="bg1"/>
                 </a:solidFill>
               </a:rPr>
-              <a:t>The pivot: a </a:t>
+              <a:t>Graft: </a:t>
             </a:r>
             <a:pPr algn="l" indent="0" marL="0">
               <a:buNone/>
@@ -1652,7 +1652,7 @@
                   <a:schemeClr val="accent1"/>
                 </a:solidFill>
               </a:rPr>
-              <a:t>real-food</a:t>
+              <a:t>real food</a:t>
             </a:r>
             <a:pPr algn="l" indent="0" marL="0">
               <a:buNone/>
@@ -1663,7 +1663,7 @@
                   <a:schemeClr val="bg1"/>
                 </a:solidFill>
               </a:rPr>
-              <a:t> recovery bar for athletes who train hard</a:t>
+              <a:t> for people who train hard</a:t>
             </a:r>
             <a:endParaRPr lang="en-US" sz="3600" dirty="0"/>
           </a:p>
@@ -1677,8 +1677,8 @@
         </p:nvSpPr>
         <p:spPr>
           <a:xfrm>
-            <a:off x="548640" y="1645920"/>
-            <a:ext cx="11064240" cy="411480"/>
+            <a:off x="548640" y="1417320"/>
+            <a:ext cx="11064240" cy="822960"/>
           </a:xfrm>
           <a:prstGeom prst="rect">
             <a:avLst/>
@@ -1699,7 +1699,7 @@
                   <a:schemeClr val="bg1"/>
                 </a:solidFill>
               </a:rPr>
-              <a:t>Two 50 g bars ≈ 29 g protein + 28 g carbs  ·  egg, quark &amp; oats  ·  no whey, sweeteners or sugar alcohols</a:t>
+              <a:t>Graft is a fresh, baked protein snack made from real food (egg, quark and oats) for athletes who train hard and can't always cook. Baked to order and delivered to squads.</a:t>
             </a:r>
             <a:endParaRPr lang="en-US" sz="1800" dirty="0"/>
           </a:p>
@@ -2209,7 +2209,7 @@
                   <a:schemeClr val="accent3"/>
                 </a:solidFill>
               </a:rPr>
-              <a:t>Real food for grafters.  (Graft: British slang for hard work.)</a:t>
+              <a:t>Ewan Hetherington · Durham Business Management graduate · MMA, football, gym · Real food for grafters.</a:t>
             </a:r>
             <a:endParaRPr lang="en-US" sz="1400" dirty="0"/>
           </a:p>
@@ -2317,7 +2317,7 @@
                   <a:schemeClr val="tx1"/>
                 </a:solidFill>
               </a:rPr>
-              <a:t>Why it's needed: told to eat real food, no time to make it</a:t>
+              <a:t>The problem: told to eat real food, no time to make it</a:t>
             </a:r>
             <a:endParaRPr lang="en-US" sz="3200" dirty="0"/>
           </a:p>
@@ -3070,7 +3070,7 @@
                   <a:schemeClr val="tx1"/>
                 </a:solidFill>
               </a:rPr>
-              <a:t>What athletes told me, and who it's for</a:t>
+              <a:t>Who it's for: Jack, and the squads who'll try it first</a:t>
             </a:r>
             <a:endParaRPr lang="en-US" sz="3200" dirty="0"/>
           </a:p>
@@ -3904,8 +3904,8 @@
         </p:nvSpPr>
         <p:spPr>
           <a:xfrm>
-            <a:off x="4846320" y="5806440"/>
-            <a:ext cx="6766560" cy="502920"/>
+            <a:off x="4846320" y="5760720"/>
+            <a:ext cx="6766560" cy="548640"/>
           </a:xfrm>
           <a:prstGeom prst="rect">
             <a:avLst/>
@@ -3921,14 +3921,14 @@
               <a:buNone/>
             </a:pPr>
             <a:r>
-              <a:rPr lang="en-US" sz="1300" i="1" dirty="0">
-                <a:solidFill>
-                  <a:schemeClr val="accent3"/>
-                </a:solidFill>
-              </a:rPr>
-              <a:t>Early adopters: coached athletes (Team Durham squads, my MMA club). One coach = ~25 athletes = one drop. Still to prove: 0/10 committed yet.</a:t>
-            </a:r>
-            <a:endParaRPr lang="en-US" sz="1300" dirty="0"/>
+              <a:rPr lang="en-US" sz="1400" b="1" dirty="0">
+                <a:solidFill>
+                  <a:schemeClr val="accent1"/>
+                </a:solidFill>
+              </a:rPr>
+              <a:t>Early adopters: coached Durham squads + my MMA club. One coach = ~25 athletes = one drop. (0/10 committed yet; the squad trial tests this.)</a:t>
+            </a:r>
+            <a:endParaRPr lang="en-US" sz="1400" dirty="0"/>
           </a:p>
         </p:txBody>
       </p:sp>
@@ -4430,7 +4430,7 @@
                   <a:schemeClr val="tx1"/>
                 </a:solidFill>
               </a:rPr>
-              <a:t>How it works: baked fresh, like Simmer Eats</a:t>
+              <a:t>Graft: how it works and what's next</a:t>
             </a:r>
             <a:endParaRPr lang="en-US" sz="3200" dirty="0"/>
           </a:p>
@@ -4490,7 +4490,7 @@
                   <a:schemeClr val="tx1"/>
                 </a:solidFill>
               </a:rPr>
-              <a:t>Three flavours in testing</a:t>
+              <a:t>Formats in testing</a:t>
             </a:r>
             <a:endParaRPr lang="en-US" sz="1600" dirty="0"/>
           </a:p>
@@ -4548,7 +4548,7 @@
                   <a:schemeClr val="accent5"/>
                 </a:solidFill>
               </a:rPr>
-              <a:t>Chocolate Peanut Butter</a:t>
+              <a:t>Soft-baked bar</a:t>
             </a:r>
             <a:endParaRPr lang="en-US" sz="1400" dirty="0"/>
           </a:p>
@@ -4606,7 +4606,7 @@
                   <a:schemeClr val="accent5"/>
                 </a:solidFill>
               </a:rPr>
-              <a:t>Vanilla</a:t>
+              <a:t>Bites</a:t>
             </a:r>
             <a:endParaRPr lang="en-US" sz="1400" dirty="0"/>
           </a:p>
@@ -4664,7 +4664,7 @@
                   <a:schemeClr val="accent5"/>
                 </a:solidFill>
               </a:rPr>
-              <a:t>Banana Bread</a:t>
+              <a:t>Slice</a:t>
             </a:r>
             <a:endParaRPr lang="en-US" sz="1400" dirty="0"/>
           </a:p>
@@ -4700,7 +4700,7 @@
                   <a:schemeClr val="accent3"/>
                 </a:solidFill>
               </a:rPr>
-              <a:t>Each 50 g bar: ~15 g protein · ~14 g carbs · ~4 g sugar · ~135 kcal (calculated) · eat two after training</a:t>
+              <a:t>~15 g protein per 50 g · egg, quark &amp; oats · no powders or sweeteners · ~4 g sugar (calculated, not lab-tested)</a:t>
             </a:r>
             <a:endParaRPr lang="en-US" sz="1400" dirty="0"/>
           </a:p>
@@ -5370,7 +5370,7 @@
                   <a:schemeClr val="accent1"/>
                 </a:solidFill>
               </a:rPr>
-              <a:t>"Baked this week, not 12 months ago." </a:t>
+              <a:t>Next: </a:t>
             </a:r>
             <a:pPr indent="0" marL="0">
               <a:buNone/>
@@ -5381,7 +5381,43 @@
                   <a:schemeClr val="bg1"/>
                 </a:solidFill>
               </a:rPr>
-              <a:t>The short shelf life is the proof it's real food, the same model as Simmer Eats' fresh meals. Next: taste tests vs Barebells, a squad trial with Team Durham, and more interviews.</a:t>
+              <a:t>blind taste test (≥7/9) → free squad trial.  </a:t>
+            </a:r>
+            <a:pPr indent="0" marL="0">
+              <a:buNone/>
+            </a:pPr>
+            <a:r>
+              <a:rPr lang="en-US" sz="1500" b="1" dirty="0">
+                <a:solidFill>
+                  <a:schemeClr val="accent1"/>
+                </a:solidFill>
+              </a:rPr>
+              <a:t>Need: </a:t>
+            </a:r>
+            <a:pPr indent="0" marL="0">
+              <a:buNone/>
+            </a:pPr>
+            <a:r>
+              <a:rPr lang="en-US" sz="1500" dirty="0">
+                <a:solidFill>
+                  <a:schemeClr val="bg1"/>
+                </a:solidFill>
+              </a:rPr>
+              <a:t>kitchen access + coach intros.</a:t>
+            </a:r>
+            <a:endParaRPr lang="en-US" sz="1500" dirty="0"/>
+          </a:p>
+          <a:p>
+            <a:pPr indent="0" marL="0">
+              <a:buNone/>
+            </a:pPr>
+            <a:r>
+              <a:rPr lang="en-US" sz="1500" b="1" dirty="0">
+                <a:solidFill>
+                  <a:schemeClr val="bg1"/>
+                </a:solidFill>
+              </a:rPr>
+              <a:t>Graft: fresh, baked, real-food protein for people who train hard. Real food for grafters.</a:t>
             </a:r>
             <a:endParaRPr lang="en-US" sz="1500" dirty="0"/>
           </a:p>
@@ -5441,9 +5477,9 @@
 </file>
 
 <file path=ppt/theme/theme1.xml><?xml version="1.0" encoding="utf-8"?>
-<a:theme xmlns:a="http://schemas.openxmlformats.org/drawingml/2006/main" name="Recovery Bar Pitch">
+<a:theme xmlns:a="http://schemas.openxmlformats.org/drawingml/2006/main" name="Graft Pitch">
   <a:themeElements>
-    <a:clrScheme name="Recovery Bar Pitch">
+    <a:clrScheme name="Graft Pitch">
       <a:dk1>
         <a:srgbClr val="1C1B19"/>
       </a:dk1>
@@ -5481,7 +5517,7 @@
         <a:srgbClr val="7C2D12"/>
       </a:folHlink>
     </a:clrScheme>
-    <a:fontScheme name="Recovery Bar Pitch">
+    <a:fontScheme name="Graft Pitch">
       <a:majorFont>
         <a:latin typeface="Arial"/>
         <a:ea typeface=""/>

</xml_diff>

<commit_message>
Deck: why-it-needs-to-happen box, precedents on gap slide, remove placeholder
Co-Authored-By: Claude Opus 5.5 <noreply@anthropic.com>
Claude-Session: https://claude.ai/code/session_01GJGkDeLHjnkx4ZbaPKgLVt
</commit_message>
<xml_diff>
--- a/09-pitch/pitch-deck.pptx
+++ b/09-pitch/pitch-deck.pptx
@@ -111,27 +111,27 @@
   <p:extLst>
     <p:ext uri="{521415D9-36F7-43E2-AB2F-B90AF26B5E84}">
       <p14:sectionLst xmlns:p14="http://schemas.microsoft.com/office/powerpoint/2010/main">
-        <p14:section name="Concept" id="{f90da0be-236d-53dc-d980-59eec338996d}">
+        <p14:section name="Concept" id="{8ce6a951-1fe8-1a82-a78f-c0edf8f32716}">
           <p14:sldIdLst>
             <p14:sldId id="256"/>
           </p14:sldIdLst>
         </p14:section>
-        <p14:section name="Problem" id="{446a5db6-64de-2dc1-06aa-20e8e3956d2b}">
+        <p14:section name="Problem" id="{560fe6e0-83fc-0edb-28f3-bd0a909e5b1a}">
           <p14:sldIdLst>
             <p14:sldId id="257"/>
           </p14:sldIdLst>
         </p14:section>
-        <p14:section name="Customers" id="{cc83562e-069b-db60-1499-dd8cf268dc52}">
+        <p14:section name="Customers" id="{7477b2bf-8f9c-0db9-feb2-6ac47f4018c0}">
           <p14:sldIdLst>
             <p14:sldId id="258"/>
           </p14:sldIdLst>
         </p14:section>
-        <p14:section name="Market" id="{6591acc7-19da-b5e4-8b5b-b761d94ce765}">
+        <p14:section name="Market" id="{9d61077a-383b-0fa8-923c-31b1f6bea039}">
           <p14:sldIdLst>
             <p14:sldId id="259"/>
           </p14:sldIdLst>
         </p14:section>
-        <p14:section name="Model" id="{08a9511d-95eb-7171-02dc-40940da1e6c8}">
+        <p14:section name="Model" id="{17c5e640-c058-f535-96cb-ecfc7c4b8c4b}">
           <p14:sldIdLst>
             <p14:sldId id="260"/>
           </p14:sldIdLst>
@@ -2951,7 +2951,7 @@
                   <a:schemeClr val="tx1"/>
                 </a:solidFill>
               </a:rPr>
-              <a:t>The convenient options don't fit. </a:t>
+              <a:t>Why this needs to happen: </a:t>
             </a:r>
             <a:pPr indent="0" marL="0">
               <a:buNone/>
@@ -2962,7 +2962,7 @@
                   <a:schemeClr val="tx1"/>
                 </a:solidFill>
               </a:rPr>
-              <a:t>Low-sugar bars rely on protein powders, sweeteners and sugar alcohols; "real-food" bars carry 10–28 g sugar and little protein. Only ~4% of UK adults get enough fibre.</a:t>
+              <a:t>the quick options are lab bars (powders, sweeteners, sugar alcohols) or sugary "natural" bars. Over half of UK adults' energy already comes from ultra-processed food, and 71% are trying to avoid it.</a:t>
             </a:r>
             <a:endParaRPr lang="en-US" sz="1500" dirty="0"/>
           </a:p>
@@ -3248,7 +3248,7 @@
                   <a:schemeClr val="accent1"/>
                 </a:solidFill>
               </a:rPr>
-              <a:t>Lined up: [add who's booked]</a:t>
+              <a:t>Next: 3–5 Mom Test interviews + poster survey (live Monday)</a:t>
             </a:r>
             <a:endParaRPr lang="en-US" sz="1400" dirty="0"/>
           </a:p>
@@ -4323,6 +4323,24 @@
                 </a:solidFill>
               </a:rPr>
               <a:t>Graft bakes to order and sells direct to squads</a:t>
+            </a:r>
+            <a:endParaRPr lang="en-US" sz="1300" dirty="0"/>
+          </a:p>
+          <a:p>
+            <a:pPr marL="342900" indent="-342900">
+              <a:spcAft>
+                <a:spcPts val="400"/>
+              </a:spcAft>
+              <a:buSzPct val="100000"/>
+              <a:buChar char="•"/>
+            </a:pPr>
+            <a:r>
+              <a:rPr lang="en-US" sz="1300" dirty="0">
+                <a:solidFill>
+                  <a:schemeClr val="tx1"/>
+                </a:solidFill>
+              </a:rPr>
+              <a:t>Proof it can work: RXBAR (egg-white bar, $600m) and Perfect Bar (fridge bar) in the US</a:t>
             </a:r>
             <a:endParaRPr lang="en-US" sz="1300" dirty="0"/>
           </a:p>

</xml_diff>

<commit_message>
Deck: zero branding (no logo or name), unbranded gap chart
Co-Authored-By: Claude Opus 5.5 <noreply@anthropic.com>
Claude-Session: https://claude.ai/code/session_01GJGkDeLHjnkx4ZbaPKgLVt
</commit_message>
<xml_diff>
--- a/09-pitch/pitch-deck.pptx
+++ b/09-pitch/pitch-deck.pptx
@@ -111,27 +111,27 @@
   <p:extLst>
     <p:ext uri="{521415D9-36F7-43E2-AB2F-B90AF26B5E84}">
       <p14:sectionLst xmlns:p14="http://schemas.microsoft.com/office/powerpoint/2010/main">
-        <p14:section name="Concept" id="{8ce6a951-1fe8-1a82-a78f-c0edf8f32716}">
+        <p14:section name="Concept" id="{93d16fc2-8181-27e2-58e6-da133b856ab0}">
           <p14:sldIdLst>
             <p14:sldId id="256"/>
           </p14:sldIdLst>
         </p14:section>
-        <p14:section name="Problem" id="{560fe6e0-83fc-0edb-28f3-bd0a909e5b1a}">
+        <p14:section name="Problem" id="{5a9cde57-3e62-3efd-4e5d-14555abb3559}">
           <p14:sldIdLst>
             <p14:sldId id="257"/>
           </p14:sldIdLst>
         </p14:section>
-        <p14:section name="Customers" id="{7477b2bf-8f9c-0db9-feb2-6ac47f4018c0}">
+        <p14:section name="Customers" id="{8fbbe425-9d87-4bd9-0474-019888dd1649}">
           <p14:sldIdLst>
             <p14:sldId id="258"/>
           </p14:sldIdLst>
         </p14:section>
-        <p14:section name="Market" id="{9d61077a-383b-0fa8-923c-31b1f6bea039}">
+        <p14:section name="Market" id="{b63c1614-5a80-ec09-f9af-6f7aab6d5b22}">
           <p14:sldIdLst>
             <p14:sldId id="259"/>
           </p14:sldIdLst>
         </p14:section>
-        <p14:section name="Model" id="{17c5e640-c058-f535-96cb-ecfc7c4b8c4b}">
+        <p14:section name="Model" id="{dd8ff3c6-d9ed-8cb5-d1be-5377efb09bf2}">
           <p14:sldIdLst>
             <p14:sldId id="260"/>
           </p14:sldIdLst>
@@ -540,7 +540,7 @@
           <a:p>
             <a:r>
               <a:rPr lang="en-US" dirty="0"/>
-              <a:t>~60s. SAY FIRST: 'Graft is a fresh, baked protein snack made from real food (egg, quark and oats) for athletes who train hard and can't always cook. Baked to order and delivered to squads.' I'm Ewan: Durham Business Management graduate; I train MMA, play football and lift. It came from my own training. After two MMA classes back to back I'd eat a full meal and still be after more. Going from MMA straight to football, I'm in a rush and need something quick but proper. On a same-day weigh-in I'm depleted after making weight and have a short window to refuel before I compete. Every time, the choice is a lab-made protein bar full of powders and sweeteners, or nothing. So I made Graft: about 15 g protein per 50 g from egg, quark and oats, no powders or sweeteners. The format (soft-baked bar, bites or slice) is decided by taste test. Graft is British slang for hard work: it is for people who put the work in. Real food for grafters. (Note for weigh-in days: fibre before competing can upset the gut, so a lower-fibre version may suit that use. Worth testing.)</a:t>
+              <a:t>~60s. SAY FIRST: 'A fresh, baked protein snack made from real food (egg, quark and oats) for athletes who train hard and can't always cook. Baked to order and delivered to squads.' I'm Ewan: Durham Business Management graduate; I train MMA, play football and lift. It came from my own training. After two MMA classes back to back I'd eat a full meal and still be after more. Going from MMA straight to football, I'm in a rush and need something quick but proper. On a same-day weigh-in I'm depleted after making weight and have a short window to refuel before I compete. Every time, the choice is a lab-made protein bar full of powders and sweeteners, or nothing. So I made this: about 15 g protein per 50 g from egg, quark and oats, no powders or sweeteners. The format (soft-baked bar, bites or slice) is decided by taste test.  (Note for weigh-in days: fibre before competing can upset the gut, so a lower-fibre version may suit that use. Worth testing.)</a:t>
             </a:r>
             <a:endParaRPr lang="en-US" dirty="0"/>
           </a:p>
@@ -804,7 +804,7 @@
           <a:p>
             <a:r>
               <a:rPr lang="en-US" dirty="0"/>
-              <a:t>~60s. I scored 25 UK protein snacks on four tests: at least 10 g protein, protein from real food rather than powders, no sweeteners, and low sugar. 20 have the protein, 11 are low in sugar, only 4 use real-food protein, and none pass all four. The high-protein, low-sugar bars all use powders, mostly with sweeteners. The real-food bars carry 13 to 20 g of sugar. Why? Shops need months of shelf life, and real food lasts days. Graft designs around that: bake to order, sell direct to squads. Graft's numbers are calculated, not yet lab-tested. OLD NOTES (competitor detail): These are the bars athletes see: Myprotein's Re-Fuel, Amacx, HIGH5, Styrkr, Huel. The ones with 20 g protein get it from protein powder, and most rely on syrups or sugar alcohols. Re-Fuel's first ingredient is maltitol. The 'real food' bars like Veloforte have lots of sugar and only 12 g protein. Across 32+ UK bars I checked, none gets its protein from real food with low sugar. Graft does: two 50 g bars give about 29 g protein and 28 g carbs from egg, quark and oats, with a little honey or banana and no sweeteners. Our numbers are calculated from the ingredients and will be lab-checked.</a:t>
+              <a:t>~60s. I scored 25 UK protein snacks on four tests: at least 10 g protein, protein from real food rather than powders, no sweeteners, and low sugar. 20 have the protein, 11 are low in sugar, only 4 use real-food protein, and none pass all four. The high-protein, low-sugar bars all use powders, mostly with sweeteners. The real-food bars carry 13 to 20 g of sugar. Why? Shops need months of shelf life, and real food lasts days. We design around that: bake to order, sell direct to squads. Our numbers are calculated, not yet lab-tested. OLD NOTES (competitor detail): These are the bars athletes see: Myprotein's Re-Fuel, Amacx, HIGH5, Styrkr, Huel. The ones with 20 g protein get it from protein powder, and most rely on syrups or sugar alcohols. Re-Fuel's first ingredient is maltitol. The 'real food' bars like Veloforte have lots of sugar and only 12 g protein. Across 32+ UK bars I checked, none gets its protein from real food with low sugar. Ours does: two 50 g bars give about 29 g protein and 28 g carbs from egg, quark and oats, with a little honey or banana and no sweeteners. Our numbers are calculated from the ingredients and will be lab-checked.</a:t>
             </a:r>
             <a:endParaRPr lang="en-US" dirty="0"/>
           </a:p>
@@ -892,7 +892,7 @@
           <a:p>
             <a:r>
               <a:rPr lang="en-US" dirty="0"/>
-              <a:t>~60s. I'm testing three formats with the same ingredients: a soft-baked bar, bites and a slice; the taste test decides. About 15 g protein per 50 g, calculated. Because it's real food, it's fresh and chilled, not shelf-stable, so I'm using the Simmer Eats model. Simmer cooks fresh meals that last up to 5 days in the fridge and can be frozen on arrival. People order weekly (and squads order through their coach), I bake to order, deliver chilled around Durham to start, and they eat it within 3 days or freeze it. 'Baked this week, not 12 months ago.' Next: a blind taste test against Barebells, aiming for 7 out of 9, then a free squad trial. What I need: kitchen access and coach introductions. SAY LAST: 'Graft is a fresh, baked protein snack made from real food (egg, quark and oats) for athletes who train hard and can't always cook. Baked to order and delivered to squads. Real food for grafters.' Thank you.</a:t>
+              <a:t>~60s. I'm testing three formats with the same ingredients: a soft-baked bar, bites and a slice; the taste test decides. About 15 g protein per 50 g, calculated. Because it's real food, it's fresh and chilled, not shelf-stable, so I'm using the Simmer Eats model. Simmer cooks fresh meals that last up to 5 days in the fridge and can be frozen on arrival. People order weekly (and squads order through their coach), I bake to order, deliver chilled around Durham to start, and they eat it within 3 days or freeze it. 'Baked this week, not 12 months ago.' Next: a blind taste test against Barebells, aiming for 7 out of 9, then a free squad trial. What I need: kitchen access and coach introductions. SAY LAST: 'A fresh, baked protein snack made from real food (egg, quark and oats) for athletes who train hard and can't always cook. Baked to order and delivered to squads.' Thank you.</a:t>
             </a:r>
             <a:endParaRPr lang="en-US" dirty="0"/>
           </a:p>
@@ -1057,7 +1057,7 @@
                   <a:schemeClr val="accent3"/>
                 </a:solidFill>
               </a:rPr>
-              <a:t>Graft · Real food for grafters · Durham Venture School</a:t>
+              <a:t>Durham Venture School · Ewan Hetherington</a:t>
             </a:r>
             <a:endParaRPr lang="en-US" sz="1000" dirty="0"/>
           </a:p>
@@ -1209,7 +1209,7 @@
                   <a:schemeClr val="accent3"/>
                 </a:solidFill>
               </a:rPr>
-              <a:t>Graft · Real food for grafters · Durham Venture School</a:t>
+              <a:t>Durham Venture School · Ewan Hetherington</a:t>
             </a:r>
             <a:endParaRPr lang="en-US" sz="1000" dirty="0"/>
           </a:p>
@@ -1641,7 +1641,7 @@
                   <a:schemeClr val="bg1"/>
                 </a:solidFill>
               </a:rPr>
-              <a:t>Graft: </a:t>
+              <a:t>A </a:t>
             </a:r>
             <a:pPr algn="l" indent="0" marL="0">
               <a:buNone/>
@@ -1652,7 +1652,7 @@
                   <a:schemeClr val="accent1"/>
                 </a:solidFill>
               </a:rPr>
-              <a:t>real food</a:t>
+              <a:t>real-food</a:t>
             </a:r>
             <a:pPr algn="l" indent="0" marL="0">
               <a:buNone/>
@@ -1663,7 +1663,7 @@
                   <a:schemeClr val="bg1"/>
                 </a:solidFill>
               </a:rPr>
-              <a:t> for people who train hard</a:t>
+              <a:t> protein snack for people who train hard</a:t>
             </a:r>
             <a:endParaRPr lang="en-US" sz="3600" dirty="0"/>
           </a:p>
@@ -1677,8 +1677,8 @@
         </p:nvSpPr>
         <p:spPr>
           <a:xfrm>
-            <a:off x="548640" y="1417320"/>
-            <a:ext cx="11064240" cy="822960"/>
+            <a:off x="548640" y="1572768"/>
+            <a:ext cx="11064240" cy="777240"/>
           </a:xfrm>
           <a:prstGeom prst="rect">
             <a:avLst/>
@@ -1694,14 +1694,14 @@
               <a:buNone/>
             </a:pPr>
             <a:r>
-              <a:rPr lang="en-US" sz="1800" dirty="0">
+              <a:rPr lang="en-US" sz="1700" dirty="0">
                 <a:solidFill>
                   <a:schemeClr val="bg1"/>
                 </a:solidFill>
               </a:rPr>
-              <a:t>Graft is a fresh, baked protein snack made from real food (egg, quark and oats) for athletes who train hard and can't always cook. Baked to order and delivered to squads.</a:t>
-            </a:r>
-            <a:endParaRPr lang="en-US" sz="1800" dirty="0"/>
+              <a:t>A fresh, baked protein snack made from real food (egg, quark and oats) for athletes who train hard and can't always cook. Baked to order and delivered to squads.</a:t>
+            </a:r>
+            <a:endParaRPr lang="en-US" sz="1700" dirty="0"/>
           </a:p>
         </p:txBody>
       </p:sp>
@@ -2155,40 +2155,16 @@
           </a:p>
         </p:txBody>
       </p:sp>
-      <p:pic>
-        <p:nvPicPr>
-          <p:cNvPr id="20" name="Graft logo" descr="Graft logo">    </p:cNvPr>
-          <p:cNvPicPr>
-            <a:picLocks noChangeAspect="1"/>
-          </p:cNvPicPr>
-          <p:nvPr/>
-        </p:nvPicPr>
-        <p:blipFill>
-          <a:blip r:embed="rId4"/>
-          <a:stretch>
-            <a:fillRect/>
-          </a:stretch>
-        </p:blipFill>
-        <p:spPr>
-          <a:xfrm>
-            <a:off x="548640" y="5669280"/>
-            <a:ext cx="1600200" cy="448056"/>
-          </a:xfrm>
-          <a:prstGeom prst="rect">
-            <a:avLst/>
-          </a:prstGeom>
-        </p:spPr>
-      </p:pic>
-      <p:sp>
-        <p:nvSpPr>
-          <p:cNvPr id="21" name="Branding note"/>
+      <p:sp>
+        <p:nvSpPr>
+          <p:cNvPr id="20" name="Branding note"/>
           <p:cNvSpPr txBox="1"/>
           <p:nvPr/>
         </p:nvSpPr>
         <p:spPr>
           <a:xfrm>
-            <a:off x="2377440" y="5715000"/>
-            <a:ext cx="9235440" cy="365760"/>
+            <a:off x="548640" y="5715000"/>
+            <a:ext cx="11064240" cy="365760"/>
           </a:xfrm>
           <a:prstGeom prst="rect">
             <a:avLst/>
@@ -2209,7 +2185,7 @@
                   <a:schemeClr val="accent3"/>
                 </a:solidFill>
               </a:rPr>
-              <a:t>Ewan Hetherington · Durham Business Management graduate · MMA, football, gym · Real food for grafters.</a:t>
+              <a:t>Ewan Hetherington · Durham Business Management graduate · MMA, football, gym</a:t>
             </a:r>
             <a:endParaRPr lang="en-US" sz="1400" dirty="0"/>
           </a:p>
@@ -4042,7 +4018,7 @@
       </p:sp>
       <p:pic>
         <p:nvPicPr>
-          <p:cNvPr id="3" name="Gap chart" descr="Scatter of 25 UK protein snacks: protein vs sugar per 50 g. Every high-protein, low-sugar bar uses powders; real-food bars are high in sugar; Graft is the only real-food point in the gap.">    </p:cNvPr>
+          <p:cNvPr id="3" name="Gap chart" descr="Scatter of 25 UK protein snacks: protein vs sugar per 50 g. Every high-protein, low-sugar bar uses powders; real-food bars are high in sugar; our snack is the only real-food point in the gap.">    </p:cNvPr>
           <p:cNvPicPr>
             <a:picLocks noChangeAspect="1"/>
           </p:cNvPicPr>
@@ -4322,7 +4298,7 @@
                   <a:schemeClr val="tx1"/>
                 </a:solidFill>
               </a:rPr>
-              <a:t>Graft bakes to order and sells direct to squads</a:t>
+              <a:t>We bake to order and sell direct to squads</a:t>
             </a:r>
             <a:endParaRPr lang="en-US" sz="1300" dirty="0"/>
           </a:p>
@@ -4448,15 +4424,303 @@
                   <a:schemeClr val="tx1"/>
                 </a:solidFill>
               </a:rPr>
-              <a:t>Graft: how it works and what's next</a:t>
+              <a:t>How it works and what's next</a:t>
             </a:r>
             <a:endParaRPr lang="en-US" sz="3200" dirty="0"/>
           </a:p>
         </p:txBody>
+      </p:sp>
+      <p:sp>
+        <p:nvSpPr>
+          <p:cNvPr id="3" name="Flavours heading"/>
+          <p:cNvSpPr txBox="1"/>
+          <p:nvPr/>
+        </p:nvSpPr>
+        <p:spPr>
+          <a:xfrm>
+            <a:off x="548640" y="1280160"/>
+            <a:ext cx="4572000" cy="365760"/>
+          </a:xfrm>
+          <a:prstGeom prst="rect">
+            <a:avLst/>
+          </a:prstGeom>
+          <a:noFill/>
+          <a:ln/>
+        </p:spPr>
+        <p:txBody>
+          <a:bodyPr wrap="square" lIns="0" tIns="0" rIns="0" bIns="0" rtlCol="0" anchor="ctr"/>
+          <a:lstStyle/>
+          <a:p>
+            <a:pPr indent="0" marL="0">
+              <a:buNone/>
+            </a:pPr>
+            <a:r>
+              <a:rPr lang="en-US" sz="1600" b="1" dirty="0">
+                <a:solidFill>
+                  <a:schemeClr val="tx1"/>
+                </a:solidFill>
+              </a:rPr>
+              <a:t>Formats in testing</a:t>
+            </a:r>
+            <a:endParaRPr lang="en-US" sz="1600" dirty="0"/>
+          </a:p>
+        </p:txBody>
+      </p:sp>
+      <p:sp>
+        <p:nvSpPr>
+          <p:cNvPr id="4" name="Flavour 1"/>
+          <p:cNvSpPr/>
+          <p:nvPr/>
+        </p:nvSpPr>
+        <p:spPr>
+          <a:xfrm>
+            <a:off x="548640" y="1737360"/>
+            <a:ext cx="2148840" cy="548640"/>
+          </a:xfrm>
+          <a:prstGeom prst="roundRect">
+            <a:avLst>
+              <a:gd name="adj" fmla="val 50000"/>
+            </a:avLst>
+          </a:prstGeom>
+          <a:solidFill>
+            <a:schemeClr val="accent4"/>
+          </a:solidFill>
+          <a:ln/>
+        </p:spPr>
+      </p:sp>
+      <p:sp>
+        <p:nvSpPr>
+          <p:cNvPr id="5" name="Flavour 1 label"/>
+          <p:cNvSpPr txBox="1"/>
+          <p:nvPr/>
+        </p:nvSpPr>
+        <p:spPr>
+          <a:xfrm>
+            <a:off x="548640" y="1737360"/>
+            <a:ext cx="2148840" cy="548640"/>
+          </a:xfrm>
+          <a:prstGeom prst="rect">
+            <a:avLst/>
+          </a:prstGeom>
+          <a:noFill/>
+          <a:ln/>
+        </p:spPr>
+        <p:txBody>
+          <a:bodyPr wrap="square" lIns="0" tIns="0" rIns="0" bIns="0" rtlCol="0" anchor="ctr"/>
+          <a:lstStyle/>
+          <a:p>
+            <a:pPr algn="ctr" indent="0" marL="0">
+              <a:buNone/>
+            </a:pPr>
+            <a:r>
+              <a:rPr lang="en-US" sz="1400" b="1" dirty="0">
+                <a:solidFill>
+                  <a:schemeClr val="accent5"/>
+                </a:solidFill>
+              </a:rPr>
+              <a:t>Soft-baked bar</a:t>
+            </a:r>
+            <a:endParaRPr lang="en-US" sz="1400" dirty="0"/>
+          </a:p>
+        </p:txBody>
+      </p:sp>
+      <p:sp>
+        <p:nvSpPr>
+          <p:cNvPr id="6" name="Flavour 2"/>
+          <p:cNvSpPr/>
+          <p:nvPr/>
+        </p:nvSpPr>
+        <p:spPr>
+          <a:xfrm>
+            <a:off x="2880360" y="1737360"/>
+            <a:ext cx="2148840" cy="548640"/>
+          </a:xfrm>
+          <a:prstGeom prst="roundRect">
+            <a:avLst>
+              <a:gd name="adj" fmla="val 50000"/>
+            </a:avLst>
+          </a:prstGeom>
+          <a:solidFill>
+            <a:schemeClr val="accent4"/>
+          </a:solidFill>
+          <a:ln/>
+        </p:spPr>
+      </p:sp>
+      <p:sp>
+        <p:nvSpPr>
+          <p:cNvPr id="7" name="Flavour 2 label"/>
+          <p:cNvSpPr txBox="1"/>
+          <p:nvPr/>
+        </p:nvSpPr>
+        <p:spPr>
+          <a:xfrm>
+            <a:off x="2880360" y="1737360"/>
+            <a:ext cx="2148840" cy="548640"/>
+          </a:xfrm>
+          <a:prstGeom prst="rect">
+            <a:avLst/>
+          </a:prstGeom>
+          <a:noFill/>
+          <a:ln/>
+        </p:spPr>
+        <p:txBody>
+          <a:bodyPr wrap="square" lIns="0" tIns="0" rIns="0" bIns="0" rtlCol="0" anchor="ctr"/>
+          <a:lstStyle/>
+          <a:p>
+            <a:pPr algn="ctr" indent="0" marL="0">
+              <a:buNone/>
+            </a:pPr>
+            <a:r>
+              <a:rPr lang="en-US" sz="1400" b="1" dirty="0">
+                <a:solidFill>
+                  <a:schemeClr val="accent5"/>
+                </a:solidFill>
+              </a:rPr>
+              <a:t>Bites</a:t>
+            </a:r>
+            <a:endParaRPr lang="en-US" sz="1400" dirty="0"/>
+          </a:p>
+        </p:txBody>
+      </p:sp>
+      <p:sp>
+        <p:nvSpPr>
+          <p:cNvPr id="8" name="Flavour 3"/>
+          <p:cNvSpPr/>
+          <p:nvPr/>
+        </p:nvSpPr>
+        <p:spPr>
+          <a:xfrm>
+            <a:off x="5212080" y="1737360"/>
+            <a:ext cx="2148840" cy="548640"/>
+          </a:xfrm>
+          <a:prstGeom prst="roundRect">
+            <a:avLst>
+              <a:gd name="adj" fmla="val 50000"/>
+            </a:avLst>
+          </a:prstGeom>
+          <a:solidFill>
+            <a:schemeClr val="accent4"/>
+          </a:solidFill>
+          <a:ln/>
+        </p:spPr>
+      </p:sp>
+      <p:sp>
+        <p:nvSpPr>
+          <p:cNvPr id="9" name="Flavour 3 label"/>
+          <p:cNvSpPr txBox="1"/>
+          <p:nvPr/>
+        </p:nvSpPr>
+        <p:spPr>
+          <a:xfrm>
+            <a:off x="5212080" y="1737360"/>
+            <a:ext cx="2148840" cy="548640"/>
+          </a:xfrm>
+          <a:prstGeom prst="rect">
+            <a:avLst/>
+          </a:prstGeom>
+          <a:noFill/>
+          <a:ln/>
+        </p:spPr>
+        <p:txBody>
+          <a:bodyPr wrap="square" lIns="0" tIns="0" rIns="0" bIns="0" rtlCol="0" anchor="ctr"/>
+          <a:lstStyle/>
+          <a:p>
+            <a:pPr algn="ctr" indent="0" marL="0">
+              <a:buNone/>
+            </a:pPr>
+            <a:r>
+              <a:rPr lang="en-US" sz="1400" b="1" dirty="0">
+                <a:solidFill>
+                  <a:schemeClr val="accent5"/>
+                </a:solidFill>
+              </a:rPr>
+              <a:t>Slice</a:t>
+            </a:r>
+            <a:endParaRPr lang="en-US" sz="1400" dirty="0"/>
+          </a:p>
+        </p:txBody>
+      </p:sp>
+      <p:sp>
+        <p:nvSpPr>
+          <p:cNvPr id="10" name="Flavour macros"/>
+          <p:cNvSpPr txBox="1"/>
+          <p:nvPr/>
+        </p:nvSpPr>
+        <p:spPr>
+          <a:xfrm>
+            <a:off x="548640" y="2377440"/>
+            <a:ext cx="11064240" cy="365760"/>
+          </a:xfrm>
+          <a:prstGeom prst="rect">
+            <a:avLst/>
+          </a:prstGeom>
+          <a:noFill/>
+          <a:ln/>
+        </p:spPr>
+        <p:txBody>
+          <a:bodyPr wrap="square" lIns="0" tIns="0" rIns="0" bIns="0" rtlCol="0" anchor="ctr"/>
+          <a:lstStyle/>
+          <a:p>
+            <a:pPr indent="0" marL="0">
+              <a:buNone/>
+            </a:pPr>
+            <a:r>
+              <a:rPr lang="en-US" sz="1400" dirty="0">
+                <a:solidFill>
+                  <a:schemeClr val="accent3"/>
+                </a:solidFill>
+              </a:rPr>
+              <a:t>~15 g protein per 50 g · egg, quark &amp; oats · no powders or sweeteners · ~4 g sugar (calculated, not lab-tested)</a:t>
+            </a:r>
+            <a:endParaRPr lang="en-US" sz="1400" dirty="0"/>
+          </a:p>
+        </p:txBody>
+      </p:sp>
+      <p:sp>
+        <p:nvSpPr>
+          <p:cNvPr id="11" name="Step 1 card"/>
+          <p:cNvSpPr/>
+          <p:nvPr/>
+        </p:nvSpPr>
+        <p:spPr>
+          <a:xfrm>
+            <a:off x="548640" y="3017520"/>
+            <a:ext cx="2560320" cy="1828800"/>
+          </a:xfrm>
+          <a:prstGeom prst="roundRect">
+            <a:avLst>
+              <a:gd name="adj" fmla="val 6000"/>
+            </a:avLst>
+          </a:prstGeom>
+          <a:solidFill>
+            <a:schemeClr val="bg2"/>
+          </a:solidFill>
+          <a:ln/>
+        </p:spPr>
+      </p:sp>
+      <p:sp>
+        <p:nvSpPr>
+          <p:cNvPr id="12" name="Step 1 circle"/>
+          <p:cNvSpPr/>
+          <p:nvPr/>
+        </p:nvSpPr>
+        <p:spPr>
+          <a:xfrm>
+            <a:off x="777240" y="3200400"/>
+            <a:ext cx="548640" cy="548640"/>
+          </a:xfrm>
+          <a:prstGeom prst="ellipse">
+            <a:avLst/>
+          </a:prstGeom>
+          <a:solidFill>
+            <a:schemeClr val="accent1"/>
+          </a:solidFill>
+          <a:ln/>
+        </p:spPr>
       </p:sp>
       <p:pic>
         <p:nvPicPr>
-          <p:cNvPr id="3" name="Graft logo" descr="Graft logo">    </p:cNvPr>
+          <p:cNvPr id="13" name="Step 1 icon" descr="Step 1">    </p:cNvPr>
           <p:cNvPicPr>
             <a:picLocks noChangeAspect="1"/>
           </p:cNvPicPr>
@@ -4470,8 +4734,8 @@
         </p:blipFill>
         <p:spPr>
           <a:xfrm>
-            <a:off x="10195560" y="457200"/>
-            <a:ext cx="1417320" cy="393192"/>
+            <a:off x="914400" y="3337560"/>
+            <a:ext cx="274320" cy="274320"/>
           </a:xfrm>
           <a:prstGeom prst="rect">
             <a:avLst/>
@@ -4480,14 +4744,14 @@
       </p:pic>
       <p:sp>
         <p:nvSpPr>
-          <p:cNvPr id="4" name="Flavours heading"/>
+          <p:cNvPr id="14" name="Step 1 title"/>
           <p:cNvSpPr txBox="1"/>
           <p:nvPr/>
         </p:nvSpPr>
         <p:spPr>
           <a:xfrm>
-            <a:off x="548640" y="1280160"/>
-            <a:ext cx="4572000" cy="365760"/>
+            <a:off x="1417320" y="3200400"/>
+            <a:ext cx="1600200" cy="548640"/>
           </a:xfrm>
           <a:prstGeom prst="rect">
             <a:avLst/>
@@ -4508,7 +4772,7 @@
                   <a:schemeClr val="tx1"/>
                 </a:solidFill>
               </a:rPr>
-              <a:t>Formats in testing</a:t>
+              <a:t>1. Order</a:t>
             </a:r>
             <a:endParaRPr lang="en-US" sz="1600" dirty="0"/>
           </a:p>
@@ -4516,223 +4780,69 @@
       </p:sp>
       <p:sp>
         <p:nvSpPr>
-          <p:cNvPr id="5" name="Flavour 1"/>
+          <p:cNvPr id="15" name="Step 1 text"/>
+          <p:cNvSpPr txBox="1"/>
+          <p:nvPr/>
+        </p:nvSpPr>
+        <p:spPr>
+          <a:xfrm>
+            <a:off x="777240" y="3886200"/>
+            <a:ext cx="2148840" cy="868680"/>
+          </a:xfrm>
+          <a:prstGeom prst="rect">
+            <a:avLst/>
+          </a:prstGeom>
+          <a:noFill/>
+          <a:ln/>
+        </p:spPr>
+        <p:txBody>
+          <a:bodyPr wrap="square" lIns="0" tIns="0" rIns="0" bIns="0" rtlCol="0" anchor="t"/>
+          <a:lstStyle/>
+          <a:p>
+            <a:pPr indent="0" marL="0">
+              <a:buNone/>
+            </a:pPr>
+            <a:r>
+              <a:rPr lang="en-US" sz="1400" dirty="0">
+                <a:solidFill>
+                  <a:schemeClr val="tx1"/>
+                </a:solidFill>
+              </a:rPr>
+              <a:t>Weekly orders and squad orders via coaches</a:t>
+            </a:r>
+            <a:endParaRPr lang="en-US" sz="1400" dirty="0"/>
+          </a:p>
+        </p:txBody>
+      </p:sp>
+      <p:sp>
+        <p:nvSpPr>
+          <p:cNvPr id="16" name="Arrow 1"/>
           <p:cNvSpPr/>
           <p:nvPr/>
         </p:nvSpPr>
         <p:spPr>
           <a:xfrm>
-            <a:off x="548640" y="1737360"/>
-            <a:ext cx="2148840" cy="548640"/>
-          </a:xfrm>
-          <a:prstGeom prst="roundRect">
-            <a:avLst>
-              <a:gd name="adj" fmla="val 50000"/>
-            </a:avLst>
+            <a:off x="3136392" y="3794760"/>
+            <a:ext cx="219456" cy="274320"/>
+          </a:xfrm>
+          <a:prstGeom prst="rightArrow">
+            <a:avLst/>
           </a:prstGeom>
           <a:solidFill>
-            <a:schemeClr val="accent4"/>
+            <a:schemeClr val="accent1"/>
           </a:solidFill>
           <a:ln/>
         </p:spPr>
       </p:sp>
       <p:sp>
         <p:nvSpPr>
-          <p:cNvPr id="6" name="Flavour 1 label"/>
-          <p:cNvSpPr txBox="1"/>
-          <p:nvPr/>
-        </p:nvSpPr>
-        <p:spPr>
-          <a:xfrm>
-            <a:off x="548640" y="1737360"/>
-            <a:ext cx="2148840" cy="548640"/>
-          </a:xfrm>
-          <a:prstGeom prst="rect">
-            <a:avLst/>
-          </a:prstGeom>
-          <a:noFill/>
-          <a:ln/>
-        </p:spPr>
-        <p:txBody>
-          <a:bodyPr wrap="square" lIns="0" tIns="0" rIns="0" bIns="0" rtlCol="0" anchor="ctr"/>
-          <a:lstStyle/>
-          <a:p>
-            <a:pPr algn="ctr" indent="0" marL="0">
-              <a:buNone/>
-            </a:pPr>
-            <a:r>
-              <a:rPr lang="en-US" sz="1400" b="1" dirty="0">
-                <a:solidFill>
-                  <a:schemeClr val="accent5"/>
-                </a:solidFill>
-              </a:rPr>
-              <a:t>Soft-baked bar</a:t>
-            </a:r>
-            <a:endParaRPr lang="en-US" sz="1400" dirty="0"/>
-          </a:p>
-        </p:txBody>
-      </p:sp>
-      <p:sp>
-        <p:nvSpPr>
-          <p:cNvPr id="7" name="Flavour 2"/>
+          <p:cNvPr id="17" name="Step 2 card"/>
           <p:cNvSpPr/>
           <p:nvPr/>
         </p:nvSpPr>
         <p:spPr>
           <a:xfrm>
-            <a:off x="2880360" y="1737360"/>
-            <a:ext cx="2148840" cy="548640"/>
-          </a:xfrm>
-          <a:prstGeom prst="roundRect">
-            <a:avLst>
-              <a:gd name="adj" fmla="val 50000"/>
-            </a:avLst>
-          </a:prstGeom>
-          <a:solidFill>
-            <a:schemeClr val="accent4"/>
-          </a:solidFill>
-          <a:ln/>
-        </p:spPr>
-      </p:sp>
-      <p:sp>
-        <p:nvSpPr>
-          <p:cNvPr id="8" name="Flavour 2 label"/>
-          <p:cNvSpPr txBox="1"/>
-          <p:nvPr/>
-        </p:nvSpPr>
-        <p:spPr>
-          <a:xfrm>
-            <a:off x="2880360" y="1737360"/>
-            <a:ext cx="2148840" cy="548640"/>
-          </a:xfrm>
-          <a:prstGeom prst="rect">
-            <a:avLst/>
-          </a:prstGeom>
-          <a:noFill/>
-          <a:ln/>
-        </p:spPr>
-        <p:txBody>
-          <a:bodyPr wrap="square" lIns="0" tIns="0" rIns="0" bIns="0" rtlCol="0" anchor="ctr"/>
-          <a:lstStyle/>
-          <a:p>
-            <a:pPr algn="ctr" indent="0" marL="0">
-              <a:buNone/>
-            </a:pPr>
-            <a:r>
-              <a:rPr lang="en-US" sz="1400" b="1" dirty="0">
-                <a:solidFill>
-                  <a:schemeClr val="accent5"/>
-                </a:solidFill>
-              </a:rPr>
-              <a:t>Bites</a:t>
-            </a:r>
-            <a:endParaRPr lang="en-US" sz="1400" dirty="0"/>
-          </a:p>
-        </p:txBody>
-      </p:sp>
-      <p:sp>
-        <p:nvSpPr>
-          <p:cNvPr id="9" name="Flavour 3"/>
-          <p:cNvSpPr/>
-          <p:nvPr/>
-        </p:nvSpPr>
-        <p:spPr>
-          <a:xfrm>
-            <a:off x="5212080" y="1737360"/>
-            <a:ext cx="2148840" cy="548640"/>
-          </a:xfrm>
-          <a:prstGeom prst="roundRect">
-            <a:avLst>
-              <a:gd name="adj" fmla="val 50000"/>
-            </a:avLst>
-          </a:prstGeom>
-          <a:solidFill>
-            <a:schemeClr val="accent4"/>
-          </a:solidFill>
-          <a:ln/>
-        </p:spPr>
-      </p:sp>
-      <p:sp>
-        <p:nvSpPr>
-          <p:cNvPr id="10" name="Flavour 3 label"/>
-          <p:cNvSpPr txBox="1"/>
-          <p:nvPr/>
-        </p:nvSpPr>
-        <p:spPr>
-          <a:xfrm>
-            <a:off x="5212080" y="1737360"/>
-            <a:ext cx="2148840" cy="548640"/>
-          </a:xfrm>
-          <a:prstGeom prst="rect">
-            <a:avLst/>
-          </a:prstGeom>
-          <a:noFill/>
-          <a:ln/>
-        </p:spPr>
-        <p:txBody>
-          <a:bodyPr wrap="square" lIns="0" tIns="0" rIns="0" bIns="0" rtlCol="0" anchor="ctr"/>
-          <a:lstStyle/>
-          <a:p>
-            <a:pPr algn="ctr" indent="0" marL="0">
-              <a:buNone/>
-            </a:pPr>
-            <a:r>
-              <a:rPr lang="en-US" sz="1400" b="1" dirty="0">
-                <a:solidFill>
-                  <a:schemeClr val="accent5"/>
-                </a:solidFill>
-              </a:rPr>
-              <a:t>Slice</a:t>
-            </a:r>
-            <a:endParaRPr lang="en-US" sz="1400" dirty="0"/>
-          </a:p>
-        </p:txBody>
-      </p:sp>
-      <p:sp>
-        <p:nvSpPr>
-          <p:cNvPr id="11" name="Flavour macros"/>
-          <p:cNvSpPr txBox="1"/>
-          <p:nvPr/>
-        </p:nvSpPr>
-        <p:spPr>
-          <a:xfrm>
-            <a:off x="548640" y="2377440"/>
-            <a:ext cx="11064240" cy="365760"/>
-          </a:xfrm>
-          <a:prstGeom prst="rect">
-            <a:avLst/>
-          </a:prstGeom>
-          <a:noFill/>
-          <a:ln/>
-        </p:spPr>
-        <p:txBody>
-          <a:bodyPr wrap="square" lIns="0" tIns="0" rIns="0" bIns="0" rtlCol="0" anchor="ctr"/>
-          <a:lstStyle/>
-          <a:p>
-            <a:pPr indent="0" marL="0">
-              <a:buNone/>
-            </a:pPr>
-            <a:r>
-              <a:rPr lang="en-US" sz="1400" dirty="0">
-                <a:solidFill>
-                  <a:schemeClr val="accent3"/>
-                </a:solidFill>
-              </a:rPr>
-              <a:t>~15 g protein per 50 g · egg, quark &amp; oats · no powders or sweeteners · ~4 g sugar (calculated, not lab-tested)</a:t>
-            </a:r>
-            <a:endParaRPr lang="en-US" sz="1400" dirty="0"/>
-          </a:p>
-        </p:txBody>
-      </p:sp>
-      <p:sp>
-        <p:nvSpPr>
-          <p:cNvPr id="12" name="Step 1 card"/>
-          <p:cNvSpPr/>
-          <p:nvPr/>
-        </p:nvSpPr>
-        <p:spPr>
-          <a:xfrm>
-            <a:off x="548640" y="3017520"/>
+            <a:off x="3383280" y="3017520"/>
             <a:ext cx="2560320" cy="1828800"/>
           </a:xfrm>
           <a:prstGeom prst="roundRect">
@@ -4748,13 +4858,13 @@
       </p:sp>
       <p:sp>
         <p:nvSpPr>
-          <p:cNvPr id="13" name="Step 1 circle"/>
+          <p:cNvPr id="18" name="Step 2 circle"/>
           <p:cNvSpPr/>
           <p:nvPr/>
         </p:nvSpPr>
         <p:spPr>
           <a:xfrm>
-            <a:off x="777240" y="3200400"/>
+            <a:off x="3611880" y="3200400"/>
             <a:ext cx="548640" cy="548640"/>
           </a:xfrm>
           <a:prstGeom prst="ellipse">
@@ -4768,7 +4878,7 @@
       </p:sp>
       <p:pic>
         <p:nvPicPr>
-          <p:cNvPr id="14" name="Step 1 icon" descr="Step 1">    </p:cNvPr>
+          <p:cNvPr id="19" name="Step 2 icon" descr="Step 2">    </p:cNvPr>
           <p:cNvPicPr>
             <a:picLocks noChangeAspect="1"/>
           </p:cNvPicPr>
@@ -4782,7 +4892,7 @@
         </p:blipFill>
         <p:spPr>
           <a:xfrm>
-            <a:off x="914400" y="3337560"/>
+            <a:off x="3749040" y="3337560"/>
             <a:ext cx="274320" cy="274320"/>
           </a:xfrm>
           <a:prstGeom prst="rect">
@@ -4792,13 +4902,13 @@
       </p:pic>
       <p:sp>
         <p:nvSpPr>
-          <p:cNvPr id="15" name="Step 1 title"/>
+          <p:cNvPr id="20" name="Step 2 title"/>
           <p:cNvSpPr txBox="1"/>
           <p:nvPr/>
         </p:nvSpPr>
         <p:spPr>
           <a:xfrm>
-            <a:off x="1417320" y="3200400"/>
+            <a:off x="4251960" y="3200400"/>
             <a:ext cx="1600200" cy="548640"/>
           </a:xfrm>
           <a:prstGeom prst="rect">
@@ -4820,7 +4930,7 @@
                   <a:schemeClr val="tx1"/>
                 </a:solidFill>
               </a:rPr>
-              <a:t>1. Order</a:t>
+              <a:t>2. Bake</a:t>
             </a:r>
             <a:endParaRPr lang="en-US" sz="1600" dirty="0"/>
           </a:p>
@@ -4828,13 +4938,13 @@
       </p:sp>
       <p:sp>
         <p:nvSpPr>
-          <p:cNvPr id="16" name="Step 1 text"/>
+          <p:cNvPr id="21" name="Step 2 text"/>
           <p:cNvSpPr txBox="1"/>
           <p:nvPr/>
         </p:nvSpPr>
         <p:spPr>
           <a:xfrm>
-            <a:off x="777240" y="3886200"/>
+            <a:off x="3611880" y="3886200"/>
             <a:ext cx="2148840" cy="868680"/>
           </a:xfrm>
           <a:prstGeom prst="rect">
@@ -4856,7 +4966,7 @@
                   <a:schemeClr val="tx1"/>
                 </a:solidFill>
               </a:rPr>
-              <a:t>Weekly orders and squad orders via coaches</a:t>
+              <a:t>Baked to order, no long-life additives</a:t>
             </a:r>
             <a:endParaRPr lang="en-US" sz="1400" dirty="0"/>
           </a:p>
@@ -4864,13 +4974,13 @@
       </p:sp>
       <p:sp>
         <p:nvSpPr>
-          <p:cNvPr id="17" name="Arrow 1"/>
+          <p:cNvPr id="22" name="Arrow 2"/>
           <p:cNvSpPr/>
           <p:nvPr/>
         </p:nvSpPr>
         <p:spPr>
           <a:xfrm>
-            <a:off x="3136392" y="3794760"/>
+            <a:off x="5971032" y="3794760"/>
             <a:ext cx="219456" cy="274320"/>
           </a:xfrm>
           <a:prstGeom prst="rightArrow">
@@ -4884,13 +4994,13 @@
       </p:sp>
       <p:sp>
         <p:nvSpPr>
-          <p:cNvPr id="18" name="Step 2 card"/>
+          <p:cNvPr id="23" name="Step 3 card"/>
           <p:cNvSpPr/>
           <p:nvPr/>
         </p:nvSpPr>
         <p:spPr>
           <a:xfrm>
-            <a:off x="3383280" y="3017520"/>
+            <a:off x="6217920" y="3017520"/>
             <a:ext cx="2560320" cy="1828800"/>
           </a:xfrm>
           <a:prstGeom prst="roundRect">
@@ -4906,13 +5016,13 @@
       </p:sp>
       <p:sp>
         <p:nvSpPr>
-          <p:cNvPr id="19" name="Step 2 circle"/>
+          <p:cNvPr id="24" name="Step 3 circle"/>
           <p:cNvSpPr/>
           <p:nvPr/>
         </p:nvSpPr>
         <p:spPr>
           <a:xfrm>
-            <a:off x="3611880" y="3200400"/>
+            <a:off x="6446520" y="3200400"/>
             <a:ext cx="548640" cy="548640"/>
           </a:xfrm>
           <a:prstGeom prst="ellipse">
@@ -4926,7 +5036,7 @@
       </p:sp>
       <p:pic>
         <p:nvPicPr>
-          <p:cNvPr id="20" name="Step 2 icon" descr="Step 2">    </p:cNvPr>
+          <p:cNvPr id="25" name="Step 3 icon" descr="Step 3">    </p:cNvPr>
           <p:cNvPicPr>
             <a:picLocks noChangeAspect="1"/>
           </p:cNvPicPr>
@@ -4940,7 +5050,7 @@
         </p:blipFill>
         <p:spPr>
           <a:xfrm>
-            <a:off x="3749040" y="3337560"/>
+            <a:off x="6583680" y="3337560"/>
             <a:ext cx="274320" cy="274320"/>
           </a:xfrm>
           <a:prstGeom prst="rect">
@@ -4950,13 +5060,13 @@
       </p:pic>
       <p:sp>
         <p:nvSpPr>
-          <p:cNvPr id="21" name="Step 2 title"/>
+          <p:cNvPr id="26" name="Step 3 title"/>
           <p:cNvSpPr txBox="1"/>
           <p:nvPr/>
         </p:nvSpPr>
         <p:spPr>
           <a:xfrm>
-            <a:off x="4251960" y="3200400"/>
+            <a:off x="7086600" y="3200400"/>
             <a:ext cx="1600200" cy="548640"/>
           </a:xfrm>
           <a:prstGeom prst="rect">
@@ -4978,7 +5088,7 @@
                   <a:schemeClr val="tx1"/>
                 </a:solidFill>
               </a:rPr>
-              <a:t>2. Bake</a:t>
+              <a:t>3. Deliver chilled</a:t>
             </a:r>
             <a:endParaRPr lang="en-US" sz="1600" dirty="0"/>
           </a:p>
@@ -4986,13 +5096,13 @@
       </p:sp>
       <p:sp>
         <p:nvSpPr>
-          <p:cNvPr id="22" name="Step 2 text"/>
+          <p:cNvPr id="27" name="Step 3 text"/>
           <p:cNvSpPr txBox="1"/>
           <p:nvPr/>
         </p:nvSpPr>
         <p:spPr>
           <a:xfrm>
-            <a:off x="3611880" y="3886200"/>
+            <a:off x="6446520" y="3886200"/>
             <a:ext cx="2148840" cy="868680"/>
           </a:xfrm>
           <a:prstGeom prst="rect">
@@ -5014,7 +5124,7 @@
                   <a:schemeClr val="tx1"/>
                 </a:solidFill>
               </a:rPr>
-              <a:t>Baked to order, no long-life additives</a:t>
+              <a:t>Hand-delivered in Durham to start</a:t>
             </a:r>
             <a:endParaRPr lang="en-US" sz="1400" dirty="0"/>
           </a:p>
@@ -5022,13 +5132,13 @@
       </p:sp>
       <p:sp>
         <p:nvSpPr>
-          <p:cNvPr id="23" name="Arrow 2"/>
+          <p:cNvPr id="28" name="Arrow 3"/>
           <p:cNvSpPr/>
           <p:nvPr/>
         </p:nvSpPr>
         <p:spPr>
           <a:xfrm>
-            <a:off x="5971032" y="3794760"/>
+            <a:off x="8805672" y="3794760"/>
             <a:ext cx="219456" cy="274320"/>
           </a:xfrm>
           <a:prstGeom prst="rightArrow">
@@ -5042,13 +5152,13 @@
       </p:sp>
       <p:sp>
         <p:nvSpPr>
-          <p:cNvPr id="24" name="Step 3 card"/>
+          <p:cNvPr id="29" name="Step 4 card"/>
           <p:cNvSpPr/>
           <p:nvPr/>
         </p:nvSpPr>
         <p:spPr>
           <a:xfrm>
-            <a:off x="6217920" y="3017520"/>
+            <a:off x="9052560" y="3017520"/>
             <a:ext cx="2560320" cy="1828800"/>
           </a:xfrm>
           <a:prstGeom prst="roundRect">
@@ -5064,13 +5174,13 @@
       </p:sp>
       <p:sp>
         <p:nvSpPr>
-          <p:cNvPr id="25" name="Step 3 circle"/>
+          <p:cNvPr id="30" name="Step 4 circle"/>
           <p:cNvSpPr/>
           <p:nvPr/>
         </p:nvSpPr>
         <p:spPr>
           <a:xfrm>
-            <a:off x="6446520" y="3200400"/>
+            <a:off x="9281160" y="3200400"/>
             <a:ext cx="548640" cy="548640"/>
           </a:xfrm>
           <a:prstGeom prst="ellipse">
@@ -5084,7 +5194,7 @@
       </p:sp>
       <p:pic>
         <p:nvPicPr>
-          <p:cNvPr id="26" name="Step 3 icon" descr="Step 3">    </p:cNvPr>
+          <p:cNvPr id="31" name="Step 4 icon" descr="Step 4">    </p:cNvPr>
           <p:cNvPicPr>
             <a:picLocks noChangeAspect="1"/>
           </p:cNvPicPr>
@@ -5098,164 +5208,6 @@
         </p:blipFill>
         <p:spPr>
           <a:xfrm>
-            <a:off x="6583680" y="3337560"/>
-            <a:ext cx="274320" cy="274320"/>
-          </a:xfrm>
-          <a:prstGeom prst="rect">
-            <a:avLst/>
-          </a:prstGeom>
-        </p:spPr>
-      </p:pic>
-      <p:sp>
-        <p:nvSpPr>
-          <p:cNvPr id="27" name="Step 3 title"/>
-          <p:cNvSpPr txBox="1"/>
-          <p:nvPr/>
-        </p:nvSpPr>
-        <p:spPr>
-          <a:xfrm>
-            <a:off x="7086600" y="3200400"/>
-            <a:ext cx="1600200" cy="548640"/>
-          </a:xfrm>
-          <a:prstGeom prst="rect">
-            <a:avLst/>
-          </a:prstGeom>
-          <a:noFill/>
-          <a:ln/>
-        </p:spPr>
-        <p:txBody>
-          <a:bodyPr wrap="square" lIns="0" tIns="0" rIns="0" bIns="0" rtlCol="0" anchor="ctr"/>
-          <a:lstStyle/>
-          <a:p>
-            <a:pPr indent="0" marL="0">
-              <a:buNone/>
-            </a:pPr>
-            <a:r>
-              <a:rPr lang="en-US" sz="1600" b="1" dirty="0">
-                <a:solidFill>
-                  <a:schemeClr val="tx1"/>
-                </a:solidFill>
-              </a:rPr>
-              <a:t>3. Deliver chilled</a:t>
-            </a:r>
-            <a:endParaRPr lang="en-US" sz="1600" dirty="0"/>
-          </a:p>
-        </p:txBody>
-      </p:sp>
-      <p:sp>
-        <p:nvSpPr>
-          <p:cNvPr id="28" name="Step 3 text"/>
-          <p:cNvSpPr txBox="1"/>
-          <p:nvPr/>
-        </p:nvSpPr>
-        <p:spPr>
-          <a:xfrm>
-            <a:off x="6446520" y="3886200"/>
-            <a:ext cx="2148840" cy="868680"/>
-          </a:xfrm>
-          <a:prstGeom prst="rect">
-            <a:avLst/>
-          </a:prstGeom>
-          <a:noFill/>
-          <a:ln/>
-        </p:spPr>
-        <p:txBody>
-          <a:bodyPr wrap="square" lIns="0" tIns="0" rIns="0" bIns="0" rtlCol="0" anchor="t"/>
-          <a:lstStyle/>
-          <a:p>
-            <a:pPr indent="0" marL="0">
-              <a:buNone/>
-            </a:pPr>
-            <a:r>
-              <a:rPr lang="en-US" sz="1400" dirty="0">
-                <a:solidFill>
-                  <a:schemeClr val="tx1"/>
-                </a:solidFill>
-              </a:rPr>
-              <a:t>Hand-delivered in Durham to start</a:t>
-            </a:r>
-            <a:endParaRPr lang="en-US" sz="1400" dirty="0"/>
-          </a:p>
-        </p:txBody>
-      </p:sp>
-      <p:sp>
-        <p:nvSpPr>
-          <p:cNvPr id="29" name="Arrow 3"/>
-          <p:cNvSpPr/>
-          <p:nvPr/>
-        </p:nvSpPr>
-        <p:spPr>
-          <a:xfrm>
-            <a:off x="8805672" y="3794760"/>
-            <a:ext cx="219456" cy="274320"/>
-          </a:xfrm>
-          <a:prstGeom prst="rightArrow">
-            <a:avLst/>
-          </a:prstGeom>
-          <a:solidFill>
-            <a:schemeClr val="accent1"/>
-          </a:solidFill>
-          <a:ln/>
-        </p:spPr>
-      </p:sp>
-      <p:sp>
-        <p:nvSpPr>
-          <p:cNvPr id="30" name="Step 4 card"/>
-          <p:cNvSpPr/>
-          <p:nvPr/>
-        </p:nvSpPr>
-        <p:spPr>
-          <a:xfrm>
-            <a:off x="9052560" y="3017520"/>
-            <a:ext cx="2560320" cy="1828800"/>
-          </a:xfrm>
-          <a:prstGeom prst="roundRect">
-            <a:avLst>
-              <a:gd name="adj" fmla="val 6000"/>
-            </a:avLst>
-          </a:prstGeom>
-          <a:solidFill>
-            <a:schemeClr val="bg2"/>
-          </a:solidFill>
-          <a:ln/>
-        </p:spPr>
-      </p:sp>
-      <p:sp>
-        <p:nvSpPr>
-          <p:cNvPr id="31" name="Step 4 circle"/>
-          <p:cNvSpPr/>
-          <p:nvPr/>
-        </p:nvSpPr>
-        <p:spPr>
-          <a:xfrm>
-            <a:off x="9281160" y="3200400"/>
-            <a:ext cx="548640" cy="548640"/>
-          </a:xfrm>
-          <a:prstGeom prst="ellipse">
-            <a:avLst/>
-          </a:prstGeom>
-          <a:solidFill>
-            <a:schemeClr val="accent1"/>
-          </a:solidFill>
-          <a:ln/>
-        </p:spPr>
-      </p:sp>
-      <p:pic>
-        <p:nvPicPr>
-          <p:cNvPr id="32" name="Step 4 icon" descr="Step 4">    </p:cNvPr>
-          <p:cNvPicPr>
-            <a:picLocks noChangeAspect="1"/>
-          </p:cNvPicPr>
-          <p:nvPr/>
-        </p:nvPicPr>
-        <p:blipFill>
-          <a:blip r:embed="rId5"/>
-          <a:stretch>
-            <a:fillRect/>
-          </a:stretch>
-        </p:blipFill>
-        <p:spPr>
-          <a:xfrm>
             <a:off x="9418320" y="3337560"/>
             <a:ext cx="274320" cy="274320"/>
           </a:xfrm>
@@ -5266,7 +5218,7 @@
       </p:pic>
       <p:sp>
         <p:nvSpPr>
-          <p:cNvPr id="33" name="Step 4 title"/>
+          <p:cNvPr id="32" name="Step 4 title"/>
           <p:cNvSpPr txBox="1"/>
           <p:nvPr/>
         </p:nvSpPr>
@@ -5302,7 +5254,7 @@
       </p:sp>
       <p:sp>
         <p:nvSpPr>
-          <p:cNvPr id="34" name="Step 4 text"/>
+          <p:cNvPr id="33" name="Step 4 text"/>
           <p:cNvSpPr txBox="1"/>
           <p:nvPr/>
         </p:nvSpPr>
@@ -5338,7 +5290,7 @@
       </p:sp>
       <p:sp>
         <p:nvSpPr>
-          <p:cNvPr id="35" name="Close box"/>
+          <p:cNvPr id="34" name="Close box"/>
           <p:cNvSpPr/>
           <p:nvPr/>
         </p:nvSpPr>
@@ -5360,7 +5312,7 @@
       </p:sp>
       <p:sp>
         <p:nvSpPr>
-          <p:cNvPr id="36" name="Close text"/>
+          <p:cNvPr id="35" name="Close text"/>
           <p:cNvSpPr txBox="1"/>
           <p:nvPr/>
         </p:nvSpPr>
@@ -5435,7 +5387,7 @@
                   <a:schemeClr val="bg1"/>
                 </a:solidFill>
               </a:rPr>
-              <a:t>Graft: fresh, baked, real-food protein for people who train hard. Real food for grafters.</a:t>
+              <a:t>Fresh, baked, real-food protein for people who train hard.</a:t>
             </a:r>
             <a:endParaRPr lang="en-US" sz="1500" dirty="0"/>
           </a:p>
@@ -5495,9 +5447,9 @@
 </file>
 
 <file path=ppt/theme/theme1.xml><?xml version="1.0" encoding="utf-8"?>
-<a:theme xmlns:a="http://schemas.openxmlformats.org/drawingml/2006/main" name="Graft Pitch">
+<a:theme xmlns:a="http://schemas.openxmlformats.org/drawingml/2006/main" name="Pitch">
   <a:themeElements>
-    <a:clrScheme name="Graft Pitch">
+    <a:clrScheme name="Pitch">
       <a:dk1>
         <a:srgbClr val="1C1B19"/>
       </a:dk1>
@@ -5535,7 +5487,7 @@
         <a:srgbClr val="7C2D12"/>
       </a:folHlink>
     </a:clrScheme>
-    <a:fontScheme name="Graft Pitch">
+    <a:fontScheme name="Pitch">
       <a:majorFont>
         <a:latin typeface="Arial"/>
         <a:ea typeface=""/>

</xml_diff>

<commit_message>
Pitch: mention landing page and waitlist in slide 5, script and Q&A
Co-Authored-By: Claude Opus 5.5 <noreply@anthropic.com>
Claude-Session: https://claude.ai/code/session_01GJGkDeLHjnkx4ZbaPKgLVt
</commit_message>
<xml_diff>
--- a/09-pitch/pitch-deck.pptx
+++ b/09-pitch/pitch-deck.pptx
@@ -111,27 +111,27 @@
   <p:extLst>
     <p:ext uri="{521415D9-36F7-43E2-AB2F-B90AF26B5E84}">
       <p14:sectionLst xmlns:p14="http://schemas.microsoft.com/office/powerpoint/2010/main">
-        <p14:section name="Concept" id="{93d16fc2-8181-27e2-58e6-da133b856ab0}">
+        <p14:section name="Concept" id="{cb3f2adf-e1b4-edea-f2ad-7a4473098a89}">
           <p14:sldIdLst>
             <p14:sldId id="256"/>
           </p14:sldIdLst>
         </p14:section>
-        <p14:section name="Problem" id="{5a9cde57-3e62-3efd-4e5d-14555abb3559}">
+        <p14:section name="Problem" id="{23a240cd-898b-16d8-bb22-d974353f0479}">
           <p14:sldIdLst>
             <p14:sldId id="257"/>
           </p14:sldIdLst>
         </p14:section>
-        <p14:section name="Customers" id="{8fbbe425-9d87-4bd9-0474-019888dd1649}">
+        <p14:section name="Customers" id="{2cd4077c-fc7b-719c-d787-9f60d0b081bc}">
           <p14:sldIdLst>
             <p14:sldId id="258"/>
           </p14:sldIdLst>
         </p14:section>
-        <p14:section name="Market" id="{b63c1614-5a80-ec09-f9af-6f7aab6d5b22}">
+        <p14:section name="Market" id="{3b3c79dd-4fae-960a-528e-f8a660805129}">
           <p14:sldIdLst>
             <p14:sldId id="259"/>
           </p14:sldIdLst>
         </p14:section>
-        <p14:section name="Model" id="{dd8ff3c6-d9ed-8cb5-d1be-5377efb09bf2}">
+        <p14:section name="Model" id="{c13a0096-786d-24fc-1f01-4c51a23d4b05}">
           <p14:sldIdLst>
             <p14:sldId id="260"/>
           </p14:sldIdLst>
@@ -892,7 +892,7 @@
           <a:p>
             <a:r>
               <a:rPr lang="en-US" dirty="0"/>
-              <a:t>~60s. I'm testing three formats with the same ingredients: a soft-baked bar, bites and a slice; the taste test decides. About 15 g protein per 50 g, calculated. Because it's real food, it's fresh and chilled, not shelf-stable, so I'm using the Simmer Eats model. Simmer cooks fresh meals that last up to 5 days in the fridge and can be frozen on arrival. People order weekly (and squads order through their coach), I bake to order, deliver chilled around Durham to start, and they eat it within 3 days or freeze it. 'Baked this week, not 12 months ago.' Next: a blind taste test against Barebells, aiming for 7 out of 9, then a free squad trial. What I need: kitchen access and coach introductions. SAY LAST: 'A fresh, baked protein snack made from real food (egg, quark and oats) for athletes who train hard and can't always cook. Baked to order and delivered to squads.' Thank you.</a:t>
+              <a:t>~60s. I'm testing three formats with the same ingredients: a soft-baked bar, bites and a slice; the taste test decides. About 15 g protein per 50 g, calculated. Because it's real food, it's fresh and chilled, not shelf-stable, so I'm using the Simmer Eats model. Simmer cooks fresh meals that last up to 5 days in the fridge and can be frozen on arrival. People order weekly (and squads order through their coach), I bake to order, deliver chilled around Durham to start, and they eat it within 3 days or freeze it. 'Baked this week, not 12 months ago.' Next: my gym poster and a landing page go live on Monday. Both send people to a short survey and a waitlist, so I can count real sign-ups. Then a blind taste test against Barebells, aiming for 7 out of 9, then a free squad trial. What I need: kitchen access and coach introductions. SAY LAST: 'A fresh, baked protein snack made from real food (egg, quark and oats) for athletes who train hard and can't always cook. Baked to order and delivered to squads.' Thank you.</a:t>
             </a:r>
             <a:endParaRPr lang="en-US" dirty="0"/>
           </a:p>
@@ -5351,7 +5351,7 @@
                   <a:schemeClr val="bg1"/>
                 </a:solidFill>
               </a:rPr>
-              <a:t>blind taste test (≥7/9) → free squad trial.  </a:t>
+              <a:t>poster + landing page waitlist (live Monday) → blind taste test (≥7/9) → free squad trial.  </a:t>
             </a:r>
             <a:pPr indent="0" marL="0">
               <a:buNone/>

</xml_diff>

<commit_message>
Deck: competitor gap table, no ingredients, no named clubs; script updated
Co-Authored-By: Claude Opus 5.5 <noreply@anthropic.com>
Claude-Session: https://claude.ai/code/session_01GJGkDeLHjnkx4ZbaPKgLVt
</commit_message>
<xml_diff>
--- a/09-pitch/pitch-deck.pptx
+++ b/09-pitch/pitch-deck.pptx
@@ -506,7 +506,7 @@
           <a:p>
             <a:r>
               <a:rPr lang="en-US" dirty="0"/>
-              <a:t>~50s. SAY FIRST: 'A fresh, baked protein snack made from real food for athletes who train hard and can't always cook. Baked to order and delivered to squads.' I'm Ewan, a Durham Business Management graduate; I train MMA, play football and lift. After two MMA classes back to back I'd eat a full meal and still be hungry. Going from MMA straight to football I had no time to cook. On a same-day weigh-in I had a short window to eat before competing. Every time, the choice was a lab-made protein bar full of powders and sweeteners, or nothing.</a:t>
+              <a:t>~50s. SAY FIRST: 'A fresh, baked protein snack made from real food for athletes who train hard and can't always cook. Baked to order.' I'm Ewan, a Durham Business Management graduate; I train MMA, play football and lift. After two MMA classes back to back I'd eat a full meal and still be hungry. Going from MMA straight to football I had no time to cook. On a same-day weigh-in I had a short window to eat before competing. Every time, the choice was a lab-made protein bar full of powders and sweeteners, or nothing.</a:t>
             </a:r>
             <a:endParaRPr lang="en-US" dirty="0"/>
           </a:p>
@@ -682,7 +682,7 @@
           <a:p>
             <a:r>
               <a:rPr lang="en-US" dirty="0"/>
-              <a:t>~55s. I've spoken to 10 athletes and gym-goers, including a pro footballer and a rugby player, plus the Team Durham S&amp;C coach and a nutrition professor. My typical customer is Jack: trains once a day, plays a sport, is trying to eat well and listens to his coach. 8 of 10 train in the gym and are trying to eat better; their deal-breakers are taste and price. My early adopters are the sharpest slice of Jack: coached Durham squads and my MMA club. Their coaches tell them to eat whole food, and the Team Durham coach watched boxes of Grenade bars go uneaten. One coach means about 25 athletes and one delivery, perfect for a fresh product. It's a migraine, not a vitamin: it happens after almost every session. Honestly, nobody has committed yet; the squad trial tests that.</a:t>
+              <a:t>~55s. I've spoken to 10 athletes and gym-goers, including a pro footballer and a rugby player, plus the Team Durham S&amp;C coach and a nutrition professor. My typical customer is Jack: trains once a day, plays a sport, is trying to eat well and listens to his coach. 8 of 10 train in the gym and are trying to eat better; their deal-breakers are taste and price. Athletes who fit this profile told me they were interested, and I then interviewed them: they want real food and high protein, and they worry about taste and price. The S&amp;C coach told me boxes of Grenade bars given to students went uneaten. I'll test first with coached and combat-sport athletes, because one coach can reach a whole squad. No agreements yet; that's the next step. It's a migraine, not a vitamin: it happens after almost every session. Honestly, nobody has committed yet; the squad trial tests that.</a:t>
             </a:r>
             <a:endParaRPr lang="en-US" dirty="0"/>
           </a:p>
@@ -770,7 +770,7 @@
           <a:p>
             <a:r>
               <a:rPr lang="en-US" dirty="0"/>
-              <a:t>~55s. Protein bars give you protein, but from powders, sweeteners and sugar alcohols. Natural bars are real food but full of sugar. Quark gives real protein, but in a pot, not grab-and-go. I scored 25 UK protein snacks on four tests: at least 10 g protein, real-food protein, no sweeteners, low sugar. 20 have the protein, 11 are low in sugar, only 4 use real-food protein, and none pass all four. [pause] Why does the gap exist? Shops need bars that last months; real food lasts days, so brands use powders and sweeteners. I design around shelf life: bake to order and sell direct to squads. And it can work: in the US, RXBAR built an egg-white bar from a kitchen and sold for $600m, and Perfect Bar proved people buy protein bars from the fridge. Nobody's doing fresh-baked here yet.</a:t>
+              <a:t>~55s. Here's the competition and where the gap comes from. Protein bars like Barebells, Grenade and Fulfil have the protein and low sugar, but it comes from milk protein powders, with sweeteners and sugar alcohols like maltitol. 'Natural' bars like Nākd and Veloforte are real food with no sweeteners, but they carry 13 to 20 g of sugar per 50 g, and Nākd's protein is only 7 g. Bio&amp;Me targets clean eating but has only 9 g of soya protein. Protein quark pots are real protein and fairly low in sugar, though some use sweeteners, but they're a pot with a spoon, not a grab-and-go snack after training. I checked 25 UK snacks on four tests and none passed all four. [pause] Why does the gap exist? Shops need bars that last months; real food lasts days, so brands use powders and sweeteners. I design around shelf life: bake to order and sell direct. And it can work: in the US, RXBAR built a real-food bar from a kitchen and sold for $600m, and Perfect Bar proved people buy protein bars from the fridge. Our snack's ticks are the aim; the recipe is still in testing.</a:t>
             </a:r>
             <a:endParaRPr lang="en-US" dirty="0"/>
           </a:p>
@@ -858,7 +858,7 @@
           <a:p>
             <a:r>
               <a:rPr lang="en-US" dirty="0"/>
-              <a:t>~50s. Same ingredients, three formats in testing: soft-baked bar, bites or a slice; the taste test decides. About 15 g protein per 50 g, calculated, not lab-tested yet. Squads order weekly through their coach; I bake to order, deliver chilled around Durham, eaten within a few days or frozen. Next: on Monday my gym poster and a simple landing page go live; both send people to a two-minute survey and a waitlist, so I'm counting real sign-ups, not compliments. Then a blind taste test against Barebells, aiming for 7 out of 9, then a free squad trial. What I need: kitchen access and coach introductions. SAY LAST: 'A fresh, baked protein snack made from real food for athletes who train hard and can't always cook. Baked to order and delivered to squads.' Thank you.</a:t>
+              <a:t>~50s. Same ingredients, three formats in testing: soft-baked bar, bites or a slice; the taste test decides. The recipe is still being finalised, so I'm not quoting exact numbers yet. People and squads order weekly; I bake to order, deliver chilled around Durham, eaten within a few days or frozen. Next: on Monday my gym poster and a simple landing page go live; both send people to a two-minute survey and a waitlist, so I'm counting real sign-ups, not compliments. Then a blind taste test against Barebells, aiming for 7 out of 9, then a free squad trial. What I need: kitchen access and coach introductions. SAY LAST: 'A fresh, baked protein snack made from real food for athletes who train hard and can't always cook. Baked to order.' Thank you.</a:t>
             </a:r>
             <a:endParaRPr lang="en-US" dirty="0"/>
           </a:p>
@@ -1665,7 +1665,7 @@
                   <a:schemeClr val="bg1"/>
                 </a:solidFill>
               </a:rPr>
-              <a:t>Egg, quark &amp; oats.  Baked to order.  Delivered to squads.</a:t>
+              <a:t>Fresh.  Baked to order.  No powders or sweeteners.</a:t>
             </a:r>
             <a:endParaRPr lang="en-US" sz="2400" dirty="0"/>
           </a:p>
@@ -2430,7 +2430,7 @@
                   <a:schemeClr val="accent5"/>
                 </a:solidFill>
               </a:rPr>
-              <a:t>Early adopters</a:t>
+              <a:t>Early interest</a:t>
             </a:r>
             <a:endParaRPr lang="en-US" sz="2400" dirty="0"/>
           </a:p>
@@ -2466,7 +2466,7 @@
                   <a:schemeClr val="tx1"/>
                 </a:solidFill>
               </a:rPr>
-              <a:t>Coached Durham squads</a:t>
+              <a:t>Athletes who fit this profile</a:t>
             </a:r>
             <a:endParaRPr lang="en-US" sz="2200" dirty="0"/>
           </a:p>
@@ -2480,7 +2480,7 @@
                   <a:schemeClr val="tx1"/>
                 </a:solidFill>
               </a:rPr>
-              <a:t>+ my MMA club.</a:t>
+              <a:t>said they were interested.</a:t>
             </a:r>
             <a:endParaRPr lang="en-US" sz="2200" dirty="0"/>
           </a:p>
@@ -2538,7 +2538,7 @@
                   <a:schemeClr val="tx1"/>
                 </a:solidFill>
               </a:rPr>
-              <a:t>Why them</a:t>
+              <a:t>Then interviewed</a:t>
             </a:r>
             <a:endParaRPr lang="en-US" sz="2400" dirty="0"/>
           </a:p>
@@ -2574,7 +2574,7 @@
                   <a:schemeClr val="tx1"/>
                 </a:solidFill>
               </a:rPr>
-              <a:t>1 coach = 25 athletes</a:t>
+              <a:t>They shared their views:</a:t>
             </a:r>
             <a:endParaRPr lang="en-US" sz="2200" dirty="0"/>
           </a:p>
@@ -2588,7 +2588,21 @@
                   <a:schemeClr val="tx1"/>
                 </a:solidFill>
               </a:rPr>
-              <a:t>= 1 delivery.</a:t>
+              <a:t>want real food, high protein;</a:t>
+            </a:r>
+            <a:endParaRPr lang="en-US" sz="2200" dirty="0"/>
+          </a:p>
+          <a:p>
+            <a:pPr indent="0" marL="0">
+              <a:buNone/>
+            </a:pPr>
+            <a:r>
+              <a:rPr lang="en-US" sz="2200" dirty="0">
+                <a:solidFill>
+                  <a:schemeClr val="tx1"/>
+                </a:solidFill>
+              </a:rPr>
+              <a:t>worried about taste &amp; price.</a:t>
             </a:r>
             <a:endParaRPr lang="en-US" sz="2200" dirty="0"/>
           </a:p>
@@ -2624,7 +2638,7 @@
                   <a:schemeClr val="accent3"/>
                 </a:solidFill>
               </a:rPr>
-              <a:t>Based on 10 athlete interviews + an S&amp;C coach + a nutrition professor.</a:t>
+              <a:t>10 athlete interviews + an S&amp;C coach + a nutrition professor. First test group: coached and combat-sport athletes.</a:t>
             </a:r>
             <a:endParaRPr lang="en-US" sz="1800" dirty="0"/>
           </a:p>
@@ -2732,22 +2746,2256 @@
                   <a:schemeClr val="tx1"/>
                 </a:solidFill>
               </a:rPr>
-              <a:t>The gap: nobody does all three</a:t>
+              <a:t>The gap: nobody does all of it</a:t>
             </a:r>
             <a:endParaRPr lang="en-US" sz="3200" dirty="0"/>
           </a:p>
         </p:txBody>
       </p:sp>
-      <p:sp>
-        <p:nvSpPr>
-          <p:cNvPr id="3" name="Row 1 name"/>
+      <p:graphicFrame>
+        <p:nvGraphicFramePr>
+          <p:cNvPr id="5" name="Competitor table"/>
+          <p:cNvGraphicFramePr>
+            <a:graphicFrameLocks noGrp="1"/>
+          </p:cNvGraphicFramePr>
+          <p:nvPr>
+            <p:extLst>
+              <p:ext uri="{D42A27DB-BD31-4B8C-83A1-F6EECF244321}">
+                <p14:modId xmlns:p14="http://schemas.microsoft.com/office/powerpoint/2010/main" val="1579011935"/>
+              </p:ext>
+            </p:extLst>
+          </p:nvPr>
+        </p:nvGraphicFramePr>
+        <p:xfrm>
+          <a:off x="548640" y="1280160"/>
+          <a:ext cx="11064240" cy="914400"/>
+        </p:xfrm>
+        <a:graphic>
+          <a:graphicData uri="http://schemas.openxmlformats.org/drawingml/2006/table">
+            <a:tbl>
+              <a:tblPr/>
+              <a:tblGrid>
+                <a:gridCol w="3291840"/>
+                <a:gridCol w="1554480"/>
+                <a:gridCol w="1554480"/>
+                <a:gridCol w="1554480"/>
+                <a:gridCol w="1554480"/>
+                <a:gridCol w="1554480"/>
+              </a:tblGrid>
+              <a:tr h="566928">
+                <a:tc>
+                  <a:txBody>
+                    <a:bodyPr/>
+                    <a:lstStyle/>
+                    <a:p>
+                      <a:pPr algn="l" indent="0" marL="0">
+                        <a:buNone/>
+                      </a:pPr>
+                      <a:endParaRPr lang="en-US" sz="1600" dirty="0"/>
+                    </a:p>
+                  </a:txBody>
+                  <a:tcPr marL="73152" marR="73152" marT="73152" marB="73152" anchor="ctr">
+                    <a:lnL w="9525" cap="flat" cmpd="sng" algn="ctr">
+                      <a:solidFill>
+                        <a:srgbClr val="E5E7EB"/>
+                      </a:solidFill>
+                      <a:prstDash val="solid"/>
+                      <a:round/>
+                      <a:headEnd type="none" w="med" len="med"/>
+                      <a:tailEnd type="none" w="med" len="med"/>
+                    </a:lnL>
+                    <a:lnR w="9525" cap="flat" cmpd="sng" algn="ctr">
+                      <a:solidFill>
+                        <a:srgbClr val="E5E7EB"/>
+                      </a:solidFill>
+                      <a:prstDash val="solid"/>
+                      <a:round/>
+                      <a:headEnd type="none" w="med" len="med"/>
+                      <a:tailEnd type="none" w="med" len="med"/>
+                    </a:lnR>
+                    <a:lnT w="9525" cap="flat" cmpd="sng" algn="ctr">
+                      <a:solidFill>
+                        <a:srgbClr val="E5E7EB"/>
+                      </a:solidFill>
+                      <a:prstDash val="solid"/>
+                      <a:round/>
+                      <a:headEnd type="none" w="med" len="med"/>
+                      <a:tailEnd type="none" w="med" len="med"/>
+                    </a:lnT>
+                    <a:lnB w="9525" cap="flat" cmpd="sng" algn="ctr">
+                      <a:solidFill>
+                        <a:srgbClr val="E5E7EB"/>
+                      </a:solidFill>
+                      <a:prstDash val="solid"/>
+                      <a:round/>
+                      <a:headEnd type="none" w="med" len="med"/>
+                      <a:tailEnd type="none" w="med" len="med"/>
+                    </a:lnB>
+                    <a:solidFill>
+                      <a:schemeClr val="tx1"/>
+                    </a:solidFill>
+                  </a:tcPr>
+                </a:tc>
+                <a:tc>
+                  <a:txBody>
+                    <a:bodyPr/>
+                    <a:lstStyle/>
+                    <a:p>
+                      <a:pPr algn="ctr" indent="0" marL="0">
+                        <a:buNone/>
+                      </a:pPr>
+                      <a:r>
+                        <a:rPr lang="en-US" sz="1600" b="1" dirty="0">
+                          <a:solidFill>
+                            <a:schemeClr val="bg1"/>
+                          </a:solidFill>
+                        </a:rPr>
+                        <a:t>High protein</a:t>
+                      </a:r>
+                      <a:endParaRPr lang="en-US" sz="1600" dirty="0"/>
+                    </a:p>
+                  </a:txBody>
+                  <a:tcPr marL="73152" marR="73152" marT="73152" marB="73152" anchor="ctr">
+                    <a:lnL w="9525" cap="flat" cmpd="sng" algn="ctr">
+                      <a:solidFill>
+                        <a:srgbClr val="E5E7EB"/>
+                      </a:solidFill>
+                      <a:prstDash val="solid"/>
+                      <a:round/>
+                      <a:headEnd type="none" w="med" len="med"/>
+                      <a:tailEnd type="none" w="med" len="med"/>
+                    </a:lnL>
+                    <a:lnR w="9525" cap="flat" cmpd="sng" algn="ctr">
+                      <a:solidFill>
+                        <a:srgbClr val="E5E7EB"/>
+                      </a:solidFill>
+                      <a:prstDash val="solid"/>
+                      <a:round/>
+                      <a:headEnd type="none" w="med" len="med"/>
+                      <a:tailEnd type="none" w="med" len="med"/>
+                    </a:lnR>
+                    <a:lnT w="9525" cap="flat" cmpd="sng" algn="ctr">
+                      <a:solidFill>
+                        <a:srgbClr val="E5E7EB"/>
+                      </a:solidFill>
+                      <a:prstDash val="solid"/>
+                      <a:round/>
+                      <a:headEnd type="none" w="med" len="med"/>
+                      <a:tailEnd type="none" w="med" len="med"/>
+                    </a:lnT>
+                    <a:lnB w="9525" cap="flat" cmpd="sng" algn="ctr">
+                      <a:solidFill>
+                        <a:srgbClr val="E5E7EB"/>
+                      </a:solidFill>
+                      <a:prstDash val="solid"/>
+                      <a:round/>
+                      <a:headEnd type="none" w="med" len="med"/>
+                      <a:tailEnd type="none" w="med" len="med"/>
+                    </a:lnB>
+                    <a:solidFill>
+                      <a:schemeClr val="tx1"/>
+                    </a:solidFill>
+                  </a:tcPr>
+                </a:tc>
+                <a:tc>
+                  <a:txBody>
+                    <a:bodyPr/>
+                    <a:lstStyle/>
+                    <a:p>
+                      <a:pPr algn="ctr" indent="0" marL="0">
+                        <a:buNone/>
+                      </a:pPr>
+                      <a:r>
+                        <a:rPr lang="en-US" sz="1600" b="1" dirty="0">
+                          <a:solidFill>
+                            <a:schemeClr val="bg1"/>
+                          </a:solidFill>
+                        </a:rPr>
+                        <a:t>Real-food protein</a:t>
+                      </a:r>
+                      <a:endParaRPr lang="en-US" sz="1600" dirty="0"/>
+                    </a:p>
+                  </a:txBody>
+                  <a:tcPr marL="73152" marR="73152" marT="73152" marB="73152" anchor="ctr">
+                    <a:lnL w="9525" cap="flat" cmpd="sng" algn="ctr">
+                      <a:solidFill>
+                        <a:srgbClr val="E5E7EB"/>
+                      </a:solidFill>
+                      <a:prstDash val="solid"/>
+                      <a:round/>
+                      <a:headEnd type="none" w="med" len="med"/>
+                      <a:tailEnd type="none" w="med" len="med"/>
+                    </a:lnL>
+                    <a:lnR w="9525" cap="flat" cmpd="sng" algn="ctr">
+                      <a:solidFill>
+                        <a:srgbClr val="E5E7EB"/>
+                      </a:solidFill>
+                      <a:prstDash val="solid"/>
+                      <a:round/>
+                      <a:headEnd type="none" w="med" len="med"/>
+                      <a:tailEnd type="none" w="med" len="med"/>
+                    </a:lnR>
+                    <a:lnT w="9525" cap="flat" cmpd="sng" algn="ctr">
+                      <a:solidFill>
+                        <a:srgbClr val="E5E7EB"/>
+                      </a:solidFill>
+                      <a:prstDash val="solid"/>
+                      <a:round/>
+                      <a:headEnd type="none" w="med" len="med"/>
+                      <a:tailEnd type="none" w="med" len="med"/>
+                    </a:lnT>
+                    <a:lnB w="9525" cap="flat" cmpd="sng" algn="ctr">
+                      <a:solidFill>
+                        <a:srgbClr val="E5E7EB"/>
+                      </a:solidFill>
+                      <a:prstDash val="solid"/>
+                      <a:round/>
+                      <a:headEnd type="none" w="med" len="med"/>
+                      <a:tailEnd type="none" w="med" len="med"/>
+                    </a:lnB>
+                    <a:solidFill>
+                      <a:schemeClr val="tx1"/>
+                    </a:solidFill>
+                  </a:tcPr>
+                </a:tc>
+                <a:tc>
+                  <a:txBody>
+                    <a:bodyPr/>
+                    <a:lstStyle/>
+                    <a:p>
+                      <a:pPr algn="ctr" indent="0" marL="0">
+                        <a:buNone/>
+                      </a:pPr>
+                      <a:r>
+                        <a:rPr lang="en-US" sz="1600" b="1" dirty="0">
+                          <a:solidFill>
+                            <a:schemeClr val="bg1"/>
+                          </a:solidFill>
+                        </a:rPr>
+                        <a:t>No sweeteners</a:t>
+                      </a:r>
+                      <a:endParaRPr lang="en-US" sz="1600" dirty="0"/>
+                    </a:p>
+                  </a:txBody>
+                  <a:tcPr marL="73152" marR="73152" marT="73152" marB="73152" anchor="ctr">
+                    <a:lnL w="9525" cap="flat" cmpd="sng" algn="ctr">
+                      <a:solidFill>
+                        <a:srgbClr val="E5E7EB"/>
+                      </a:solidFill>
+                      <a:prstDash val="solid"/>
+                      <a:round/>
+                      <a:headEnd type="none" w="med" len="med"/>
+                      <a:tailEnd type="none" w="med" len="med"/>
+                    </a:lnL>
+                    <a:lnR w="9525" cap="flat" cmpd="sng" algn="ctr">
+                      <a:solidFill>
+                        <a:srgbClr val="E5E7EB"/>
+                      </a:solidFill>
+                      <a:prstDash val="solid"/>
+                      <a:round/>
+                      <a:headEnd type="none" w="med" len="med"/>
+                      <a:tailEnd type="none" w="med" len="med"/>
+                    </a:lnR>
+                    <a:lnT w="9525" cap="flat" cmpd="sng" algn="ctr">
+                      <a:solidFill>
+                        <a:srgbClr val="E5E7EB"/>
+                      </a:solidFill>
+                      <a:prstDash val="solid"/>
+                      <a:round/>
+                      <a:headEnd type="none" w="med" len="med"/>
+                      <a:tailEnd type="none" w="med" len="med"/>
+                    </a:lnT>
+                    <a:lnB w="9525" cap="flat" cmpd="sng" algn="ctr">
+                      <a:solidFill>
+                        <a:srgbClr val="E5E7EB"/>
+                      </a:solidFill>
+                      <a:prstDash val="solid"/>
+                      <a:round/>
+                      <a:headEnd type="none" w="med" len="med"/>
+                      <a:tailEnd type="none" w="med" len="med"/>
+                    </a:lnB>
+                    <a:solidFill>
+                      <a:schemeClr val="tx1"/>
+                    </a:solidFill>
+                  </a:tcPr>
+                </a:tc>
+                <a:tc>
+                  <a:txBody>
+                    <a:bodyPr/>
+                    <a:lstStyle/>
+                    <a:p>
+                      <a:pPr algn="ctr" indent="0" marL="0">
+                        <a:buNone/>
+                      </a:pPr>
+                      <a:r>
+                        <a:rPr lang="en-US" sz="1600" b="1" dirty="0">
+                          <a:solidFill>
+                            <a:schemeClr val="bg1"/>
+                          </a:solidFill>
+                        </a:rPr>
+                        <a:t>Low sugar</a:t>
+                      </a:r>
+                      <a:endParaRPr lang="en-US" sz="1600" dirty="0"/>
+                    </a:p>
+                  </a:txBody>
+                  <a:tcPr marL="73152" marR="73152" marT="73152" marB="73152" anchor="ctr">
+                    <a:lnL w="9525" cap="flat" cmpd="sng" algn="ctr">
+                      <a:solidFill>
+                        <a:srgbClr val="E5E7EB"/>
+                      </a:solidFill>
+                      <a:prstDash val="solid"/>
+                      <a:round/>
+                      <a:headEnd type="none" w="med" len="med"/>
+                      <a:tailEnd type="none" w="med" len="med"/>
+                    </a:lnL>
+                    <a:lnR w="9525" cap="flat" cmpd="sng" algn="ctr">
+                      <a:solidFill>
+                        <a:srgbClr val="E5E7EB"/>
+                      </a:solidFill>
+                      <a:prstDash val="solid"/>
+                      <a:round/>
+                      <a:headEnd type="none" w="med" len="med"/>
+                      <a:tailEnd type="none" w="med" len="med"/>
+                    </a:lnR>
+                    <a:lnT w="9525" cap="flat" cmpd="sng" algn="ctr">
+                      <a:solidFill>
+                        <a:srgbClr val="E5E7EB"/>
+                      </a:solidFill>
+                      <a:prstDash val="solid"/>
+                      <a:round/>
+                      <a:headEnd type="none" w="med" len="med"/>
+                      <a:tailEnd type="none" w="med" len="med"/>
+                    </a:lnT>
+                    <a:lnB w="9525" cap="flat" cmpd="sng" algn="ctr">
+                      <a:solidFill>
+                        <a:srgbClr val="E5E7EB"/>
+                      </a:solidFill>
+                      <a:prstDash val="solid"/>
+                      <a:round/>
+                      <a:headEnd type="none" w="med" len="med"/>
+                      <a:tailEnd type="none" w="med" len="med"/>
+                    </a:lnB>
+                    <a:solidFill>
+                      <a:schemeClr val="tx1"/>
+                    </a:solidFill>
+                  </a:tcPr>
+                </a:tc>
+                <a:tc>
+                  <a:txBody>
+                    <a:bodyPr/>
+                    <a:lstStyle/>
+                    <a:p>
+                      <a:pPr algn="ctr" indent="0" marL="0">
+                        <a:buNone/>
+                      </a:pPr>
+                      <a:r>
+                        <a:rPr lang="en-US" sz="1600" b="1" dirty="0">
+                          <a:solidFill>
+                            <a:schemeClr val="bg1"/>
+                          </a:solidFill>
+                        </a:rPr>
+                        <a:t>Grab-and-go</a:t>
+                      </a:r>
+                      <a:endParaRPr lang="en-US" sz="1600" dirty="0"/>
+                    </a:p>
+                  </a:txBody>
+                  <a:tcPr marL="73152" marR="73152" marT="73152" marB="73152" anchor="ctr">
+                    <a:lnL w="9525" cap="flat" cmpd="sng" algn="ctr">
+                      <a:solidFill>
+                        <a:srgbClr val="E5E7EB"/>
+                      </a:solidFill>
+                      <a:prstDash val="solid"/>
+                      <a:round/>
+                      <a:headEnd type="none" w="med" len="med"/>
+                      <a:tailEnd type="none" w="med" len="med"/>
+                    </a:lnL>
+                    <a:lnR w="9525" cap="flat" cmpd="sng" algn="ctr">
+                      <a:solidFill>
+                        <a:srgbClr val="E5E7EB"/>
+                      </a:solidFill>
+                      <a:prstDash val="solid"/>
+                      <a:round/>
+                      <a:headEnd type="none" w="med" len="med"/>
+                      <a:tailEnd type="none" w="med" len="med"/>
+                    </a:lnR>
+                    <a:lnT w="9525" cap="flat" cmpd="sng" algn="ctr">
+                      <a:solidFill>
+                        <a:srgbClr val="E5E7EB"/>
+                      </a:solidFill>
+                      <a:prstDash val="solid"/>
+                      <a:round/>
+                      <a:headEnd type="none" w="med" len="med"/>
+                      <a:tailEnd type="none" w="med" len="med"/>
+                    </a:lnT>
+                    <a:lnB w="9525" cap="flat" cmpd="sng" algn="ctr">
+                      <a:solidFill>
+                        <a:srgbClr val="E5E7EB"/>
+                      </a:solidFill>
+                      <a:prstDash val="solid"/>
+                      <a:round/>
+                      <a:headEnd type="none" w="med" len="med"/>
+                      <a:tailEnd type="none" w="med" len="med"/>
+                    </a:lnB>
+                    <a:solidFill>
+                      <a:schemeClr val="tx1"/>
+                    </a:solidFill>
+                  </a:tcPr>
+                </a:tc>
+              </a:tr>
+              <a:tr h="566928">
+                <a:tc>
+                  <a:txBody>
+                    <a:bodyPr/>
+                    <a:lstStyle/>
+                    <a:p>
+                      <a:pPr algn="l" indent="0" marL="0">
+                        <a:buNone/>
+                      </a:pPr>
+                      <a:r>
+                        <a:rPr lang="en-US" sz="1600" b="1" dirty="0">
+                          <a:solidFill>
+                            <a:schemeClr val="tx1"/>
+                          </a:solidFill>
+                        </a:rPr>
+                        <a:t>Barebells · Grenade · Fulfil</a:t>
+                      </a:r>
+                      <a:endParaRPr lang="en-US" sz="1600" dirty="0"/>
+                    </a:p>
+                  </a:txBody>
+                  <a:tcPr marL="73152" marR="73152" marT="73152" marB="73152" anchor="ctr">
+                    <a:lnL w="9525" cap="flat" cmpd="sng" algn="ctr">
+                      <a:solidFill>
+                        <a:srgbClr val="E5E7EB"/>
+                      </a:solidFill>
+                      <a:prstDash val="solid"/>
+                      <a:round/>
+                      <a:headEnd type="none" w="med" len="med"/>
+                      <a:tailEnd type="none" w="med" len="med"/>
+                    </a:lnL>
+                    <a:lnR w="9525" cap="flat" cmpd="sng" algn="ctr">
+                      <a:solidFill>
+                        <a:srgbClr val="E5E7EB"/>
+                      </a:solidFill>
+                      <a:prstDash val="solid"/>
+                      <a:round/>
+                      <a:headEnd type="none" w="med" len="med"/>
+                      <a:tailEnd type="none" w="med" len="med"/>
+                    </a:lnR>
+                    <a:lnT w="9525" cap="flat" cmpd="sng" algn="ctr">
+                      <a:solidFill>
+                        <a:srgbClr val="E5E7EB"/>
+                      </a:solidFill>
+                      <a:prstDash val="solid"/>
+                      <a:round/>
+                      <a:headEnd type="none" w="med" len="med"/>
+                      <a:tailEnd type="none" w="med" len="med"/>
+                    </a:lnT>
+                    <a:lnB w="9525" cap="flat" cmpd="sng" algn="ctr">
+                      <a:solidFill>
+                        <a:srgbClr val="E5E7EB"/>
+                      </a:solidFill>
+                      <a:prstDash val="solid"/>
+                      <a:round/>
+                      <a:headEnd type="none" w="med" len="med"/>
+                      <a:tailEnd type="none" w="med" len="med"/>
+                    </a:lnB>
+                    <a:solidFill>
+                      <a:schemeClr val="bg1"/>
+                    </a:solidFill>
+                  </a:tcPr>
+                </a:tc>
+                <a:tc>
+                  <a:txBody>
+                    <a:bodyPr/>
+                    <a:lstStyle/>
+                    <a:p>
+                      <a:pPr algn="ctr" indent="0" marL="0">
+                        <a:buNone/>
+                      </a:pPr>
+                      <a:r>
+                        <a:rPr lang="en-US" sz="2400" dirty="0">
+                          <a:solidFill>
+                            <a:schemeClr val="accent2"/>
+                          </a:solidFill>
+                        </a:rPr>
+                        <a:t>✓</a:t>
+                      </a:r>
+                      <a:endParaRPr lang="en-US" sz="2400" dirty="0"/>
+                    </a:p>
+                  </a:txBody>
+                  <a:tcPr marL="73152" marR="73152" marT="73152" marB="73152" anchor="ctr">
+                    <a:lnL w="9525" cap="flat" cmpd="sng" algn="ctr">
+                      <a:solidFill>
+                        <a:srgbClr val="E5E7EB"/>
+                      </a:solidFill>
+                      <a:prstDash val="solid"/>
+                      <a:round/>
+                      <a:headEnd type="none" w="med" len="med"/>
+                      <a:tailEnd type="none" w="med" len="med"/>
+                    </a:lnL>
+                    <a:lnR w="9525" cap="flat" cmpd="sng" algn="ctr">
+                      <a:solidFill>
+                        <a:srgbClr val="E5E7EB"/>
+                      </a:solidFill>
+                      <a:prstDash val="solid"/>
+                      <a:round/>
+                      <a:headEnd type="none" w="med" len="med"/>
+                      <a:tailEnd type="none" w="med" len="med"/>
+                    </a:lnR>
+                    <a:lnT w="9525" cap="flat" cmpd="sng" algn="ctr">
+                      <a:solidFill>
+                        <a:srgbClr val="E5E7EB"/>
+                      </a:solidFill>
+                      <a:prstDash val="solid"/>
+                      <a:round/>
+                      <a:headEnd type="none" w="med" len="med"/>
+                      <a:tailEnd type="none" w="med" len="med"/>
+                    </a:lnT>
+                    <a:lnB w="9525" cap="flat" cmpd="sng" algn="ctr">
+                      <a:solidFill>
+                        <a:srgbClr val="E5E7EB"/>
+                      </a:solidFill>
+                      <a:prstDash val="solid"/>
+                      <a:round/>
+                      <a:headEnd type="none" w="med" len="med"/>
+                      <a:tailEnd type="none" w="med" len="med"/>
+                    </a:lnB>
+                    <a:solidFill>
+                      <a:schemeClr val="bg1"/>
+                    </a:solidFill>
+                  </a:tcPr>
+                </a:tc>
+                <a:tc>
+                  <a:txBody>
+                    <a:bodyPr/>
+                    <a:lstStyle/>
+                    <a:p>
+                      <a:pPr algn="ctr" indent="0" marL="0">
+                        <a:buNone/>
+                      </a:pPr>
+                      <a:r>
+                        <a:rPr lang="en-US" sz="2400" dirty="0">
+                          <a:solidFill>
+                            <a:schemeClr val="accent1"/>
+                          </a:solidFill>
+                        </a:rPr>
+                        <a:t>✗</a:t>
+                      </a:r>
+                      <a:endParaRPr lang="en-US" sz="2400" dirty="0"/>
+                    </a:p>
+                  </a:txBody>
+                  <a:tcPr marL="73152" marR="73152" marT="73152" marB="73152" anchor="ctr">
+                    <a:lnL w="9525" cap="flat" cmpd="sng" algn="ctr">
+                      <a:solidFill>
+                        <a:srgbClr val="E5E7EB"/>
+                      </a:solidFill>
+                      <a:prstDash val="solid"/>
+                      <a:round/>
+                      <a:headEnd type="none" w="med" len="med"/>
+                      <a:tailEnd type="none" w="med" len="med"/>
+                    </a:lnL>
+                    <a:lnR w="9525" cap="flat" cmpd="sng" algn="ctr">
+                      <a:solidFill>
+                        <a:srgbClr val="E5E7EB"/>
+                      </a:solidFill>
+                      <a:prstDash val="solid"/>
+                      <a:round/>
+                      <a:headEnd type="none" w="med" len="med"/>
+                      <a:tailEnd type="none" w="med" len="med"/>
+                    </a:lnR>
+                    <a:lnT w="9525" cap="flat" cmpd="sng" algn="ctr">
+                      <a:solidFill>
+                        <a:srgbClr val="E5E7EB"/>
+                      </a:solidFill>
+                      <a:prstDash val="solid"/>
+                      <a:round/>
+                      <a:headEnd type="none" w="med" len="med"/>
+                      <a:tailEnd type="none" w="med" len="med"/>
+                    </a:lnT>
+                    <a:lnB w="9525" cap="flat" cmpd="sng" algn="ctr">
+                      <a:solidFill>
+                        <a:srgbClr val="E5E7EB"/>
+                      </a:solidFill>
+                      <a:prstDash val="solid"/>
+                      <a:round/>
+                      <a:headEnd type="none" w="med" len="med"/>
+                      <a:tailEnd type="none" w="med" len="med"/>
+                    </a:lnB>
+                    <a:solidFill>
+                      <a:schemeClr val="bg1"/>
+                    </a:solidFill>
+                  </a:tcPr>
+                </a:tc>
+                <a:tc>
+                  <a:txBody>
+                    <a:bodyPr/>
+                    <a:lstStyle/>
+                    <a:p>
+                      <a:pPr algn="ctr" indent="0" marL="0">
+                        <a:buNone/>
+                      </a:pPr>
+                      <a:r>
+                        <a:rPr lang="en-US" sz="2400" dirty="0">
+                          <a:solidFill>
+                            <a:schemeClr val="accent1"/>
+                          </a:solidFill>
+                        </a:rPr>
+                        <a:t>✗</a:t>
+                      </a:r>
+                      <a:endParaRPr lang="en-US" sz="2400" dirty="0"/>
+                    </a:p>
+                  </a:txBody>
+                  <a:tcPr marL="73152" marR="73152" marT="73152" marB="73152" anchor="ctr">
+                    <a:lnL w="9525" cap="flat" cmpd="sng" algn="ctr">
+                      <a:solidFill>
+                        <a:srgbClr val="E5E7EB"/>
+                      </a:solidFill>
+                      <a:prstDash val="solid"/>
+                      <a:round/>
+                      <a:headEnd type="none" w="med" len="med"/>
+                      <a:tailEnd type="none" w="med" len="med"/>
+                    </a:lnL>
+                    <a:lnR w="9525" cap="flat" cmpd="sng" algn="ctr">
+                      <a:solidFill>
+                        <a:srgbClr val="E5E7EB"/>
+                      </a:solidFill>
+                      <a:prstDash val="solid"/>
+                      <a:round/>
+                      <a:headEnd type="none" w="med" len="med"/>
+                      <a:tailEnd type="none" w="med" len="med"/>
+                    </a:lnR>
+                    <a:lnT w="9525" cap="flat" cmpd="sng" algn="ctr">
+                      <a:solidFill>
+                        <a:srgbClr val="E5E7EB"/>
+                      </a:solidFill>
+                      <a:prstDash val="solid"/>
+                      <a:round/>
+                      <a:headEnd type="none" w="med" len="med"/>
+                      <a:tailEnd type="none" w="med" len="med"/>
+                    </a:lnT>
+                    <a:lnB w="9525" cap="flat" cmpd="sng" algn="ctr">
+                      <a:solidFill>
+                        <a:srgbClr val="E5E7EB"/>
+                      </a:solidFill>
+                      <a:prstDash val="solid"/>
+                      <a:round/>
+                      <a:headEnd type="none" w="med" len="med"/>
+                      <a:tailEnd type="none" w="med" len="med"/>
+                    </a:lnB>
+                    <a:solidFill>
+                      <a:schemeClr val="bg1"/>
+                    </a:solidFill>
+                  </a:tcPr>
+                </a:tc>
+                <a:tc>
+                  <a:txBody>
+                    <a:bodyPr/>
+                    <a:lstStyle/>
+                    <a:p>
+                      <a:pPr algn="ctr" indent="0" marL="0">
+                        <a:buNone/>
+                      </a:pPr>
+                      <a:r>
+                        <a:rPr lang="en-US" sz="2400" dirty="0">
+                          <a:solidFill>
+                            <a:schemeClr val="accent2"/>
+                          </a:solidFill>
+                        </a:rPr>
+                        <a:t>✓</a:t>
+                      </a:r>
+                      <a:endParaRPr lang="en-US" sz="2400" dirty="0"/>
+                    </a:p>
+                  </a:txBody>
+                  <a:tcPr marL="73152" marR="73152" marT="73152" marB="73152" anchor="ctr">
+                    <a:lnL w="9525" cap="flat" cmpd="sng" algn="ctr">
+                      <a:solidFill>
+                        <a:srgbClr val="E5E7EB"/>
+                      </a:solidFill>
+                      <a:prstDash val="solid"/>
+                      <a:round/>
+                      <a:headEnd type="none" w="med" len="med"/>
+                      <a:tailEnd type="none" w="med" len="med"/>
+                    </a:lnL>
+                    <a:lnR w="9525" cap="flat" cmpd="sng" algn="ctr">
+                      <a:solidFill>
+                        <a:srgbClr val="E5E7EB"/>
+                      </a:solidFill>
+                      <a:prstDash val="solid"/>
+                      <a:round/>
+                      <a:headEnd type="none" w="med" len="med"/>
+                      <a:tailEnd type="none" w="med" len="med"/>
+                    </a:lnR>
+                    <a:lnT w="9525" cap="flat" cmpd="sng" algn="ctr">
+                      <a:solidFill>
+                        <a:srgbClr val="E5E7EB"/>
+                      </a:solidFill>
+                      <a:prstDash val="solid"/>
+                      <a:round/>
+                      <a:headEnd type="none" w="med" len="med"/>
+                      <a:tailEnd type="none" w="med" len="med"/>
+                    </a:lnT>
+                    <a:lnB w="9525" cap="flat" cmpd="sng" algn="ctr">
+                      <a:solidFill>
+                        <a:srgbClr val="E5E7EB"/>
+                      </a:solidFill>
+                      <a:prstDash val="solid"/>
+                      <a:round/>
+                      <a:headEnd type="none" w="med" len="med"/>
+                      <a:tailEnd type="none" w="med" len="med"/>
+                    </a:lnB>
+                    <a:solidFill>
+                      <a:schemeClr val="bg1"/>
+                    </a:solidFill>
+                  </a:tcPr>
+                </a:tc>
+                <a:tc>
+                  <a:txBody>
+                    <a:bodyPr/>
+                    <a:lstStyle/>
+                    <a:p>
+                      <a:pPr algn="ctr" indent="0" marL="0">
+                        <a:buNone/>
+                      </a:pPr>
+                      <a:r>
+                        <a:rPr lang="en-US" sz="2400" dirty="0">
+                          <a:solidFill>
+                            <a:schemeClr val="accent2"/>
+                          </a:solidFill>
+                        </a:rPr>
+                        <a:t>✓</a:t>
+                      </a:r>
+                      <a:endParaRPr lang="en-US" sz="2400" dirty="0"/>
+                    </a:p>
+                  </a:txBody>
+                  <a:tcPr marL="73152" marR="73152" marT="73152" marB="73152" anchor="ctr">
+                    <a:lnL w="9525" cap="flat" cmpd="sng" algn="ctr">
+                      <a:solidFill>
+                        <a:srgbClr val="E5E7EB"/>
+                      </a:solidFill>
+                      <a:prstDash val="solid"/>
+                      <a:round/>
+                      <a:headEnd type="none" w="med" len="med"/>
+                      <a:tailEnd type="none" w="med" len="med"/>
+                    </a:lnL>
+                    <a:lnR w="9525" cap="flat" cmpd="sng" algn="ctr">
+                      <a:solidFill>
+                        <a:srgbClr val="E5E7EB"/>
+                      </a:solidFill>
+                      <a:prstDash val="solid"/>
+                      <a:round/>
+                      <a:headEnd type="none" w="med" len="med"/>
+                      <a:tailEnd type="none" w="med" len="med"/>
+                    </a:lnR>
+                    <a:lnT w="9525" cap="flat" cmpd="sng" algn="ctr">
+                      <a:solidFill>
+                        <a:srgbClr val="E5E7EB"/>
+                      </a:solidFill>
+                      <a:prstDash val="solid"/>
+                      <a:round/>
+                      <a:headEnd type="none" w="med" len="med"/>
+                      <a:tailEnd type="none" w="med" len="med"/>
+                    </a:lnT>
+                    <a:lnB w="9525" cap="flat" cmpd="sng" algn="ctr">
+                      <a:solidFill>
+                        <a:srgbClr val="E5E7EB"/>
+                      </a:solidFill>
+                      <a:prstDash val="solid"/>
+                      <a:round/>
+                      <a:headEnd type="none" w="med" len="med"/>
+                      <a:tailEnd type="none" w="med" len="med"/>
+                    </a:lnB>
+                    <a:solidFill>
+                      <a:schemeClr val="bg1"/>
+                    </a:solidFill>
+                  </a:tcPr>
+                </a:tc>
+              </a:tr>
+              <a:tr h="566928">
+                <a:tc>
+                  <a:txBody>
+                    <a:bodyPr/>
+                    <a:lstStyle/>
+                    <a:p>
+                      <a:pPr algn="l" indent="0" marL="0">
+                        <a:buNone/>
+                      </a:pPr>
+                      <a:r>
+                        <a:rPr lang="en-US" sz="1600" b="1" dirty="0">
+                          <a:solidFill>
+                            <a:schemeClr val="tx1"/>
+                          </a:solidFill>
+                        </a:rPr>
+                        <a:t>Nākd · Veloforte</a:t>
+                      </a:r>
+                      <a:endParaRPr lang="en-US" sz="1600" dirty="0"/>
+                    </a:p>
+                  </a:txBody>
+                  <a:tcPr marL="73152" marR="73152" marT="73152" marB="73152" anchor="ctr">
+                    <a:lnL w="9525" cap="flat" cmpd="sng" algn="ctr">
+                      <a:solidFill>
+                        <a:srgbClr val="E5E7EB"/>
+                      </a:solidFill>
+                      <a:prstDash val="solid"/>
+                      <a:round/>
+                      <a:headEnd type="none" w="med" len="med"/>
+                      <a:tailEnd type="none" w="med" len="med"/>
+                    </a:lnL>
+                    <a:lnR w="9525" cap="flat" cmpd="sng" algn="ctr">
+                      <a:solidFill>
+                        <a:srgbClr val="E5E7EB"/>
+                      </a:solidFill>
+                      <a:prstDash val="solid"/>
+                      <a:round/>
+                      <a:headEnd type="none" w="med" len="med"/>
+                      <a:tailEnd type="none" w="med" len="med"/>
+                    </a:lnR>
+                    <a:lnT w="9525" cap="flat" cmpd="sng" algn="ctr">
+                      <a:solidFill>
+                        <a:srgbClr val="E5E7EB"/>
+                      </a:solidFill>
+                      <a:prstDash val="solid"/>
+                      <a:round/>
+                      <a:headEnd type="none" w="med" len="med"/>
+                      <a:tailEnd type="none" w="med" len="med"/>
+                    </a:lnT>
+                    <a:lnB w="9525" cap="flat" cmpd="sng" algn="ctr">
+                      <a:solidFill>
+                        <a:srgbClr val="E5E7EB"/>
+                      </a:solidFill>
+                      <a:prstDash val="solid"/>
+                      <a:round/>
+                      <a:headEnd type="none" w="med" len="med"/>
+                      <a:tailEnd type="none" w="med" len="med"/>
+                    </a:lnB>
+                    <a:solidFill>
+                      <a:schemeClr val="bg1"/>
+                    </a:solidFill>
+                  </a:tcPr>
+                </a:tc>
+                <a:tc>
+                  <a:txBody>
+                    <a:bodyPr/>
+                    <a:lstStyle/>
+                    <a:p>
+                      <a:pPr algn="ctr" indent="0" marL="0">
+                        <a:buNone/>
+                      </a:pPr>
+                      <a:r>
+                        <a:rPr lang="en-US" sz="1600" dirty="0">
+                          <a:solidFill>
+                            <a:schemeClr val="tx1"/>
+                          </a:solidFill>
+                        </a:rPr>
+                        <a:t>Some</a:t>
+                      </a:r>
+                      <a:endParaRPr lang="en-US" sz="1600" dirty="0"/>
+                    </a:p>
+                  </a:txBody>
+                  <a:tcPr marL="73152" marR="73152" marT="73152" marB="73152" anchor="ctr">
+                    <a:lnL w="9525" cap="flat" cmpd="sng" algn="ctr">
+                      <a:solidFill>
+                        <a:srgbClr val="E5E7EB"/>
+                      </a:solidFill>
+                      <a:prstDash val="solid"/>
+                      <a:round/>
+                      <a:headEnd type="none" w="med" len="med"/>
+                      <a:tailEnd type="none" w="med" len="med"/>
+                    </a:lnL>
+                    <a:lnR w="9525" cap="flat" cmpd="sng" algn="ctr">
+                      <a:solidFill>
+                        <a:srgbClr val="E5E7EB"/>
+                      </a:solidFill>
+                      <a:prstDash val="solid"/>
+                      <a:round/>
+                      <a:headEnd type="none" w="med" len="med"/>
+                      <a:tailEnd type="none" w="med" len="med"/>
+                    </a:lnR>
+                    <a:lnT w="9525" cap="flat" cmpd="sng" algn="ctr">
+                      <a:solidFill>
+                        <a:srgbClr val="E5E7EB"/>
+                      </a:solidFill>
+                      <a:prstDash val="solid"/>
+                      <a:round/>
+                      <a:headEnd type="none" w="med" len="med"/>
+                      <a:tailEnd type="none" w="med" len="med"/>
+                    </a:lnT>
+                    <a:lnB w="9525" cap="flat" cmpd="sng" algn="ctr">
+                      <a:solidFill>
+                        <a:srgbClr val="E5E7EB"/>
+                      </a:solidFill>
+                      <a:prstDash val="solid"/>
+                      <a:round/>
+                      <a:headEnd type="none" w="med" len="med"/>
+                      <a:tailEnd type="none" w="med" len="med"/>
+                    </a:lnB>
+                    <a:solidFill>
+                      <a:schemeClr val="bg1"/>
+                    </a:solidFill>
+                  </a:tcPr>
+                </a:tc>
+                <a:tc>
+                  <a:txBody>
+                    <a:bodyPr/>
+                    <a:lstStyle/>
+                    <a:p>
+                      <a:pPr algn="ctr" indent="0" marL="0">
+                        <a:buNone/>
+                      </a:pPr>
+                      <a:r>
+                        <a:rPr lang="en-US" sz="2400" dirty="0">
+                          <a:solidFill>
+                            <a:schemeClr val="accent2"/>
+                          </a:solidFill>
+                        </a:rPr>
+                        <a:t>✓</a:t>
+                      </a:r>
+                      <a:endParaRPr lang="en-US" sz="2400" dirty="0"/>
+                    </a:p>
+                  </a:txBody>
+                  <a:tcPr marL="73152" marR="73152" marT="73152" marB="73152" anchor="ctr">
+                    <a:lnL w="9525" cap="flat" cmpd="sng" algn="ctr">
+                      <a:solidFill>
+                        <a:srgbClr val="E5E7EB"/>
+                      </a:solidFill>
+                      <a:prstDash val="solid"/>
+                      <a:round/>
+                      <a:headEnd type="none" w="med" len="med"/>
+                      <a:tailEnd type="none" w="med" len="med"/>
+                    </a:lnL>
+                    <a:lnR w="9525" cap="flat" cmpd="sng" algn="ctr">
+                      <a:solidFill>
+                        <a:srgbClr val="E5E7EB"/>
+                      </a:solidFill>
+                      <a:prstDash val="solid"/>
+                      <a:round/>
+                      <a:headEnd type="none" w="med" len="med"/>
+                      <a:tailEnd type="none" w="med" len="med"/>
+                    </a:lnR>
+                    <a:lnT w="9525" cap="flat" cmpd="sng" algn="ctr">
+                      <a:solidFill>
+                        <a:srgbClr val="E5E7EB"/>
+                      </a:solidFill>
+                      <a:prstDash val="solid"/>
+                      <a:round/>
+                      <a:headEnd type="none" w="med" len="med"/>
+                      <a:tailEnd type="none" w="med" len="med"/>
+                    </a:lnT>
+                    <a:lnB w="9525" cap="flat" cmpd="sng" algn="ctr">
+                      <a:solidFill>
+                        <a:srgbClr val="E5E7EB"/>
+                      </a:solidFill>
+                      <a:prstDash val="solid"/>
+                      <a:round/>
+                      <a:headEnd type="none" w="med" len="med"/>
+                      <a:tailEnd type="none" w="med" len="med"/>
+                    </a:lnB>
+                    <a:solidFill>
+                      <a:schemeClr val="bg1"/>
+                    </a:solidFill>
+                  </a:tcPr>
+                </a:tc>
+                <a:tc>
+                  <a:txBody>
+                    <a:bodyPr/>
+                    <a:lstStyle/>
+                    <a:p>
+                      <a:pPr algn="ctr" indent="0" marL="0">
+                        <a:buNone/>
+                      </a:pPr>
+                      <a:r>
+                        <a:rPr lang="en-US" sz="2400" dirty="0">
+                          <a:solidFill>
+                            <a:schemeClr val="accent2"/>
+                          </a:solidFill>
+                        </a:rPr>
+                        <a:t>✓</a:t>
+                      </a:r>
+                      <a:endParaRPr lang="en-US" sz="2400" dirty="0"/>
+                    </a:p>
+                  </a:txBody>
+                  <a:tcPr marL="73152" marR="73152" marT="73152" marB="73152" anchor="ctr">
+                    <a:lnL w="9525" cap="flat" cmpd="sng" algn="ctr">
+                      <a:solidFill>
+                        <a:srgbClr val="E5E7EB"/>
+                      </a:solidFill>
+                      <a:prstDash val="solid"/>
+                      <a:round/>
+                      <a:headEnd type="none" w="med" len="med"/>
+                      <a:tailEnd type="none" w="med" len="med"/>
+                    </a:lnL>
+                    <a:lnR w="9525" cap="flat" cmpd="sng" algn="ctr">
+                      <a:solidFill>
+                        <a:srgbClr val="E5E7EB"/>
+                      </a:solidFill>
+                      <a:prstDash val="solid"/>
+                      <a:round/>
+                      <a:headEnd type="none" w="med" len="med"/>
+                      <a:tailEnd type="none" w="med" len="med"/>
+                    </a:lnR>
+                    <a:lnT w="9525" cap="flat" cmpd="sng" algn="ctr">
+                      <a:solidFill>
+                        <a:srgbClr val="E5E7EB"/>
+                      </a:solidFill>
+                      <a:prstDash val="solid"/>
+                      <a:round/>
+                      <a:headEnd type="none" w="med" len="med"/>
+                      <a:tailEnd type="none" w="med" len="med"/>
+                    </a:lnT>
+                    <a:lnB w="9525" cap="flat" cmpd="sng" algn="ctr">
+                      <a:solidFill>
+                        <a:srgbClr val="E5E7EB"/>
+                      </a:solidFill>
+                      <a:prstDash val="solid"/>
+                      <a:round/>
+                      <a:headEnd type="none" w="med" len="med"/>
+                      <a:tailEnd type="none" w="med" len="med"/>
+                    </a:lnB>
+                    <a:solidFill>
+                      <a:schemeClr val="bg1"/>
+                    </a:solidFill>
+                  </a:tcPr>
+                </a:tc>
+                <a:tc>
+                  <a:txBody>
+                    <a:bodyPr/>
+                    <a:lstStyle/>
+                    <a:p>
+                      <a:pPr algn="ctr" indent="0" marL="0">
+                        <a:buNone/>
+                      </a:pPr>
+                      <a:r>
+                        <a:rPr lang="en-US" sz="2400" dirty="0">
+                          <a:solidFill>
+                            <a:schemeClr val="accent1"/>
+                          </a:solidFill>
+                        </a:rPr>
+                        <a:t>✗</a:t>
+                      </a:r>
+                      <a:endParaRPr lang="en-US" sz="2400" dirty="0"/>
+                    </a:p>
+                  </a:txBody>
+                  <a:tcPr marL="73152" marR="73152" marT="73152" marB="73152" anchor="ctr">
+                    <a:lnL w="9525" cap="flat" cmpd="sng" algn="ctr">
+                      <a:solidFill>
+                        <a:srgbClr val="E5E7EB"/>
+                      </a:solidFill>
+                      <a:prstDash val="solid"/>
+                      <a:round/>
+                      <a:headEnd type="none" w="med" len="med"/>
+                      <a:tailEnd type="none" w="med" len="med"/>
+                    </a:lnL>
+                    <a:lnR w="9525" cap="flat" cmpd="sng" algn="ctr">
+                      <a:solidFill>
+                        <a:srgbClr val="E5E7EB"/>
+                      </a:solidFill>
+                      <a:prstDash val="solid"/>
+                      <a:round/>
+                      <a:headEnd type="none" w="med" len="med"/>
+                      <a:tailEnd type="none" w="med" len="med"/>
+                    </a:lnR>
+                    <a:lnT w="9525" cap="flat" cmpd="sng" algn="ctr">
+                      <a:solidFill>
+                        <a:srgbClr val="E5E7EB"/>
+                      </a:solidFill>
+                      <a:prstDash val="solid"/>
+                      <a:round/>
+                      <a:headEnd type="none" w="med" len="med"/>
+                      <a:tailEnd type="none" w="med" len="med"/>
+                    </a:lnT>
+                    <a:lnB w="9525" cap="flat" cmpd="sng" algn="ctr">
+                      <a:solidFill>
+                        <a:srgbClr val="E5E7EB"/>
+                      </a:solidFill>
+                      <a:prstDash val="solid"/>
+                      <a:round/>
+                      <a:headEnd type="none" w="med" len="med"/>
+                      <a:tailEnd type="none" w="med" len="med"/>
+                    </a:lnB>
+                    <a:solidFill>
+                      <a:schemeClr val="bg1"/>
+                    </a:solidFill>
+                  </a:tcPr>
+                </a:tc>
+                <a:tc>
+                  <a:txBody>
+                    <a:bodyPr/>
+                    <a:lstStyle/>
+                    <a:p>
+                      <a:pPr algn="ctr" indent="0" marL="0">
+                        <a:buNone/>
+                      </a:pPr>
+                      <a:r>
+                        <a:rPr lang="en-US" sz="2400" dirty="0">
+                          <a:solidFill>
+                            <a:schemeClr val="accent2"/>
+                          </a:solidFill>
+                        </a:rPr>
+                        <a:t>✓</a:t>
+                      </a:r>
+                      <a:endParaRPr lang="en-US" sz="2400" dirty="0"/>
+                    </a:p>
+                  </a:txBody>
+                  <a:tcPr marL="73152" marR="73152" marT="73152" marB="73152" anchor="ctr">
+                    <a:lnL w="9525" cap="flat" cmpd="sng" algn="ctr">
+                      <a:solidFill>
+                        <a:srgbClr val="E5E7EB"/>
+                      </a:solidFill>
+                      <a:prstDash val="solid"/>
+                      <a:round/>
+                      <a:headEnd type="none" w="med" len="med"/>
+                      <a:tailEnd type="none" w="med" len="med"/>
+                    </a:lnL>
+                    <a:lnR w="9525" cap="flat" cmpd="sng" algn="ctr">
+                      <a:solidFill>
+                        <a:srgbClr val="E5E7EB"/>
+                      </a:solidFill>
+                      <a:prstDash val="solid"/>
+                      <a:round/>
+                      <a:headEnd type="none" w="med" len="med"/>
+                      <a:tailEnd type="none" w="med" len="med"/>
+                    </a:lnR>
+                    <a:lnT w="9525" cap="flat" cmpd="sng" algn="ctr">
+                      <a:solidFill>
+                        <a:srgbClr val="E5E7EB"/>
+                      </a:solidFill>
+                      <a:prstDash val="solid"/>
+                      <a:round/>
+                      <a:headEnd type="none" w="med" len="med"/>
+                      <a:tailEnd type="none" w="med" len="med"/>
+                    </a:lnT>
+                    <a:lnB w="9525" cap="flat" cmpd="sng" algn="ctr">
+                      <a:solidFill>
+                        <a:srgbClr val="E5E7EB"/>
+                      </a:solidFill>
+                      <a:prstDash val="solid"/>
+                      <a:round/>
+                      <a:headEnd type="none" w="med" len="med"/>
+                      <a:tailEnd type="none" w="med" len="med"/>
+                    </a:lnB>
+                    <a:solidFill>
+                      <a:schemeClr val="bg1"/>
+                    </a:solidFill>
+                  </a:tcPr>
+                </a:tc>
+              </a:tr>
+              <a:tr h="566928">
+                <a:tc>
+                  <a:txBody>
+                    <a:bodyPr/>
+                    <a:lstStyle/>
+                    <a:p>
+                      <a:pPr algn="l" indent="0" marL="0">
+                        <a:buNone/>
+                      </a:pPr>
+                      <a:r>
+                        <a:rPr lang="en-US" sz="1600" b="1" dirty="0">
+                          <a:solidFill>
+                            <a:schemeClr val="tx1"/>
+                          </a:solidFill>
+                        </a:rPr>
+                        <a:t>Bio&amp;Me</a:t>
+                      </a:r>
+                      <a:endParaRPr lang="en-US" sz="1600" dirty="0"/>
+                    </a:p>
+                  </a:txBody>
+                  <a:tcPr marL="73152" marR="73152" marT="73152" marB="73152" anchor="ctr">
+                    <a:lnL w="9525" cap="flat" cmpd="sng" algn="ctr">
+                      <a:solidFill>
+                        <a:srgbClr val="E5E7EB"/>
+                      </a:solidFill>
+                      <a:prstDash val="solid"/>
+                      <a:round/>
+                      <a:headEnd type="none" w="med" len="med"/>
+                      <a:tailEnd type="none" w="med" len="med"/>
+                    </a:lnL>
+                    <a:lnR w="9525" cap="flat" cmpd="sng" algn="ctr">
+                      <a:solidFill>
+                        <a:srgbClr val="E5E7EB"/>
+                      </a:solidFill>
+                      <a:prstDash val="solid"/>
+                      <a:round/>
+                      <a:headEnd type="none" w="med" len="med"/>
+                      <a:tailEnd type="none" w="med" len="med"/>
+                    </a:lnR>
+                    <a:lnT w="9525" cap="flat" cmpd="sng" algn="ctr">
+                      <a:solidFill>
+                        <a:srgbClr val="E5E7EB"/>
+                      </a:solidFill>
+                      <a:prstDash val="solid"/>
+                      <a:round/>
+                      <a:headEnd type="none" w="med" len="med"/>
+                      <a:tailEnd type="none" w="med" len="med"/>
+                    </a:lnT>
+                    <a:lnB w="9525" cap="flat" cmpd="sng" algn="ctr">
+                      <a:solidFill>
+                        <a:srgbClr val="E5E7EB"/>
+                      </a:solidFill>
+                      <a:prstDash val="solid"/>
+                      <a:round/>
+                      <a:headEnd type="none" w="med" len="med"/>
+                      <a:tailEnd type="none" w="med" len="med"/>
+                    </a:lnB>
+                    <a:solidFill>
+                      <a:schemeClr val="bg1"/>
+                    </a:solidFill>
+                  </a:tcPr>
+                </a:tc>
+                <a:tc>
+                  <a:txBody>
+                    <a:bodyPr/>
+                    <a:lstStyle/>
+                    <a:p>
+                      <a:pPr algn="ctr" indent="0" marL="0">
+                        <a:buNone/>
+                      </a:pPr>
+                      <a:r>
+                        <a:rPr lang="en-US" sz="2400" dirty="0">
+                          <a:solidFill>
+                            <a:schemeClr val="accent1"/>
+                          </a:solidFill>
+                        </a:rPr>
+                        <a:t>✗</a:t>
+                      </a:r>
+                      <a:endParaRPr lang="en-US" sz="2400" dirty="0"/>
+                    </a:p>
+                  </a:txBody>
+                  <a:tcPr marL="73152" marR="73152" marT="73152" marB="73152" anchor="ctr">
+                    <a:lnL w="9525" cap="flat" cmpd="sng" algn="ctr">
+                      <a:solidFill>
+                        <a:srgbClr val="E5E7EB"/>
+                      </a:solidFill>
+                      <a:prstDash val="solid"/>
+                      <a:round/>
+                      <a:headEnd type="none" w="med" len="med"/>
+                      <a:tailEnd type="none" w="med" len="med"/>
+                    </a:lnL>
+                    <a:lnR w="9525" cap="flat" cmpd="sng" algn="ctr">
+                      <a:solidFill>
+                        <a:srgbClr val="E5E7EB"/>
+                      </a:solidFill>
+                      <a:prstDash val="solid"/>
+                      <a:round/>
+                      <a:headEnd type="none" w="med" len="med"/>
+                      <a:tailEnd type="none" w="med" len="med"/>
+                    </a:lnR>
+                    <a:lnT w="9525" cap="flat" cmpd="sng" algn="ctr">
+                      <a:solidFill>
+                        <a:srgbClr val="E5E7EB"/>
+                      </a:solidFill>
+                      <a:prstDash val="solid"/>
+                      <a:round/>
+                      <a:headEnd type="none" w="med" len="med"/>
+                      <a:tailEnd type="none" w="med" len="med"/>
+                    </a:lnT>
+                    <a:lnB w="9525" cap="flat" cmpd="sng" algn="ctr">
+                      <a:solidFill>
+                        <a:srgbClr val="E5E7EB"/>
+                      </a:solidFill>
+                      <a:prstDash val="solid"/>
+                      <a:round/>
+                      <a:headEnd type="none" w="med" len="med"/>
+                      <a:tailEnd type="none" w="med" len="med"/>
+                    </a:lnB>
+                    <a:solidFill>
+                      <a:schemeClr val="bg1"/>
+                    </a:solidFill>
+                  </a:tcPr>
+                </a:tc>
+                <a:tc>
+                  <a:txBody>
+                    <a:bodyPr/>
+                    <a:lstStyle/>
+                    <a:p>
+                      <a:pPr algn="ctr" indent="0" marL="0">
+                        <a:buNone/>
+                      </a:pPr>
+                      <a:r>
+                        <a:rPr lang="en-US" sz="2400" dirty="0">
+                          <a:solidFill>
+                            <a:schemeClr val="accent1"/>
+                          </a:solidFill>
+                        </a:rPr>
+                        <a:t>✗</a:t>
+                      </a:r>
+                      <a:endParaRPr lang="en-US" sz="2400" dirty="0"/>
+                    </a:p>
+                  </a:txBody>
+                  <a:tcPr marL="73152" marR="73152" marT="73152" marB="73152" anchor="ctr">
+                    <a:lnL w="9525" cap="flat" cmpd="sng" algn="ctr">
+                      <a:solidFill>
+                        <a:srgbClr val="E5E7EB"/>
+                      </a:solidFill>
+                      <a:prstDash val="solid"/>
+                      <a:round/>
+                      <a:headEnd type="none" w="med" len="med"/>
+                      <a:tailEnd type="none" w="med" len="med"/>
+                    </a:lnL>
+                    <a:lnR w="9525" cap="flat" cmpd="sng" algn="ctr">
+                      <a:solidFill>
+                        <a:srgbClr val="E5E7EB"/>
+                      </a:solidFill>
+                      <a:prstDash val="solid"/>
+                      <a:round/>
+                      <a:headEnd type="none" w="med" len="med"/>
+                      <a:tailEnd type="none" w="med" len="med"/>
+                    </a:lnR>
+                    <a:lnT w="9525" cap="flat" cmpd="sng" algn="ctr">
+                      <a:solidFill>
+                        <a:srgbClr val="E5E7EB"/>
+                      </a:solidFill>
+                      <a:prstDash val="solid"/>
+                      <a:round/>
+                      <a:headEnd type="none" w="med" len="med"/>
+                      <a:tailEnd type="none" w="med" len="med"/>
+                    </a:lnT>
+                    <a:lnB w="9525" cap="flat" cmpd="sng" algn="ctr">
+                      <a:solidFill>
+                        <a:srgbClr val="E5E7EB"/>
+                      </a:solidFill>
+                      <a:prstDash val="solid"/>
+                      <a:round/>
+                      <a:headEnd type="none" w="med" len="med"/>
+                      <a:tailEnd type="none" w="med" len="med"/>
+                    </a:lnB>
+                    <a:solidFill>
+                      <a:schemeClr val="bg1"/>
+                    </a:solidFill>
+                  </a:tcPr>
+                </a:tc>
+                <a:tc>
+                  <a:txBody>
+                    <a:bodyPr/>
+                    <a:lstStyle/>
+                    <a:p>
+                      <a:pPr algn="ctr" indent="0" marL="0">
+                        <a:buNone/>
+                      </a:pPr>
+                      <a:r>
+                        <a:rPr lang="en-US" sz="2400" dirty="0">
+                          <a:solidFill>
+                            <a:schemeClr val="accent2"/>
+                          </a:solidFill>
+                        </a:rPr>
+                        <a:t>✓</a:t>
+                      </a:r>
+                      <a:endParaRPr lang="en-US" sz="2400" dirty="0"/>
+                    </a:p>
+                  </a:txBody>
+                  <a:tcPr marL="73152" marR="73152" marT="73152" marB="73152" anchor="ctr">
+                    <a:lnL w="9525" cap="flat" cmpd="sng" algn="ctr">
+                      <a:solidFill>
+                        <a:srgbClr val="E5E7EB"/>
+                      </a:solidFill>
+                      <a:prstDash val="solid"/>
+                      <a:round/>
+                      <a:headEnd type="none" w="med" len="med"/>
+                      <a:tailEnd type="none" w="med" len="med"/>
+                    </a:lnL>
+                    <a:lnR w="9525" cap="flat" cmpd="sng" algn="ctr">
+                      <a:solidFill>
+                        <a:srgbClr val="E5E7EB"/>
+                      </a:solidFill>
+                      <a:prstDash val="solid"/>
+                      <a:round/>
+                      <a:headEnd type="none" w="med" len="med"/>
+                      <a:tailEnd type="none" w="med" len="med"/>
+                    </a:lnR>
+                    <a:lnT w="9525" cap="flat" cmpd="sng" algn="ctr">
+                      <a:solidFill>
+                        <a:srgbClr val="E5E7EB"/>
+                      </a:solidFill>
+                      <a:prstDash val="solid"/>
+                      <a:round/>
+                      <a:headEnd type="none" w="med" len="med"/>
+                      <a:tailEnd type="none" w="med" len="med"/>
+                    </a:lnT>
+                    <a:lnB w="9525" cap="flat" cmpd="sng" algn="ctr">
+                      <a:solidFill>
+                        <a:srgbClr val="E5E7EB"/>
+                      </a:solidFill>
+                      <a:prstDash val="solid"/>
+                      <a:round/>
+                      <a:headEnd type="none" w="med" len="med"/>
+                      <a:tailEnd type="none" w="med" len="med"/>
+                    </a:lnB>
+                    <a:solidFill>
+                      <a:schemeClr val="bg1"/>
+                    </a:solidFill>
+                  </a:tcPr>
+                </a:tc>
+                <a:tc>
+                  <a:txBody>
+                    <a:bodyPr/>
+                    <a:lstStyle/>
+                    <a:p>
+                      <a:pPr algn="ctr" indent="0" marL="0">
+                        <a:buNone/>
+                      </a:pPr>
+                      <a:r>
+                        <a:rPr lang="en-US" sz="2400" dirty="0">
+                          <a:solidFill>
+                            <a:schemeClr val="accent1"/>
+                          </a:solidFill>
+                        </a:rPr>
+                        <a:t>✗</a:t>
+                      </a:r>
+                      <a:endParaRPr lang="en-US" sz="2400" dirty="0"/>
+                    </a:p>
+                  </a:txBody>
+                  <a:tcPr marL="73152" marR="73152" marT="73152" marB="73152" anchor="ctr">
+                    <a:lnL w="9525" cap="flat" cmpd="sng" algn="ctr">
+                      <a:solidFill>
+                        <a:srgbClr val="E5E7EB"/>
+                      </a:solidFill>
+                      <a:prstDash val="solid"/>
+                      <a:round/>
+                      <a:headEnd type="none" w="med" len="med"/>
+                      <a:tailEnd type="none" w="med" len="med"/>
+                    </a:lnL>
+                    <a:lnR w="9525" cap="flat" cmpd="sng" algn="ctr">
+                      <a:solidFill>
+                        <a:srgbClr val="E5E7EB"/>
+                      </a:solidFill>
+                      <a:prstDash val="solid"/>
+                      <a:round/>
+                      <a:headEnd type="none" w="med" len="med"/>
+                      <a:tailEnd type="none" w="med" len="med"/>
+                    </a:lnR>
+                    <a:lnT w="9525" cap="flat" cmpd="sng" algn="ctr">
+                      <a:solidFill>
+                        <a:srgbClr val="E5E7EB"/>
+                      </a:solidFill>
+                      <a:prstDash val="solid"/>
+                      <a:round/>
+                      <a:headEnd type="none" w="med" len="med"/>
+                      <a:tailEnd type="none" w="med" len="med"/>
+                    </a:lnT>
+                    <a:lnB w="9525" cap="flat" cmpd="sng" algn="ctr">
+                      <a:solidFill>
+                        <a:srgbClr val="E5E7EB"/>
+                      </a:solidFill>
+                      <a:prstDash val="solid"/>
+                      <a:round/>
+                      <a:headEnd type="none" w="med" len="med"/>
+                      <a:tailEnd type="none" w="med" len="med"/>
+                    </a:lnB>
+                    <a:solidFill>
+                      <a:schemeClr val="bg1"/>
+                    </a:solidFill>
+                  </a:tcPr>
+                </a:tc>
+                <a:tc>
+                  <a:txBody>
+                    <a:bodyPr/>
+                    <a:lstStyle/>
+                    <a:p>
+                      <a:pPr algn="ctr" indent="0" marL="0">
+                        <a:buNone/>
+                      </a:pPr>
+                      <a:r>
+                        <a:rPr lang="en-US" sz="2400" dirty="0">
+                          <a:solidFill>
+                            <a:schemeClr val="accent2"/>
+                          </a:solidFill>
+                        </a:rPr>
+                        <a:t>✓</a:t>
+                      </a:r>
+                      <a:endParaRPr lang="en-US" sz="2400" dirty="0"/>
+                    </a:p>
+                  </a:txBody>
+                  <a:tcPr marL="73152" marR="73152" marT="73152" marB="73152" anchor="ctr">
+                    <a:lnL w="9525" cap="flat" cmpd="sng" algn="ctr">
+                      <a:solidFill>
+                        <a:srgbClr val="E5E7EB"/>
+                      </a:solidFill>
+                      <a:prstDash val="solid"/>
+                      <a:round/>
+                      <a:headEnd type="none" w="med" len="med"/>
+                      <a:tailEnd type="none" w="med" len="med"/>
+                    </a:lnL>
+                    <a:lnR w="9525" cap="flat" cmpd="sng" algn="ctr">
+                      <a:solidFill>
+                        <a:srgbClr val="E5E7EB"/>
+                      </a:solidFill>
+                      <a:prstDash val="solid"/>
+                      <a:round/>
+                      <a:headEnd type="none" w="med" len="med"/>
+                      <a:tailEnd type="none" w="med" len="med"/>
+                    </a:lnR>
+                    <a:lnT w="9525" cap="flat" cmpd="sng" algn="ctr">
+                      <a:solidFill>
+                        <a:srgbClr val="E5E7EB"/>
+                      </a:solidFill>
+                      <a:prstDash val="solid"/>
+                      <a:round/>
+                      <a:headEnd type="none" w="med" len="med"/>
+                      <a:tailEnd type="none" w="med" len="med"/>
+                    </a:lnT>
+                    <a:lnB w="9525" cap="flat" cmpd="sng" algn="ctr">
+                      <a:solidFill>
+                        <a:srgbClr val="E5E7EB"/>
+                      </a:solidFill>
+                      <a:prstDash val="solid"/>
+                      <a:round/>
+                      <a:headEnd type="none" w="med" len="med"/>
+                      <a:tailEnd type="none" w="med" len="med"/>
+                    </a:lnB>
+                    <a:solidFill>
+                      <a:schemeClr val="bg1"/>
+                    </a:solidFill>
+                  </a:tcPr>
+                </a:tc>
+              </a:tr>
+              <a:tr h="566928">
+                <a:tc>
+                  <a:txBody>
+                    <a:bodyPr/>
+                    <a:lstStyle/>
+                    <a:p>
+                      <a:pPr algn="l" indent="0" marL="0">
+                        <a:buNone/>
+                      </a:pPr>
+                      <a:r>
+                        <a:rPr lang="en-US" sz="1600" b="1" dirty="0">
+                          <a:solidFill>
+                            <a:schemeClr val="tx1"/>
+                          </a:solidFill>
+                        </a:rPr>
+                        <a:t>Protein quark pots</a:t>
+                      </a:r>
+                      <a:endParaRPr lang="en-US" sz="1600" dirty="0"/>
+                    </a:p>
+                  </a:txBody>
+                  <a:tcPr marL="73152" marR="73152" marT="73152" marB="73152" anchor="ctr">
+                    <a:lnL w="9525" cap="flat" cmpd="sng" algn="ctr">
+                      <a:solidFill>
+                        <a:srgbClr val="E5E7EB"/>
+                      </a:solidFill>
+                      <a:prstDash val="solid"/>
+                      <a:round/>
+                      <a:headEnd type="none" w="med" len="med"/>
+                      <a:tailEnd type="none" w="med" len="med"/>
+                    </a:lnL>
+                    <a:lnR w="9525" cap="flat" cmpd="sng" algn="ctr">
+                      <a:solidFill>
+                        <a:srgbClr val="E5E7EB"/>
+                      </a:solidFill>
+                      <a:prstDash val="solid"/>
+                      <a:round/>
+                      <a:headEnd type="none" w="med" len="med"/>
+                      <a:tailEnd type="none" w="med" len="med"/>
+                    </a:lnR>
+                    <a:lnT w="9525" cap="flat" cmpd="sng" algn="ctr">
+                      <a:solidFill>
+                        <a:srgbClr val="E5E7EB"/>
+                      </a:solidFill>
+                      <a:prstDash val="solid"/>
+                      <a:round/>
+                      <a:headEnd type="none" w="med" len="med"/>
+                      <a:tailEnd type="none" w="med" len="med"/>
+                    </a:lnT>
+                    <a:lnB w="9525" cap="flat" cmpd="sng" algn="ctr">
+                      <a:solidFill>
+                        <a:srgbClr val="E5E7EB"/>
+                      </a:solidFill>
+                      <a:prstDash val="solid"/>
+                      <a:round/>
+                      <a:headEnd type="none" w="med" len="med"/>
+                      <a:tailEnd type="none" w="med" len="med"/>
+                    </a:lnB>
+                    <a:solidFill>
+                      <a:schemeClr val="bg1"/>
+                    </a:solidFill>
+                  </a:tcPr>
+                </a:tc>
+                <a:tc>
+                  <a:txBody>
+                    <a:bodyPr/>
+                    <a:lstStyle/>
+                    <a:p>
+                      <a:pPr algn="ctr" indent="0" marL="0">
+                        <a:buNone/>
+                      </a:pPr>
+                      <a:r>
+                        <a:rPr lang="en-US" sz="2400" dirty="0">
+                          <a:solidFill>
+                            <a:schemeClr val="accent2"/>
+                          </a:solidFill>
+                        </a:rPr>
+                        <a:t>✓</a:t>
+                      </a:r>
+                      <a:endParaRPr lang="en-US" sz="2400" dirty="0"/>
+                    </a:p>
+                  </a:txBody>
+                  <a:tcPr marL="73152" marR="73152" marT="73152" marB="73152" anchor="ctr">
+                    <a:lnL w="9525" cap="flat" cmpd="sng" algn="ctr">
+                      <a:solidFill>
+                        <a:srgbClr val="E5E7EB"/>
+                      </a:solidFill>
+                      <a:prstDash val="solid"/>
+                      <a:round/>
+                      <a:headEnd type="none" w="med" len="med"/>
+                      <a:tailEnd type="none" w="med" len="med"/>
+                    </a:lnL>
+                    <a:lnR w="9525" cap="flat" cmpd="sng" algn="ctr">
+                      <a:solidFill>
+                        <a:srgbClr val="E5E7EB"/>
+                      </a:solidFill>
+                      <a:prstDash val="solid"/>
+                      <a:round/>
+                      <a:headEnd type="none" w="med" len="med"/>
+                      <a:tailEnd type="none" w="med" len="med"/>
+                    </a:lnR>
+                    <a:lnT w="9525" cap="flat" cmpd="sng" algn="ctr">
+                      <a:solidFill>
+                        <a:srgbClr val="E5E7EB"/>
+                      </a:solidFill>
+                      <a:prstDash val="solid"/>
+                      <a:round/>
+                      <a:headEnd type="none" w="med" len="med"/>
+                      <a:tailEnd type="none" w="med" len="med"/>
+                    </a:lnT>
+                    <a:lnB w="9525" cap="flat" cmpd="sng" algn="ctr">
+                      <a:solidFill>
+                        <a:srgbClr val="E5E7EB"/>
+                      </a:solidFill>
+                      <a:prstDash val="solid"/>
+                      <a:round/>
+                      <a:headEnd type="none" w="med" len="med"/>
+                      <a:tailEnd type="none" w="med" len="med"/>
+                    </a:lnB>
+                    <a:solidFill>
+                      <a:schemeClr val="bg1"/>
+                    </a:solidFill>
+                  </a:tcPr>
+                </a:tc>
+                <a:tc>
+                  <a:txBody>
+                    <a:bodyPr/>
+                    <a:lstStyle/>
+                    <a:p>
+                      <a:pPr algn="ctr" indent="0" marL="0">
+                        <a:buNone/>
+                      </a:pPr>
+                      <a:r>
+                        <a:rPr lang="en-US" sz="2400" dirty="0">
+                          <a:solidFill>
+                            <a:schemeClr val="accent2"/>
+                          </a:solidFill>
+                        </a:rPr>
+                        <a:t>✓</a:t>
+                      </a:r>
+                      <a:endParaRPr lang="en-US" sz="2400" dirty="0"/>
+                    </a:p>
+                  </a:txBody>
+                  <a:tcPr marL="73152" marR="73152" marT="73152" marB="73152" anchor="ctr">
+                    <a:lnL w="9525" cap="flat" cmpd="sng" algn="ctr">
+                      <a:solidFill>
+                        <a:srgbClr val="E5E7EB"/>
+                      </a:solidFill>
+                      <a:prstDash val="solid"/>
+                      <a:round/>
+                      <a:headEnd type="none" w="med" len="med"/>
+                      <a:tailEnd type="none" w="med" len="med"/>
+                    </a:lnL>
+                    <a:lnR w="9525" cap="flat" cmpd="sng" algn="ctr">
+                      <a:solidFill>
+                        <a:srgbClr val="E5E7EB"/>
+                      </a:solidFill>
+                      <a:prstDash val="solid"/>
+                      <a:round/>
+                      <a:headEnd type="none" w="med" len="med"/>
+                      <a:tailEnd type="none" w="med" len="med"/>
+                    </a:lnR>
+                    <a:lnT w="9525" cap="flat" cmpd="sng" algn="ctr">
+                      <a:solidFill>
+                        <a:srgbClr val="E5E7EB"/>
+                      </a:solidFill>
+                      <a:prstDash val="solid"/>
+                      <a:round/>
+                      <a:headEnd type="none" w="med" len="med"/>
+                      <a:tailEnd type="none" w="med" len="med"/>
+                    </a:lnT>
+                    <a:lnB w="9525" cap="flat" cmpd="sng" algn="ctr">
+                      <a:solidFill>
+                        <a:srgbClr val="E5E7EB"/>
+                      </a:solidFill>
+                      <a:prstDash val="solid"/>
+                      <a:round/>
+                      <a:headEnd type="none" w="med" len="med"/>
+                      <a:tailEnd type="none" w="med" len="med"/>
+                    </a:lnB>
+                    <a:solidFill>
+                      <a:schemeClr val="bg1"/>
+                    </a:solidFill>
+                  </a:tcPr>
+                </a:tc>
+                <a:tc>
+                  <a:txBody>
+                    <a:bodyPr/>
+                    <a:lstStyle/>
+                    <a:p>
+                      <a:pPr algn="ctr" indent="0" marL="0">
+                        <a:buNone/>
+                      </a:pPr>
+                      <a:r>
+                        <a:rPr lang="en-US" sz="1600" dirty="0">
+                          <a:solidFill>
+                            <a:schemeClr val="tx1"/>
+                          </a:solidFill>
+                        </a:rPr>
+                        <a:t>Some</a:t>
+                      </a:r>
+                      <a:endParaRPr lang="en-US" sz="1600" dirty="0"/>
+                    </a:p>
+                  </a:txBody>
+                  <a:tcPr marL="73152" marR="73152" marT="73152" marB="73152" anchor="ctr">
+                    <a:lnL w="9525" cap="flat" cmpd="sng" algn="ctr">
+                      <a:solidFill>
+                        <a:srgbClr val="E5E7EB"/>
+                      </a:solidFill>
+                      <a:prstDash val="solid"/>
+                      <a:round/>
+                      <a:headEnd type="none" w="med" len="med"/>
+                      <a:tailEnd type="none" w="med" len="med"/>
+                    </a:lnL>
+                    <a:lnR w="9525" cap="flat" cmpd="sng" algn="ctr">
+                      <a:solidFill>
+                        <a:srgbClr val="E5E7EB"/>
+                      </a:solidFill>
+                      <a:prstDash val="solid"/>
+                      <a:round/>
+                      <a:headEnd type="none" w="med" len="med"/>
+                      <a:tailEnd type="none" w="med" len="med"/>
+                    </a:lnR>
+                    <a:lnT w="9525" cap="flat" cmpd="sng" algn="ctr">
+                      <a:solidFill>
+                        <a:srgbClr val="E5E7EB"/>
+                      </a:solidFill>
+                      <a:prstDash val="solid"/>
+                      <a:round/>
+                      <a:headEnd type="none" w="med" len="med"/>
+                      <a:tailEnd type="none" w="med" len="med"/>
+                    </a:lnT>
+                    <a:lnB w="9525" cap="flat" cmpd="sng" algn="ctr">
+                      <a:solidFill>
+                        <a:srgbClr val="E5E7EB"/>
+                      </a:solidFill>
+                      <a:prstDash val="solid"/>
+                      <a:round/>
+                      <a:headEnd type="none" w="med" len="med"/>
+                      <a:tailEnd type="none" w="med" len="med"/>
+                    </a:lnB>
+                    <a:solidFill>
+                      <a:schemeClr val="bg1"/>
+                    </a:solidFill>
+                  </a:tcPr>
+                </a:tc>
+                <a:tc>
+                  <a:txBody>
+                    <a:bodyPr/>
+                    <a:lstStyle/>
+                    <a:p>
+                      <a:pPr algn="ctr" indent="0" marL="0">
+                        <a:buNone/>
+                      </a:pPr>
+                      <a:r>
+                        <a:rPr lang="en-US" sz="2400" dirty="0">
+                          <a:solidFill>
+                            <a:schemeClr val="accent2"/>
+                          </a:solidFill>
+                        </a:rPr>
+                        <a:t>✓</a:t>
+                      </a:r>
+                      <a:endParaRPr lang="en-US" sz="2400" dirty="0"/>
+                    </a:p>
+                  </a:txBody>
+                  <a:tcPr marL="73152" marR="73152" marT="73152" marB="73152" anchor="ctr">
+                    <a:lnL w="9525" cap="flat" cmpd="sng" algn="ctr">
+                      <a:solidFill>
+                        <a:srgbClr val="E5E7EB"/>
+                      </a:solidFill>
+                      <a:prstDash val="solid"/>
+                      <a:round/>
+                      <a:headEnd type="none" w="med" len="med"/>
+                      <a:tailEnd type="none" w="med" len="med"/>
+                    </a:lnL>
+                    <a:lnR w="9525" cap="flat" cmpd="sng" algn="ctr">
+                      <a:solidFill>
+                        <a:srgbClr val="E5E7EB"/>
+                      </a:solidFill>
+                      <a:prstDash val="solid"/>
+                      <a:round/>
+                      <a:headEnd type="none" w="med" len="med"/>
+                      <a:tailEnd type="none" w="med" len="med"/>
+                    </a:lnR>
+                    <a:lnT w="9525" cap="flat" cmpd="sng" algn="ctr">
+                      <a:solidFill>
+                        <a:srgbClr val="E5E7EB"/>
+                      </a:solidFill>
+                      <a:prstDash val="solid"/>
+                      <a:round/>
+                      <a:headEnd type="none" w="med" len="med"/>
+                      <a:tailEnd type="none" w="med" len="med"/>
+                    </a:lnT>
+                    <a:lnB w="9525" cap="flat" cmpd="sng" algn="ctr">
+                      <a:solidFill>
+                        <a:srgbClr val="E5E7EB"/>
+                      </a:solidFill>
+                      <a:prstDash val="solid"/>
+                      <a:round/>
+                      <a:headEnd type="none" w="med" len="med"/>
+                      <a:tailEnd type="none" w="med" len="med"/>
+                    </a:lnB>
+                    <a:solidFill>
+                      <a:schemeClr val="bg1"/>
+                    </a:solidFill>
+                  </a:tcPr>
+                </a:tc>
+                <a:tc>
+                  <a:txBody>
+                    <a:bodyPr/>
+                    <a:lstStyle/>
+                    <a:p>
+                      <a:pPr algn="ctr" indent="0" marL="0">
+                        <a:buNone/>
+                      </a:pPr>
+                      <a:r>
+                        <a:rPr lang="en-US" sz="2400" dirty="0">
+                          <a:solidFill>
+                            <a:schemeClr val="accent1"/>
+                          </a:solidFill>
+                        </a:rPr>
+                        <a:t>✗</a:t>
+                      </a:r>
+                      <a:endParaRPr lang="en-US" sz="2400" dirty="0"/>
+                    </a:p>
+                  </a:txBody>
+                  <a:tcPr marL="73152" marR="73152" marT="73152" marB="73152" anchor="ctr">
+                    <a:lnL w="9525" cap="flat" cmpd="sng" algn="ctr">
+                      <a:solidFill>
+                        <a:srgbClr val="E5E7EB"/>
+                      </a:solidFill>
+                      <a:prstDash val="solid"/>
+                      <a:round/>
+                      <a:headEnd type="none" w="med" len="med"/>
+                      <a:tailEnd type="none" w="med" len="med"/>
+                    </a:lnL>
+                    <a:lnR w="9525" cap="flat" cmpd="sng" algn="ctr">
+                      <a:solidFill>
+                        <a:srgbClr val="E5E7EB"/>
+                      </a:solidFill>
+                      <a:prstDash val="solid"/>
+                      <a:round/>
+                      <a:headEnd type="none" w="med" len="med"/>
+                      <a:tailEnd type="none" w="med" len="med"/>
+                    </a:lnR>
+                    <a:lnT w="9525" cap="flat" cmpd="sng" algn="ctr">
+                      <a:solidFill>
+                        <a:srgbClr val="E5E7EB"/>
+                      </a:solidFill>
+                      <a:prstDash val="solid"/>
+                      <a:round/>
+                      <a:headEnd type="none" w="med" len="med"/>
+                      <a:tailEnd type="none" w="med" len="med"/>
+                    </a:lnT>
+                    <a:lnB w="9525" cap="flat" cmpd="sng" algn="ctr">
+                      <a:solidFill>
+                        <a:srgbClr val="E5E7EB"/>
+                      </a:solidFill>
+                      <a:prstDash val="solid"/>
+                      <a:round/>
+                      <a:headEnd type="none" w="med" len="med"/>
+                      <a:tailEnd type="none" w="med" len="med"/>
+                    </a:lnB>
+                    <a:solidFill>
+                      <a:schemeClr val="bg1"/>
+                    </a:solidFill>
+                  </a:tcPr>
+                </a:tc>
+              </a:tr>
+              <a:tr h="566928">
+                <a:tc>
+                  <a:txBody>
+                    <a:bodyPr/>
+                    <a:lstStyle/>
+                    <a:p>
+                      <a:pPr algn="l" indent="0" marL="0">
+                        <a:buNone/>
+                      </a:pPr>
+                      <a:r>
+                        <a:rPr lang="en-US" sz="1600" b="1" dirty="0">
+                          <a:solidFill>
+                            <a:schemeClr val="tx1"/>
+                          </a:solidFill>
+                        </a:rPr>
+                        <a:t>Our snack (aim)</a:t>
+                      </a:r>
+                      <a:endParaRPr lang="en-US" sz="1600" dirty="0"/>
+                    </a:p>
+                  </a:txBody>
+                  <a:tcPr marL="73152" marR="73152" marT="73152" marB="73152" anchor="ctr">
+                    <a:lnL w="9525" cap="flat" cmpd="sng" algn="ctr">
+                      <a:solidFill>
+                        <a:srgbClr val="E5E7EB"/>
+                      </a:solidFill>
+                      <a:prstDash val="solid"/>
+                      <a:round/>
+                      <a:headEnd type="none" w="med" len="med"/>
+                      <a:tailEnd type="none" w="med" len="med"/>
+                    </a:lnL>
+                    <a:lnR w="9525" cap="flat" cmpd="sng" algn="ctr">
+                      <a:solidFill>
+                        <a:srgbClr val="E5E7EB"/>
+                      </a:solidFill>
+                      <a:prstDash val="solid"/>
+                      <a:round/>
+                      <a:headEnd type="none" w="med" len="med"/>
+                      <a:tailEnd type="none" w="med" len="med"/>
+                    </a:lnR>
+                    <a:lnT w="9525" cap="flat" cmpd="sng" algn="ctr">
+                      <a:solidFill>
+                        <a:srgbClr val="E5E7EB"/>
+                      </a:solidFill>
+                      <a:prstDash val="solid"/>
+                      <a:round/>
+                      <a:headEnd type="none" w="med" len="med"/>
+                      <a:tailEnd type="none" w="med" len="med"/>
+                    </a:lnT>
+                    <a:lnB w="9525" cap="flat" cmpd="sng" algn="ctr">
+                      <a:solidFill>
+                        <a:srgbClr val="E5E7EB"/>
+                      </a:solidFill>
+                      <a:prstDash val="solid"/>
+                      <a:round/>
+                      <a:headEnd type="none" w="med" len="med"/>
+                      <a:tailEnd type="none" w="med" len="med"/>
+                    </a:lnB>
+                    <a:solidFill>
+                      <a:schemeClr val="accent4"/>
+                    </a:solidFill>
+                  </a:tcPr>
+                </a:tc>
+                <a:tc>
+                  <a:txBody>
+                    <a:bodyPr/>
+                    <a:lstStyle/>
+                    <a:p>
+                      <a:pPr algn="ctr" indent="0" marL="0">
+                        <a:buNone/>
+                      </a:pPr>
+                      <a:r>
+                        <a:rPr lang="en-US" sz="2400" b="1" dirty="0">
+                          <a:solidFill>
+                            <a:schemeClr val="accent2"/>
+                          </a:solidFill>
+                        </a:rPr>
+                        <a:t>✓</a:t>
+                      </a:r>
+                      <a:endParaRPr lang="en-US" sz="2400" dirty="0"/>
+                    </a:p>
+                  </a:txBody>
+                  <a:tcPr marL="73152" marR="73152" marT="73152" marB="73152" anchor="ctr">
+                    <a:lnL w="9525" cap="flat" cmpd="sng" algn="ctr">
+                      <a:solidFill>
+                        <a:srgbClr val="E5E7EB"/>
+                      </a:solidFill>
+                      <a:prstDash val="solid"/>
+                      <a:round/>
+                      <a:headEnd type="none" w="med" len="med"/>
+                      <a:tailEnd type="none" w="med" len="med"/>
+                    </a:lnL>
+                    <a:lnR w="9525" cap="flat" cmpd="sng" algn="ctr">
+                      <a:solidFill>
+                        <a:srgbClr val="E5E7EB"/>
+                      </a:solidFill>
+                      <a:prstDash val="solid"/>
+                      <a:round/>
+                      <a:headEnd type="none" w="med" len="med"/>
+                      <a:tailEnd type="none" w="med" len="med"/>
+                    </a:lnR>
+                    <a:lnT w="9525" cap="flat" cmpd="sng" algn="ctr">
+                      <a:solidFill>
+                        <a:srgbClr val="E5E7EB"/>
+                      </a:solidFill>
+                      <a:prstDash val="solid"/>
+                      <a:round/>
+                      <a:headEnd type="none" w="med" len="med"/>
+                      <a:tailEnd type="none" w="med" len="med"/>
+                    </a:lnT>
+                    <a:lnB w="9525" cap="flat" cmpd="sng" algn="ctr">
+                      <a:solidFill>
+                        <a:srgbClr val="E5E7EB"/>
+                      </a:solidFill>
+                      <a:prstDash val="solid"/>
+                      <a:round/>
+                      <a:headEnd type="none" w="med" len="med"/>
+                      <a:tailEnd type="none" w="med" len="med"/>
+                    </a:lnB>
+                    <a:solidFill>
+                      <a:schemeClr val="accent4"/>
+                    </a:solidFill>
+                  </a:tcPr>
+                </a:tc>
+                <a:tc>
+                  <a:txBody>
+                    <a:bodyPr/>
+                    <a:lstStyle/>
+                    <a:p>
+                      <a:pPr algn="ctr" indent="0" marL="0">
+                        <a:buNone/>
+                      </a:pPr>
+                      <a:r>
+                        <a:rPr lang="en-US" sz="2400" b="1" dirty="0">
+                          <a:solidFill>
+                            <a:schemeClr val="accent2"/>
+                          </a:solidFill>
+                        </a:rPr>
+                        <a:t>✓</a:t>
+                      </a:r>
+                      <a:endParaRPr lang="en-US" sz="2400" dirty="0"/>
+                    </a:p>
+                  </a:txBody>
+                  <a:tcPr marL="73152" marR="73152" marT="73152" marB="73152" anchor="ctr">
+                    <a:lnL w="9525" cap="flat" cmpd="sng" algn="ctr">
+                      <a:solidFill>
+                        <a:srgbClr val="E5E7EB"/>
+                      </a:solidFill>
+                      <a:prstDash val="solid"/>
+                      <a:round/>
+                      <a:headEnd type="none" w="med" len="med"/>
+                      <a:tailEnd type="none" w="med" len="med"/>
+                    </a:lnL>
+                    <a:lnR w="9525" cap="flat" cmpd="sng" algn="ctr">
+                      <a:solidFill>
+                        <a:srgbClr val="E5E7EB"/>
+                      </a:solidFill>
+                      <a:prstDash val="solid"/>
+                      <a:round/>
+                      <a:headEnd type="none" w="med" len="med"/>
+                      <a:tailEnd type="none" w="med" len="med"/>
+                    </a:lnR>
+                    <a:lnT w="9525" cap="flat" cmpd="sng" algn="ctr">
+                      <a:solidFill>
+                        <a:srgbClr val="E5E7EB"/>
+                      </a:solidFill>
+                      <a:prstDash val="solid"/>
+                      <a:round/>
+                      <a:headEnd type="none" w="med" len="med"/>
+                      <a:tailEnd type="none" w="med" len="med"/>
+                    </a:lnT>
+                    <a:lnB w="9525" cap="flat" cmpd="sng" algn="ctr">
+                      <a:solidFill>
+                        <a:srgbClr val="E5E7EB"/>
+                      </a:solidFill>
+                      <a:prstDash val="solid"/>
+                      <a:round/>
+                      <a:headEnd type="none" w="med" len="med"/>
+                      <a:tailEnd type="none" w="med" len="med"/>
+                    </a:lnB>
+                    <a:solidFill>
+                      <a:schemeClr val="accent4"/>
+                    </a:solidFill>
+                  </a:tcPr>
+                </a:tc>
+                <a:tc>
+                  <a:txBody>
+                    <a:bodyPr/>
+                    <a:lstStyle/>
+                    <a:p>
+                      <a:pPr algn="ctr" indent="0" marL="0">
+                        <a:buNone/>
+                      </a:pPr>
+                      <a:r>
+                        <a:rPr lang="en-US" sz="2400" b="1" dirty="0">
+                          <a:solidFill>
+                            <a:schemeClr val="accent2"/>
+                          </a:solidFill>
+                        </a:rPr>
+                        <a:t>✓</a:t>
+                      </a:r>
+                      <a:endParaRPr lang="en-US" sz="2400" dirty="0"/>
+                    </a:p>
+                  </a:txBody>
+                  <a:tcPr marL="73152" marR="73152" marT="73152" marB="73152" anchor="ctr">
+                    <a:lnL w="9525" cap="flat" cmpd="sng" algn="ctr">
+                      <a:solidFill>
+                        <a:srgbClr val="E5E7EB"/>
+                      </a:solidFill>
+                      <a:prstDash val="solid"/>
+                      <a:round/>
+                      <a:headEnd type="none" w="med" len="med"/>
+                      <a:tailEnd type="none" w="med" len="med"/>
+                    </a:lnL>
+                    <a:lnR w="9525" cap="flat" cmpd="sng" algn="ctr">
+                      <a:solidFill>
+                        <a:srgbClr val="E5E7EB"/>
+                      </a:solidFill>
+                      <a:prstDash val="solid"/>
+                      <a:round/>
+                      <a:headEnd type="none" w="med" len="med"/>
+                      <a:tailEnd type="none" w="med" len="med"/>
+                    </a:lnR>
+                    <a:lnT w="9525" cap="flat" cmpd="sng" algn="ctr">
+                      <a:solidFill>
+                        <a:srgbClr val="E5E7EB"/>
+                      </a:solidFill>
+                      <a:prstDash val="solid"/>
+                      <a:round/>
+                      <a:headEnd type="none" w="med" len="med"/>
+                      <a:tailEnd type="none" w="med" len="med"/>
+                    </a:lnT>
+                    <a:lnB w="9525" cap="flat" cmpd="sng" algn="ctr">
+                      <a:solidFill>
+                        <a:srgbClr val="E5E7EB"/>
+                      </a:solidFill>
+                      <a:prstDash val="solid"/>
+                      <a:round/>
+                      <a:headEnd type="none" w="med" len="med"/>
+                      <a:tailEnd type="none" w="med" len="med"/>
+                    </a:lnB>
+                    <a:solidFill>
+                      <a:schemeClr val="accent4"/>
+                    </a:solidFill>
+                  </a:tcPr>
+                </a:tc>
+                <a:tc>
+                  <a:txBody>
+                    <a:bodyPr/>
+                    <a:lstStyle/>
+                    <a:p>
+                      <a:pPr algn="ctr" indent="0" marL="0">
+                        <a:buNone/>
+                      </a:pPr>
+                      <a:r>
+                        <a:rPr lang="en-US" sz="2400" b="1" dirty="0">
+                          <a:solidFill>
+                            <a:schemeClr val="accent2"/>
+                          </a:solidFill>
+                        </a:rPr>
+                        <a:t>✓</a:t>
+                      </a:r>
+                      <a:endParaRPr lang="en-US" sz="2400" dirty="0"/>
+                    </a:p>
+                  </a:txBody>
+                  <a:tcPr marL="73152" marR="73152" marT="73152" marB="73152" anchor="ctr">
+                    <a:lnL w="9525" cap="flat" cmpd="sng" algn="ctr">
+                      <a:solidFill>
+                        <a:srgbClr val="E5E7EB"/>
+                      </a:solidFill>
+                      <a:prstDash val="solid"/>
+                      <a:round/>
+                      <a:headEnd type="none" w="med" len="med"/>
+                      <a:tailEnd type="none" w="med" len="med"/>
+                    </a:lnL>
+                    <a:lnR w="9525" cap="flat" cmpd="sng" algn="ctr">
+                      <a:solidFill>
+                        <a:srgbClr val="E5E7EB"/>
+                      </a:solidFill>
+                      <a:prstDash val="solid"/>
+                      <a:round/>
+                      <a:headEnd type="none" w="med" len="med"/>
+                      <a:tailEnd type="none" w="med" len="med"/>
+                    </a:lnR>
+                    <a:lnT w="9525" cap="flat" cmpd="sng" algn="ctr">
+                      <a:solidFill>
+                        <a:srgbClr val="E5E7EB"/>
+                      </a:solidFill>
+                      <a:prstDash val="solid"/>
+                      <a:round/>
+                      <a:headEnd type="none" w="med" len="med"/>
+                      <a:tailEnd type="none" w="med" len="med"/>
+                    </a:lnT>
+                    <a:lnB w="9525" cap="flat" cmpd="sng" algn="ctr">
+                      <a:solidFill>
+                        <a:srgbClr val="E5E7EB"/>
+                      </a:solidFill>
+                      <a:prstDash val="solid"/>
+                      <a:round/>
+                      <a:headEnd type="none" w="med" len="med"/>
+                      <a:tailEnd type="none" w="med" len="med"/>
+                    </a:lnB>
+                    <a:solidFill>
+                      <a:schemeClr val="accent4"/>
+                    </a:solidFill>
+                  </a:tcPr>
+                </a:tc>
+                <a:tc>
+                  <a:txBody>
+                    <a:bodyPr/>
+                    <a:lstStyle/>
+                    <a:p>
+                      <a:pPr algn="ctr" indent="0" marL="0">
+                        <a:buNone/>
+                      </a:pPr>
+                      <a:r>
+                        <a:rPr lang="en-US" sz="2400" b="1" dirty="0">
+                          <a:solidFill>
+                            <a:schemeClr val="accent2"/>
+                          </a:solidFill>
+                        </a:rPr>
+                        <a:t>✓</a:t>
+                      </a:r>
+                      <a:endParaRPr lang="en-US" sz="2400" dirty="0"/>
+                    </a:p>
+                  </a:txBody>
+                  <a:tcPr marL="73152" marR="73152" marT="73152" marB="73152" anchor="ctr">
+                    <a:lnL w="9525" cap="flat" cmpd="sng" algn="ctr">
+                      <a:solidFill>
+                        <a:srgbClr val="E5E7EB"/>
+                      </a:solidFill>
+                      <a:prstDash val="solid"/>
+                      <a:round/>
+                      <a:headEnd type="none" w="med" len="med"/>
+                      <a:tailEnd type="none" w="med" len="med"/>
+                    </a:lnL>
+                    <a:lnR w="9525" cap="flat" cmpd="sng" algn="ctr">
+                      <a:solidFill>
+                        <a:srgbClr val="E5E7EB"/>
+                      </a:solidFill>
+                      <a:prstDash val="solid"/>
+                      <a:round/>
+                      <a:headEnd type="none" w="med" len="med"/>
+                      <a:tailEnd type="none" w="med" len="med"/>
+                    </a:lnR>
+                    <a:lnT w="9525" cap="flat" cmpd="sng" algn="ctr">
+                      <a:solidFill>
+                        <a:srgbClr val="E5E7EB"/>
+                      </a:solidFill>
+                      <a:prstDash val="solid"/>
+                      <a:round/>
+                      <a:headEnd type="none" w="med" len="med"/>
+                      <a:tailEnd type="none" w="med" len="med"/>
+                    </a:lnT>
+                    <a:lnB w="9525" cap="flat" cmpd="sng" algn="ctr">
+                      <a:solidFill>
+                        <a:srgbClr val="E5E7EB"/>
+                      </a:solidFill>
+                      <a:prstDash val="solid"/>
+                      <a:round/>
+                      <a:headEnd type="none" w="med" len="med"/>
+                      <a:tailEnd type="none" w="med" len="med"/>
+                    </a:lnB>
+                    <a:solidFill>
+                      <a:schemeClr val="accent4"/>
+                    </a:solidFill>
+                  </a:tcPr>
+                </a:tc>
+              </a:tr>
+            </a:tbl>
+          </a:graphicData>
+        </a:graphic>
+      </p:graphicFrame>
+      <p:sp>
+        <p:nvSpPr>
+          <p:cNvPr id="4" name="Gap line"/>
           <p:cNvSpPr txBox="1"/>
           <p:nvPr/>
         </p:nvSpPr>
         <p:spPr>
           <a:xfrm>
-            <a:off x="548640" y="1417320"/>
-            <a:ext cx="3291840" cy="640080"/>
+            <a:off x="548640" y="4983480"/>
+            <a:ext cx="11064240" cy="731520"/>
           </a:xfrm>
           <a:prstGeom prst="rect">
             <a:avLst/>
@@ -2763,27 +5011,27 @@
               <a:buNone/>
             </a:pPr>
             <a:r>
-              <a:rPr lang="en-US" sz="2600" b="1" dirty="0">
+              <a:rPr lang="en-US" sz="1800" b="1" dirty="0">
                 <a:solidFill>
                   <a:schemeClr val="tx1"/>
                 </a:solidFill>
               </a:rPr>
-              <a:t>Protein bars</a:t>
+              <a:t>25 UK snacks checked: none pass all four tests.  Why? Shops need months of shelf life; real food lasts days.</a:t>
             </a:r>
-            <a:endParaRPr lang="en-US" sz="2600" dirty="0"/>
-          </a:p>
-        </p:txBody>
-      </p:sp>
-      <p:sp>
-        <p:nvSpPr>
-          <p:cNvPr id="4" name="Row 1 good"/>
+            <a:endParaRPr lang="en-US" sz="1800" dirty="0"/>
+          </a:p>
+        </p:txBody>
+      </p:sp>
+      <p:sp>
+        <p:nvSpPr>
+          <p:cNvPr id="5" name="Sources"/>
           <p:cNvSpPr txBox="1"/>
           <p:nvPr/>
         </p:nvSpPr>
         <p:spPr>
           <a:xfrm>
-            <a:off x="4023360" y="1417320"/>
-            <a:ext cx="3474720" cy="640080"/>
+            <a:off x="548640" y="5806440"/>
+            <a:ext cx="11064240" cy="274320"/>
           </a:xfrm>
           <a:prstGeom prst="rect">
             <a:avLst/>
@@ -2799,360 +5047,14 @@
               <a:buNone/>
             </a:pPr>
             <a:r>
-              <a:rPr lang="en-US" sz="2400" dirty="0">
+              <a:rPr lang="en-US" sz="1000" i="1" dirty="0">
                 <a:solidFill>
-                  <a:schemeClr val="accent2"/>
+                  <a:schemeClr val="accent3"/>
                 </a:solidFill>
               </a:rPr>
-              <a:t>✓ high protein</a:t>
+              <a:t>Brand and retailer pages, Oct 2026. Protein ≥10 g; low sugar ≤5 g per 50 g.</a:t>
             </a:r>
-            <a:endParaRPr lang="en-US" sz="2400" dirty="0"/>
-          </a:p>
-        </p:txBody>
-      </p:sp>
-      <p:sp>
-        <p:nvSpPr>
-          <p:cNvPr id="5" name="Row 1 bad"/>
-          <p:cNvSpPr txBox="1"/>
-          <p:nvPr/>
-        </p:nvSpPr>
-        <p:spPr>
-          <a:xfrm>
-            <a:off x="7589520" y="1417320"/>
-            <a:ext cx="4023360" cy="640080"/>
-          </a:xfrm>
-          <a:prstGeom prst="rect">
-            <a:avLst/>
-          </a:prstGeom>
-          <a:noFill/>
-          <a:ln/>
-        </p:spPr>
-        <p:txBody>
-          <a:bodyPr wrap="square" lIns="0" tIns="0" rIns="0" bIns="0" rtlCol="0" anchor="ctr"/>
-          <a:lstStyle/>
-          <a:p>
-            <a:pPr indent="0" marL="0">
-              <a:buNone/>
-            </a:pPr>
-            <a:r>
-              <a:rPr lang="en-US" sz="2400" dirty="0">
-                <a:solidFill>
-                  <a:schemeClr val="accent1"/>
-                </a:solidFill>
-              </a:rPr>
-              <a:t>✗ powders &amp; sweeteners</a:t>
-            </a:r>
-            <a:endParaRPr lang="en-US" sz="2400" dirty="0"/>
-          </a:p>
-        </p:txBody>
-      </p:sp>
-      <p:sp>
-        <p:nvSpPr>
-          <p:cNvPr id="6" name="Row 2 name"/>
-          <p:cNvSpPr txBox="1"/>
-          <p:nvPr/>
-        </p:nvSpPr>
-        <p:spPr>
-          <a:xfrm>
-            <a:off x="548640" y="2286000"/>
-            <a:ext cx="3291840" cy="640080"/>
-          </a:xfrm>
-          <a:prstGeom prst="rect">
-            <a:avLst/>
-          </a:prstGeom>
-          <a:noFill/>
-          <a:ln/>
-        </p:spPr>
-        <p:txBody>
-          <a:bodyPr wrap="square" lIns="0" tIns="0" rIns="0" bIns="0" rtlCol="0" anchor="ctr"/>
-          <a:lstStyle/>
-          <a:p>
-            <a:pPr indent="0" marL="0">
-              <a:buNone/>
-            </a:pPr>
-            <a:r>
-              <a:rPr lang="en-US" sz="2600" b="1" dirty="0">
-                <a:solidFill>
-                  <a:schemeClr val="tx1"/>
-                </a:solidFill>
-              </a:rPr>
-              <a:t>"Natural" bars</a:t>
-            </a:r>
-            <a:endParaRPr lang="en-US" sz="2600" dirty="0"/>
-          </a:p>
-        </p:txBody>
-      </p:sp>
-      <p:sp>
-        <p:nvSpPr>
-          <p:cNvPr id="7" name="Row 2 good"/>
-          <p:cNvSpPr txBox="1"/>
-          <p:nvPr/>
-        </p:nvSpPr>
-        <p:spPr>
-          <a:xfrm>
-            <a:off x="4023360" y="2286000"/>
-            <a:ext cx="3474720" cy="640080"/>
-          </a:xfrm>
-          <a:prstGeom prst="rect">
-            <a:avLst/>
-          </a:prstGeom>
-          <a:noFill/>
-          <a:ln/>
-        </p:spPr>
-        <p:txBody>
-          <a:bodyPr wrap="square" lIns="0" tIns="0" rIns="0" bIns="0" rtlCol="0" anchor="ctr"/>
-          <a:lstStyle/>
-          <a:p>
-            <a:pPr indent="0" marL="0">
-              <a:buNone/>
-            </a:pPr>
-            <a:r>
-              <a:rPr lang="en-US" sz="2400" dirty="0">
-                <a:solidFill>
-                  <a:schemeClr val="accent2"/>
-                </a:solidFill>
-              </a:rPr>
-              <a:t>✓ real food</a:t>
-            </a:r>
-            <a:endParaRPr lang="en-US" sz="2400" dirty="0"/>
-          </a:p>
-        </p:txBody>
-      </p:sp>
-      <p:sp>
-        <p:nvSpPr>
-          <p:cNvPr id="8" name="Row 2 bad"/>
-          <p:cNvSpPr txBox="1"/>
-          <p:nvPr/>
-        </p:nvSpPr>
-        <p:spPr>
-          <a:xfrm>
-            <a:off x="7589520" y="2286000"/>
-            <a:ext cx="4023360" cy="640080"/>
-          </a:xfrm>
-          <a:prstGeom prst="rect">
-            <a:avLst/>
-          </a:prstGeom>
-          <a:noFill/>
-          <a:ln/>
-        </p:spPr>
-        <p:txBody>
-          <a:bodyPr wrap="square" lIns="0" tIns="0" rIns="0" bIns="0" rtlCol="0" anchor="ctr"/>
-          <a:lstStyle/>
-          <a:p>
-            <a:pPr indent="0" marL="0">
-              <a:buNone/>
-            </a:pPr>
-            <a:r>
-              <a:rPr lang="en-US" sz="2400" dirty="0">
-                <a:solidFill>
-                  <a:schemeClr val="accent1"/>
-                </a:solidFill>
-              </a:rPr>
-              <a:t>✗ high sugar</a:t>
-            </a:r>
-            <a:endParaRPr lang="en-US" sz="2400" dirty="0"/>
-          </a:p>
-        </p:txBody>
-      </p:sp>
-      <p:sp>
-        <p:nvSpPr>
-          <p:cNvPr id="9" name="Row 3 name"/>
-          <p:cNvSpPr txBox="1"/>
-          <p:nvPr/>
-        </p:nvSpPr>
-        <p:spPr>
-          <a:xfrm>
-            <a:off x="548640" y="3154680"/>
-            <a:ext cx="3291840" cy="640080"/>
-          </a:xfrm>
-          <a:prstGeom prst="rect">
-            <a:avLst/>
-          </a:prstGeom>
-          <a:noFill/>
-          <a:ln/>
-        </p:spPr>
-        <p:txBody>
-          <a:bodyPr wrap="square" lIns="0" tIns="0" rIns="0" bIns="0" rtlCol="0" anchor="ctr"/>
-          <a:lstStyle/>
-          <a:p>
-            <a:pPr indent="0" marL="0">
-              <a:buNone/>
-            </a:pPr>
-            <a:r>
-              <a:rPr lang="en-US" sz="2600" b="1" dirty="0">
-                <a:solidFill>
-                  <a:schemeClr val="tx1"/>
-                </a:solidFill>
-              </a:rPr>
-              <a:t>Quark pots</a:t>
-            </a:r>
-            <a:endParaRPr lang="en-US" sz="2600" dirty="0"/>
-          </a:p>
-        </p:txBody>
-      </p:sp>
-      <p:sp>
-        <p:nvSpPr>
-          <p:cNvPr id="10" name="Row 3 good"/>
-          <p:cNvSpPr txBox="1"/>
-          <p:nvPr/>
-        </p:nvSpPr>
-        <p:spPr>
-          <a:xfrm>
-            <a:off x="4023360" y="3154680"/>
-            <a:ext cx="3474720" cy="640080"/>
-          </a:xfrm>
-          <a:prstGeom prst="rect">
-            <a:avLst/>
-          </a:prstGeom>
-          <a:noFill/>
-          <a:ln/>
-        </p:spPr>
-        <p:txBody>
-          <a:bodyPr wrap="square" lIns="0" tIns="0" rIns="0" bIns="0" rtlCol="0" anchor="ctr"/>
-          <a:lstStyle/>
-          <a:p>
-            <a:pPr indent="0" marL="0">
-              <a:buNone/>
-            </a:pPr>
-            <a:r>
-              <a:rPr lang="en-US" sz="2400" dirty="0">
-                <a:solidFill>
-                  <a:schemeClr val="accent2"/>
-                </a:solidFill>
-              </a:rPr>
-              <a:t>✓ real protein</a:t>
-            </a:r>
-            <a:endParaRPr lang="en-US" sz="2400" dirty="0"/>
-          </a:p>
-        </p:txBody>
-      </p:sp>
-      <p:sp>
-        <p:nvSpPr>
-          <p:cNvPr id="11" name="Row 3 bad"/>
-          <p:cNvSpPr txBox="1"/>
-          <p:nvPr/>
-        </p:nvSpPr>
-        <p:spPr>
-          <a:xfrm>
-            <a:off x="7589520" y="3154680"/>
-            <a:ext cx="4023360" cy="640080"/>
-          </a:xfrm>
-          <a:prstGeom prst="rect">
-            <a:avLst/>
-          </a:prstGeom>
-          <a:noFill/>
-          <a:ln/>
-        </p:spPr>
-        <p:txBody>
-          <a:bodyPr wrap="square" lIns="0" tIns="0" rIns="0" bIns="0" rtlCol="0" anchor="ctr"/>
-          <a:lstStyle/>
-          <a:p>
-            <a:pPr indent="0" marL="0">
-              <a:buNone/>
-            </a:pPr>
-            <a:r>
-              <a:rPr lang="en-US" sz="2400" dirty="0">
-                <a:solidFill>
-                  <a:schemeClr val="accent1"/>
-                </a:solidFill>
-              </a:rPr>
-              <a:t>✗ not grab-and-go</a:t>
-            </a:r>
-            <a:endParaRPr lang="en-US" sz="2400" dirty="0"/>
-          </a:p>
-        </p:txBody>
-      </p:sp>
-      <p:sp>
-        <p:nvSpPr>
-          <p:cNvPr id="12" name="Gap box"/>
-          <p:cNvSpPr/>
-          <p:nvPr/>
-        </p:nvSpPr>
-        <p:spPr>
-          <a:xfrm>
-            <a:off x="548640" y="4206240"/>
-            <a:ext cx="11064240" cy="1463040"/>
-          </a:xfrm>
-          <a:prstGeom prst="roundRect">
-            <a:avLst>
-              <a:gd name="adj" fmla="val 7500"/>
-            </a:avLst>
-          </a:prstGeom>
-          <a:solidFill>
-            <a:schemeClr val="tx1"/>
-          </a:solidFill>
-          <a:ln/>
-        </p:spPr>
-      </p:sp>
-      <p:sp>
-        <p:nvSpPr>
-          <p:cNvPr id="13" name="Gap line"/>
-          <p:cNvSpPr txBox="1"/>
-          <p:nvPr/>
-        </p:nvSpPr>
-        <p:spPr>
-          <a:xfrm>
-            <a:off x="822960" y="4343400"/>
-            <a:ext cx="10515600" cy="548640"/>
-          </a:xfrm>
-          <a:prstGeom prst="rect">
-            <a:avLst/>
-          </a:prstGeom>
-          <a:noFill/>
-          <a:ln/>
-        </p:spPr>
-        <p:txBody>
-          <a:bodyPr wrap="square" lIns="0" tIns="0" rIns="0" bIns="0" rtlCol="0" anchor="ctr"/>
-          <a:lstStyle/>
-          <a:p>
-            <a:pPr indent="0" marL="0">
-              <a:buNone/>
-            </a:pPr>
-            <a:r>
-              <a:rPr lang="en-US" sz="2400" b="1" dirty="0">
-                <a:solidFill>
-                  <a:schemeClr val="bg1"/>
-                </a:solidFill>
-              </a:rPr>
-              <a:t>25 UK snacks tested. 0 are high protein, real food AND low sugar.</a:t>
-            </a:r>
-            <a:endParaRPr lang="en-US" sz="2400" dirty="0"/>
-          </a:p>
-        </p:txBody>
-      </p:sp>
-      <p:sp>
-        <p:nvSpPr>
-          <p:cNvPr id="14" name="Why line"/>
-          <p:cNvSpPr txBox="1"/>
-          <p:nvPr/>
-        </p:nvSpPr>
-        <p:spPr>
-          <a:xfrm>
-            <a:off x="822960" y="4937760"/>
-            <a:ext cx="10515600" cy="548640"/>
-          </a:xfrm>
-          <a:prstGeom prst="rect">
-            <a:avLst/>
-          </a:prstGeom>
-          <a:noFill/>
-          <a:ln/>
-        </p:spPr>
-        <p:txBody>
-          <a:bodyPr wrap="square" lIns="0" tIns="0" rIns="0" bIns="0" rtlCol="0" anchor="ctr"/>
-          <a:lstStyle/>
-          <a:p>
-            <a:pPr indent="0" marL="0">
-              <a:buNone/>
-            </a:pPr>
-            <a:r>
-              <a:rPr lang="en-US" sz="2000" dirty="0">
-                <a:solidFill>
-                  <a:schemeClr val="accent4"/>
-                </a:solidFill>
-              </a:rPr>
-              <a:t>Why? Shops need months of shelf life. Real food lasts days.</a:t>
-            </a:r>
-            <a:endParaRPr lang="en-US" sz="2000" dirty="0"/>
+            <a:endParaRPr lang="en-US" sz="1000" dirty="0"/>
           </a:p>
         </p:txBody>
       </p:sp>
@@ -3294,7 +5196,7 @@
                   <a:schemeClr val="tx1"/>
                 </a:solidFill>
               </a:rPr>
-              <a:t>Bake to order  →  deliver chilled  →  squads</a:t>
+              <a:t>Order weekly  →  bake to order  →  deliver chilled</a:t>
             </a:r>
             <a:endParaRPr lang="en-US" sz="2800" dirty="0"/>
           </a:p>
@@ -3330,7 +5232,7 @@
                   <a:schemeClr val="accent3"/>
                 </a:solidFill>
               </a:rPr>
-              <a:t>~15 g protein per 50 g. No powders, no sweeteners.</a:t>
+              <a:t>Recipe still in testing. Aim: high protein, low sugar, no powders or sweeteners.</a:t>
             </a:r>
             <a:endParaRPr lang="en-US" sz="2000" dirty="0"/>
           </a:p>

</xml_diff>